<commit_message>
updated the SOPDT Optimization.pptx
</commit_message>
<xml_diff>
--- a/Activities/Presentations/SOPDT Optimization.pptx
+++ b/Activities/Presentations/SOPDT Optimization.pptx
@@ -2,10 +2,10 @@
 <file path=ppt/presentation.xml><?xml version="1.0" encoding="utf-8"?>
 <p:presentation xmlns:a="http://schemas.openxmlformats.org/drawingml/2006/main" xmlns:r="http://schemas.openxmlformats.org/officeDocument/2006/relationships" xmlns:p="http://schemas.openxmlformats.org/presentationml/2006/main" saveSubsetFonts="1">
   <p:sldMasterIdLst>
-    <p:sldMasterId id="2147483648" r:id="rId1"/>
+    <p:sldMasterId id="2147483708" r:id="rId1"/>
   </p:sldMasterIdLst>
   <p:notesMasterIdLst>
-    <p:notesMasterId r:id="rId13"/>
+    <p:notesMasterId r:id="rId14"/>
   </p:notesMasterIdLst>
   <p:sldIdLst>
     <p:sldId id="256" r:id="rId2"/>
@@ -16,9 +16,10 @@
     <p:sldId id="261" r:id="rId7"/>
     <p:sldId id="264" r:id="rId8"/>
     <p:sldId id="260" r:id="rId9"/>
-    <p:sldId id="263" r:id="rId10"/>
-    <p:sldId id="265" r:id="rId11"/>
-    <p:sldId id="266" r:id="rId12"/>
+    <p:sldId id="267" r:id="rId10"/>
+    <p:sldId id="263" r:id="rId11"/>
+    <p:sldId id="265" r:id="rId12"/>
+    <p:sldId id="266" r:id="rId13"/>
   </p:sldIdLst>
   <p:sldSz cx="9144000" cy="6858000" type="screen4x3"/>
   <p:notesSz cx="6858000" cy="9144000"/>
@@ -218,7 +219,7 @@
           <a:p>
             <a:fld id="{597D2713-7E41-4F19-935D-43CE91CC1DCC}" type="datetimeFigureOut">
               <a:rPr lang="id-ID" smtClean="0"/>
-              <a:t>17/06/2020</a:t>
+              <a:t>18/06/2020</a:t>
             </a:fld>
             <a:endParaRPr lang="id-ID"/>
           </a:p>
@@ -505,7 +506,13 @@
       </p:grpSpPr>
       <p:sp>
         <p:nvSpPr>
-          <p:cNvPr id="2" name="Title 1"/>
+          <p:cNvPr id="2" name="Title 1">
+            <a:extLst>
+              <a:ext uri="{FF2B5EF4-FFF2-40B4-BE49-F238E27FC236}">
+                <a16:creationId xmlns:a16="http://schemas.microsoft.com/office/drawing/2014/main" id="{406B9713-A7A7-47AB-ACA5-E2B755792B64}"/>
+              </a:ext>
+            </a:extLst>
+          </p:cNvPr>
           <p:cNvSpPr>
             <a:spLocks noGrp="1"/>
           </p:cNvSpPr>
@@ -515,13 +522,17 @@
         </p:nvSpPr>
         <p:spPr>
           <a:xfrm>
-            <a:off x="685800" y="2130425"/>
-            <a:ext cx="7772400" cy="1470025"/>
+            <a:off x="1143000" y="1122363"/>
+            <a:ext cx="6858000" cy="2387600"/>
           </a:xfrm>
         </p:spPr>
         <p:txBody>
-          <a:bodyPr/>
-          <a:lstStyle/>
+          <a:bodyPr anchor="b"/>
+          <a:lstStyle>
+            <a:lvl1pPr algn="ctr">
+              <a:defRPr sz="4500"/>
+            </a:lvl1pPr>
+          </a:lstStyle>
           <a:p>
             <a:r>
               <a:rPr lang="en-US"/>
@@ -533,7 +544,13 @@
       </p:sp>
       <p:sp>
         <p:nvSpPr>
-          <p:cNvPr id="3" name="Subtitle 2"/>
+          <p:cNvPr id="3" name="Subtitle 2">
+            <a:extLst>
+              <a:ext uri="{FF2B5EF4-FFF2-40B4-BE49-F238E27FC236}">
+                <a16:creationId xmlns:a16="http://schemas.microsoft.com/office/drawing/2014/main" id="{687097ED-B072-46E5-91AE-6FE8F59ED1BD}"/>
+              </a:ext>
+            </a:extLst>
+          </p:cNvPr>
           <p:cNvSpPr>
             <a:spLocks noGrp="1"/>
           </p:cNvSpPr>
@@ -543,8 +560,8 @@
         </p:nvSpPr>
         <p:spPr>
           <a:xfrm>
-            <a:off x="1371600" y="3886200"/>
-            <a:ext cx="6400800" cy="1752600"/>
+            <a:off x="1143000" y="3602038"/>
+            <a:ext cx="6858000" cy="1655762"/>
           </a:xfrm>
         </p:spPr>
         <p:txBody>
@@ -552,93 +569,39 @@
           <a:lstStyle>
             <a:lvl1pPr marL="0" indent="0" algn="ctr">
               <a:buNone/>
-              <a:defRPr>
-                <a:solidFill>
-                  <a:schemeClr val="tx1">
-                    <a:tint val="75000"/>
-                  </a:schemeClr>
-                </a:solidFill>
-              </a:defRPr>
+              <a:defRPr sz="1800"/>
             </a:lvl1pPr>
-            <a:lvl2pPr marL="457200" indent="0" algn="ctr">
+            <a:lvl2pPr marL="342900" indent="0" algn="ctr">
               <a:buNone/>
-              <a:defRPr>
-                <a:solidFill>
-                  <a:schemeClr val="tx1">
-                    <a:tint val="75000"/>
-                  </a:schemeClr>
-                </a:solidFill>
-              </a:defRPr>
+              <a:defRPr sz="1500"/>
             </a:lvl2pPr>
-            <a:lvl3pPr marL="914400" indent="0" algn="ctr">
+            <a:lvl3pPr marL="685800" indent="0" algn="ctr">
               <a:buNone/>
-              <a:defRPr>
-                <a:solidFill>
-                  <a:schemeClr val="tx1">
-                    <a:tint val="75000"/>
-                  </a:schemeClr>
-                </a:solidFill>
-              </a:defRPr>
+              <a:defRPr sz="1350"/>
             </a:lvl3pPr>
-            <a:lvl4pPr marL="1371600" indent="0" algn="ctr">
+            <a:lvl4pPr marL="1028700" indent="0" algn="ctr">
               <a:buNone/>
-              <a:defRPr>
-                <a:solidFill>
-                  <a:schemeClr val="tx1">
-                    <a:tint val="75000"/>
-                  </a:schemeClr>
-                </a:solidFill>
-              </a:defRPr>
+              <a:defRPr sz="1200"/>
             </a:lvl4pPr>
-            <a:lvl5pPr marL="1828800" indent="0" algn="ctr">
+            <a:lvl5pPr marL="1371600" indent="0" algn="ctr">
               <a:buNone/>
-              <a:defRPr>
-                <a:solidFill>
-                  <a:schemeClr val="tx1">
-                    <a:tint val="75000"/>
-                  </a:schemeClr>
-                </a:solidFill>
-              </a:defRPr>
+              <a:defRPr sz="1200"/>
             </a:lvl5pPr>
-            <a:lvl6pPr marL="2286000" indent="0" algn="ctr">
+            <a:lvl6pPr marL="1714500" indent="0" algn="ctr">
               <a:buNone/>
-              <a:defRPr>
-                <a:solidFill>
-                  <a:schemeClr val="tx1">
-                    <a:tint val="75000"/>
-                  </a:schemeClr>
-                </a:solidFill>
-              </a:defRPr>
+              <a:defRPr sz="1200"/>
             </a:lvl6pPr>
-            <a:lvl7pPr marL="2743200" indent="0" algn="ctr">
+            <a:lvl7pPr marL="2057400" indent="0" algn="ctr">
               <a:buNone/>
-              <a:defRPr>
-                <a:solidFill>
-                  <a:schemeClr val="tx1">
-                    <a:tint val="75000"/>
-                  </a:schemeClr>
-                </a:solidFill>
-              </a:defRPr>
+              <a:defRPr sz="1200"/>
             </a:lvl7pPr>
-            <a:lvl8pPr marL="3200400" indent="0" algn="ctr">
+            <a:lvl8pPr marL="2400300" indent="0" algn="ctr">
               <a:buNone/>
-              <a:defRPr>
-                <a:solidFill>
-                  <a:schemeClr val="tx1">
-                    <a:tint val="75000"/>
-                  </a:schemeClr>
-                </a:solidFill>
-              </a:defRPr>
+              <a:defRPr sz="1200"/>
             </a:lvl8pPr>
-            <a:lvl9pPr marL="3657600" indent="0" algn="ctr">
+            <a:lvl9pPr marL="2743200" indent="0" algn="ctr">
               <a:buNone/>
-              <a:defRPr>
-                <a:solidFill>
-                  <a:schemeClr val="tx1">
-                    <a:tint val="75000"/>
-                  </a:schemeClr>
-                </a:solidFill>
-              </a:defRPr>
+              <a:defRPr sz="1200"/>
             </a:lvl9pPr>
           </a:lstStyle>
           <a:p>
@@ -652,7 +615,13 @@
       </p:sp>
       <p:sp>
         <p:nvSpPr>
-          <p:cNvPr id="4" name="Date Placeholder 3"/>
+          <p:cNvPr id="4" name="Date Placeholder 3">
+            <a:extLst>
+              <a:ext uri="{FF2B5EF4-FFF2-40B4-BE49-F238E27FC236}">
+                <a16:creationId xmlns:a16="http://schemas.microsoft.com/office/drawing/2014/main" id="{0A6C5076-E549-4E40-AE91-0557866DD77D}"/>
+              </a:ext>
+            </a:extLst>
+          </p:cNvPr>
           <p:cNvSpPr>
             <a:spLocks noGrp="1"/>
           </p:cNvSpPr>
@@ -667,7 +636,7 @@
           <a:p>
             <a:fld id="{D52594CB-B6E1-40F2-A96C-098D7E152D8D}" type="datetime1">
               <a:rPr lang="id-ID" smtClean="0"/>
-              <a:t>17/06/2020</a:t>
+              <a:t>18/06/2020</a:t>
             </a:fld>
             <a:endParaRPr lang="id-ID"/>
           </a:p>
@@ -675,7 +644,13 @@
       </p:sp>
       <p:sp>
         <p:nvSpPr>
-          <p:cNvPr id="5" name="Footer Placeholder 4"/>
+          <p:cNvPr id="5" name="Footer Placeholder 4">
+            <a:extLst>
+              <a:ext uri="{FF2B5EF4-FFF2-40B4-BE49-F238E27FC236}">
+                <a16:creationId xmlns:a16="http://schemas.microsoft.com/office/drawing/2014/main" id="{58F33C86-D7B8-4FBD-B282-C1D4B791DC1E}"/>
+              </a:ext>
+            </a:extLst>
+          </p:cNvPr>
           <p:cNvSpPr>
             <a:spLocks noGrp="1"/>
           </p:cNvSpPr>
@@ -694,7 +669,13 @@
       </p:sp>
       <p:sp>
         <p:nvSpPr>
-          <p:cNvPr id="6" name="Slide Number Placeholder 5"/>
+          <p:cNvPr id="6" name="Slide Number Placeholder 5">
+            <a:extLst>
+              <a:ext uri="{FF2B5EF4-FFF2-40B4-BE49-F238E27FC236}">
+                <a16:creationId xmlns:a16="http://schemas.microsoft.com/office/drawing/2014/main" id="{C82A8370-F11F-409F-842F-2D5342188F78}"/>
+              </a:ext>
+            </a:extLst>
+          </p:cNvPr>
           <p:cNvSpPr>
             <a:spLocks noGrp="1"/>
           </p:cNvSpPr>
@@ -718,7 +699,7 @@
     </p:spTree>
     <p:extLst>
       <p:ext uri="{BB962C8B-B14F-4D97-AF65-F5344CB8AC3E}">
-        <p14:creationId xmlns:p14="http://schemas.microsoft.com/office/powerpoint/2010/main" val="3122287262"/>
+        <p14:creationId xmlns:p14="http://schemas.microsoft.com/office/powerpoint/2010/main" val="2851751214"/>
       </p:ext>
     </p:extLst>
   </p:cSld>
@@ -747,7 +728,13 @@
       </p:grpSpPr>
       <p:sp>
         <p:nvSpPr>
-          <p:cNvPr id="2" name="Title 1"/>
+          <p:cNvPr id="2" name="Title 1">
+            <a:extLst>
+              <a:ext uri="{FF2B5EF4-FFF2-40B4-BE49-F238E27FC236}">
+                <a16:creationId xmlns:a16="http://schemas.microsoft.com/office/drawing/2014/main" id="{0A908BB4-67AE-44AE-854C-1954838EACF1}"/>
+              </a:ext>
+            </a:extLst>
+          </p:cNvPr>
           <p:cNvSpPr>
             <a:spLocks noGrp="1"/>
           </p:cNvSpPr>
@@ -770,7 +757,13 @@
       </p:sp>
       <p:sp>
         <p:nvSpPr>
-          <p:cNvPr id="3" name="Vertical Text Placeholder 2"/>
+          <p:cNvPr id="3" name="Vertical Text Placeholder 2">
+            <a:extLst>
+              <a:ext uri="{FF2B5EF4-FFF2-40B4-BE49-F238E27FC236}">
+                <a16:creationId xmlns:a16="http://schemas.microsoft.com/office/drawing/2014/main" id="{4C4658FB-F1DD-48B8-828B-EB602B4CD464}"/>
+              </a:ext>
+            </a:extLst>
+          </p:cNvPr>
           <p:cNvSpPr>
             <a:spLocks noGrp="1"/>
           </p:cNvSpPr>
@@ -822,7 +815,13 @@
       </p:sp>
       <p:sp>
         <p:nvSpPr>
-          <p:cNvPr id="4" name="Date Placeholder 3"/>
+          <p:cNvPr id="4" name="Date Placeholder 3">
+            <a:extLst>
+              <a:ext uri="{FF2B5EF4-FFF2-40B4-BE49-F238E27FC236}">
+                <a16:creationId xmlns:a16="http://schemas.microsoft.com/office/drawing/2014/main" id="{8D26038E-EE27-462D-9751-C6155149704F}"/>
+              </a:ext>
+            </a:extLst>
+          </p:cNvPr>
           <p:cNvSpPr>
             <a:spLocks noGrp="1"/>
           </p:cNvSpPr>
@@ -837,7 +836,7 @@
           <a:p>
             <a:fld id="{7AFF31AE-7E83-4051-921C-AF3F8D575BC5}" type="datetime1">
               <a:rPr lang="id-ID" smtClean="0"/>
-              <a:t>17/06/2020</a:t>
+              <a:t>18/06/2020</a:t>
             </a:fld>
             <a:endParaRPr lang="id-ID"/>
           </a:p>
@@ -845,7 +844,13 @@
       </p:sp>
       <p:sp>
         <p:nvSpPr>
-          <p:cNvPr id="5" name="Footer Placeholder 4"/>
+          <p:cNvPr id="5" name="Footer Placeholder 4">
+            <a:extLst>
+              <a:ext uri="{FF2B5EF4-FFF2-40B4-BE49-F238E27FC236}">
+                <a16:creationId xmlns:a16="http://schemas.microsoft.com/office/drawing/2014/main" id="{98576C17-E0BA-4DE8-9176-54D91F239A8C}"/>
+              </a:ext>
+            </a:extLst>
+          </p:cNvPr>
           <p:cNvSpPr>
             <a:spLocks noGrp="1"/>
           </p:cNvSpPr>
@@ -864,7 +869,13 @@
       </p:sp>
       <p:sp>
         <p:nvSpPr>
-          <p:cNvPr id="6" name="Slide Number Placeholder 5"/>
+          <p:cNvPr id="6" name="Slide Number Placeholder 5">
+            <a:extLst>
+              <a:ext uri="{FF2B5EF4-FFF2-40B4-BE49-F238E27FC236}">
+                <a16:creationId xmlns:a16="http://schemas.microsoft.com/office/drawing/2014/main" id="{80A7CCD0-DA7E-4251-A881-4F6D2D1A8D31}"/>
+              </a:ext>
+            </a:extLst>
+          </p:cNvPr>
           <p:cNvSpPr>
             <a:spLocks noGrp="1"/>
           </p:cNvSpPr>
@@ -888,7 +899,7 @@
     </p:spTree>
     <p:extLst>
       <p:ext uri="{BB962C8B-B14F-4D97-AF65-F5344CB8AC3E}">
-        <p14:creationId xmlns:p14="http://schemas.microsoft.com/office/powerpoint/2010/main" val="4291831015"/>
+        <p14:creationId xmlns:p14="http://schemas.microsoft.com/office/powerpoint/2010/main" val="4124332608"/>
       </p:ext>
     </p:extLst>
   </p:cSld>
@@ -917,7 +928,13 @@
       </p:grpSpPr>
       <p:sp>
         <p:nvSpPr>
-          <p:cNvPr id="2" name="Vertical Title 1"/>
+          <p:cNvPr id="2" name="Vertical Title 1">
+            <a:extLst>
+              <a:ext uri="{FF2B5EF4-FFF2-40B4-BE49-F238E27FC236}">
+                <a16:creationId xmlns:a16="http://schemas.microsoft.com/office/drawing/2014/main" id="{DFCE603F-B41A-4BB4-BB26-13737DF235E8}"/>
+              </a:ext>
+            </a:extLst>
+          </p:cNvPr>
           <p:cNvSpPr>
             <a:spLocks noGrp="1"/>
           </p:cNvSpPr>
@@ -927,8 +944,8 @@
         </p:nvSpPr>
         <p:spPr>
           <a:xfrm>
-            <a:off x="6629400" y="274638"/>
-            <a:ext cx="2057400" cy="5851525"/>
+            <a:off x="6543675" y="365125"/>
+            <a:ext cx="1971675" cy="5811838"/>
           </a:xfrm>
         </p:spPr>
         <p:txBody>
@@ -945,7 +962,13 @@
       </p:sp>
       <p:sp>
         <p:nvSpPr>
-          <p:cNvPr id="3" name="Vertical Text Placeholder 2"/>
+          <p:cNvPr id="3" name="Vertical Text Placeholder 2">
+            <a:extLst>
+              <a:ext uri="{FF2B5EF4-FFF2-40B4-BE49-F238E27FC236}">
+                <a16:creationId xmlns:a16="http://schemas.microsoft.com/office/drawing/2014/main" id="{1D181F7F-831D-4EBC-B796-FA4D862109E9}"/>
+              </a:ext>
+            </a:extLst>
+          </p:cNvPr>
           <p:cNvSpPr>
             <a:spLocks noGrp="1"/>
           </p:cNvSpPr>
@@ -955,8 +978,8 @@
         </p:nvSpPr>
         <p:spPr>
           <a:xfrm>
-            <a:off x="457200" y="274638"/>
-            <a:ext cx="6019800" cy="5851525"/>
+            <a:off x="628650" y="365125"/>
+            <a:ext cx="5800725" cy="5811838"/>
           </a:xfrm>
         </p:spPr>
         <p:txBody>
@@ -1002,7 +1025,13 @@
       </p:sp>
       <p:sp>
         <p:nvSpPr>
-          <p:cNvPr id="4" name="Date Placeholder 3"/>
+          <p:cNvPr id="4" name="Date Placeholder 3">
+            <a:extLst>
+              <a:ext uri="{FF2B5EF4-FFF2-40B4-BE49-F238E27FC236}">
+                <a16:creationId xmlns:a16="http://schemas.microsoft.com/office/drawing/2014/main" id="{3B0525E4-2311-45CD-8BB3-10FD2EBF280F}"/>
+              </a:ext>
+            </a:extLst>
+          </p:cNvPr>
           <p:cNvSpPr>
             <a:spLocks noGrp="1"/>
           </p:cNvSpPr>
@@ -1017,7 +1046,7 @@
           <a:p>
             <a:fld id="{555CC458-75DB-4CD5-97E4-FE96F9D71AC9}" type="datetime1">
               <a:rPr lang="id-ID" smtClean="0"/>
-              <a:t>17/06/2020</a:t>
+              <a:t>18/06/2020</a:t>
             </a:fld>
             <a:endParaRPr lang="id-ID"/>
           </a:p>
@@ -1025,7 +1054,13 @@
       </p:sp>
       <p:sp>
         <p:nvSpPr>
-          <p:cNvPr id="5" name="Footer Placeholder 4"/>
+          <p:cNvPr id="5" name="Footer Placeholder 4">
+            <a:extLst>
+              <a:ext uri="{FF2B5EF4-FFF2-40B4-BE49-F238E27FC236}">
+                <a16:creationId xmlns:a16="http://schemas.microsoft.com/office/drawing/2014/main" id="{6F61E722-E6D0-4B57-A664-8940A401E8E5}"/>
+              </a:ext>
+            </a:extLst>
+          </p:cNvPr>
           <p:cNvSpPr>
             <a:spLocks noGrp="1"/>
           </p:cNvSpPr>
@@ -1044,7 +1079,13 @@
       </p:sp>
       <p:sp>
         <p:nvSpPr>
-          <p:cNvPr id="6" name="Slide Number Placeholder 5"/>
+          <p:cNvPr id="6" name="Slide Number Placeholder 5">
+            <a:extLst>
+              <a:ext uri="{FF2B5EF4-FFF2-40B4-BE49-F238E27FC236}">
+                <a16:creationId xmlns:a16="http://schemas.microsoft.com/office/drawing/2014/main" id="{1F95E4A4-867B-4CF4-80CA-B6FD78A5A1E7}"/>
+              </a:ext>
+            </a:extLst>
+          </p:cNvPr>
           <p:cNvSpPr>
             <a:spLocks noGrp="1"/>
           </p:cNvSpPr>
@@ -1068,7 +1109,7 @@
     </p:spTree>
     <p:extLst>
       <p:ext uri="{BB962C8B-B14F-4D97-AF65-F5344CB8AC3E}">
-        <p14:creationId xmlns:p14="http://schemas.microsoft.com/office/powerpoint/2010/main" val="1157790847"/>
+        <p14:creationId xmlns:p14="http://schemas.microsoft.com/office/powerpoint/2010/main" val="1393882432"/>
       </p:ext>
     </p:extLst>
   </p:cSld>
@@ -1097,7 +1138,13 @@
       </p:grpSpPr>
       <p:sp>
         <p:nvSpPr>
-          <p:cNvPr id="2" name="Title 1"/>
+          <p:cNvPr id="2" name="Title 1">
+            <a:extLst>
+              <a:ext uri="{FF2B5EF4-FFF2-40B4-BE49-F238E27FC236}">
+                <a16:creationId xmlns:a16="http://schemas.microsoft.com/office/drawing/2014/main" id="{F492182E-E31A-4ED3-9F01-B5E3349A8647}"/>
+              </a:ext>
+            </a:extLst>
+          </p:cNvPr>
           <p:cNvSpPr>
             <a:spLocks noGrp="1"/>
           </p:cNvSpPr>
@@ -1120,7 +1167,13 @@
       </p:sp>
       <p:sp>
         <p:nvSpPr>
-          <p:cNvPr id="3" name="Content Placeholder 2"/>
+          <p:cNvPr id="3" name="Content Placeholder 2">
+            <a:extLst>
+              <a:ext uri="{FF2B5EF4-FFF2-40B4-BE49-F238E27FC236}">
+                <a16:creationId xmlns:a16="http://schemas.microsoft.com/office/drawing/2014/main" id="{9649F975-397F-4958-91C6-612C1A0A29C1}"/>
+              </a:ext>
+            </a:extLst>
+          </p:cNvPr>
           <p:cNvSpPr>
             <a:spLocks noGrp="1"/>
           </p:cNvSpPr>
@@ -1172,7 +1225,13 @@
       </p:sp>
       <p:sp>
         <p:nvSpPr>
-          <p:cNvPr id="4" name="Date Placeholder 3"/>
+          <p:cNvPr id="4" name="Date Placeholder 3">
+            <a:extLst>
+              <a:ext uri="{FF2B5EF4-FFF2-40B4-BE49-F238E27FC236}">
+                <a16:creationId xmlns:a16="http://schemas.microsoft.com/office/drawing/2014/main" id="{726027EA-AF6A-4397-837F-23F79493A59A}"/>
+              </a:ext>
+            </a:extLst>
+          </p:cNvPr>
           <p:cNvSpPr>
             <a:spLocks noGrp="1"/>
           </p:cNvSpPr>
@@ -1187,7 +1246,7 @@
           <a:p>
             <a:fld id="{7C2CE307-A98E-4AD9-9F26-6E28005044CF}" type="datetime1">
               <a:rPr lang="id-ID" smtClean="0"/>
-              <a:t>17/06/2020</a:t>
+              <a:t>18/06/2020</a:t>
             </a:fld>
             <a:endParaRPr lang="id-ID"/>
           </a:p>
@@ -1195,7 +1254,13 @@
       </p:sp>
       <p:sp>
         <p:nvSpPr>
-          <p:cNvPr id="5" name="Footer Placeholder 4"/>
+          <p:cNvPr id="5" name="Footer Placeholder 4">
+            <a:extLst>
+              <a:ext uri="{FF2B5EF4-FFF2-40B4-BE49-F238E27FC236}">
+                <a16:creationId xmlns:a16="http://schemas.microsoft.com/office/drawing/2014/main" id="{107DFBD0-00AD-4C70-BD6B-A1F80A4DC7E4}"/>
+              </a:ext>
+            </a:extLst>
+          </p:cNvPr>
           <p:cNvSpPr>
             <a:spLocks noGrp="1"/>
           </p:cNvSpPr>
@@ -1214,7 +1279,13 @@
       </p:sp>
       <p:sp>
         <p:nvSpPr>
-          <p:cNvPr id="6" name="Slide Number Placeholder 5"/>
+          <p:cNvPr id="6" name="Slide Number Placeholder 5">
+            <a:extLst>
+              <a:ext uri="{FF2B5EF4-FFF2-40B4-BE49-F238E27FC236}">
+                <a16:creationId xmlns:a16="http://schemas.microsoft.com/office/drawing/2014/main" id="{A16B0274-B928-4D92-A9C1-EB0B49492224}"/>
+              </a:ext>
+            </a:extLst>
+          </p:cNvPr>
           <p:cNvSpPr>
             <a:spLocks noGrp="1"/>
           </p:cNvSpPr>
@@ -1238,7 +1309,7 @@
     </p:spTree>
     <p:extLst>
       <p:ext uri="{BB962C8B-B14F-4D97-AF65-F5344CB8AC3E}">
-        <p14:creationId xmlns:p14="http://schemas.microsoft.com/office/powerpoint/2010/main" val="2434441818"/>
+        <p14:creationId xmlns:p14="http://schemas.microsoft.com/office/powerpoint/2010/main" val="1544471084"/>
       </p:ext>
     </p:extLst>
   </p:cSld>
@@ -1267,7 +1338,13 @@
       </p:grpSpPr>
       <p:sp>
         <p:nvSpPr>
-          <p:cNvPr id="2" name="Title 1"/>
+          <p:cNvPr id="2" name="Title 1">
+            <a:extLst>
+              <a:ext uri="{FF2B5EF4-FFF2-40B4-BE49-F238E27FC236}">
+                <a16:creationId xmlns:a16="http://schemas.microsoft.com/office/drawing/2014/main" id="{A6DEE850-EB0D-4243-9C71-2CB3B65C13A2}"/>
+              </a:ext>
+            </a:extLst>
+          </p:cNvPr>
           <p:cNvSpPr>
             <a:spLocks noGrp="1"/>
           </p:cNvSpPr>
@@ -1277,15 +1354,15 @@
         </p:nvSpPr>
         <p:spPr>
           <a:xfrm>
-            <a:off x="722313" y="4406900"/>
-            <a:ext cx="7772400" cy="1362075"/>
+            <a:off x="623888" y="1709739"/>
+            <a:ext cx="7886700" cy="2852737"/>
           </a:xfrm>
         </p:spPr>
         <p:txBody>
-          <a:bodyPr anchor="t"/>
+          <a:bodyPr anchor="b"/>
           <a:lstStyle>
-            <a:lvl1pPr algn="l">
-              <a:defRPr sz="4000" b="1" cap="all"/>
+            <a:lvl1pPr>
+              <a:defRPr sz="4500"/>
             </a:lvl1pPr>
           </a:lstStyle>
           <a:p>
@@ -1299,7 +1376,13 @@
       </p:sp>
       <p:sp>
         <p:nvSpPr>
-          <p:cNvPr id="3" name="Text Placeholder 2"/>
+          <p:cNvPr id="3" name="Text Placeholder 2">
+            <a:extLst>
+              <a:ext uri="{FF2B5EF4-FFF2-40B4-BE49-F238E27FC236}">
+                <a16:creationId xmlns:a16="http://schemas.microsoft.com/office/drawing/2014/main" id="{FEDB9AB0-4D01-47E5-B302-60C176AC11E2}"/>
+              </a:ext>
+            </a:extLst>
+          </p:cNvPr>
           <p:cNvSpPr>
             <a:spLocks noGrp="1"/>
           </p:cNvSpPr>
@@ -1309,24 +1392,14 @@
         </p:nvSpPr>
         <p:spPr>
           <a:xfrm>
-            <a:off x="722313" y="2906713"/>
-            <a:ext cx="7772400" cy="1500187"/>
+            <a:off x="623888" y="4589464"/>
+            <a:ext cx="7886700" cy="1500187"/>
           </a:xfrm>
         </p:spPr>
         <p:txBody>
-          <a:bodyPr anchor="b"/>
+          <a:bodyPr/>
           <a:lstStyle>
             <a:lvl1pPr marL="0" indent="0">
-              <a:buNone/>
-              <a:defRPr sz="2000">
-                <a:solidFill>
-                  <a:schemeClr val="tx1">
-                    <a:tint val="75000"/>
-                  </a:schemeClr>
-                </a:solidFill>
-              </a:defRPr>
-            </a:lvl1pPr>
-            <a:lvl2pPr marL="457200" indent="0">
               <a:buNone/>
               <a:defRPr sz="1800">
                 <a:solidFill>
@@ -1335,10 +1408,20 @@
                   </a:schemeClr>
                 </a:solidFill>
               </a:defRPr>
+            </a:lvl1pPr>
+            <a:lvl2pPr marL="342900" indent="0">
+              <a:buNone/>
+              <a:defRPr sz="1500">
+                <a:solidFill>
+                  <a:schemeClr val="tx1">
+                    <a:tint val="75000"/>
+                  </a:schemeClr>
+                </a:solidFill>
+              </a:defRPr>
             </a:lvl2pPr>
-            <a:lvl3pPr marL="914400" indent="0">
+            <a:lvl3pPr marL="685800" indent="0">
               <a:buNone/>
-              <a:defRPr sz="1600">
+              <a:defRPr sz="1350">
                 <a:solidFill>
                   <a:schemeClr val="tx1">
                     <a:tint val="75000"/>
@@ -1346,9 +1429,9 @@
                 </a:solidFill>
               </a:defRPr>
             </a:lvl3pPr>
-            <a:lvl4pPr marL="1371600" indent="0">
+            <a:lvl4pPr marL="1028700" indent="0">
               <a:buNone/>
-              <a:defRPr sz="1400">
+              <a:defRPr sz="1200">
                 <a:solidFill>
                   <a:schemeClr val="tx1">
                     <a:tint val="75000"/>
@@ -1356,9 +1439,9 @@
                 </a:solidFill>
               </a:defRPr>
             </a:lvl4pPr>
-            <a:lvl5pPr marL="1828800" indent="0">
+            <a:lvl5pPr marL="1371600" indent="0">
               <a:buNone/>
-              <a:defRPr sz="1400">
+              <a:defRPr sz="1200">
                 <a:solidFill>
                   <a:schemeClr val="tx1">
                     <a:tint val="75000"/>
@@ -1366,9 +1449,9 @@
                 </a:solidFill>
               </a:defRPr>
             </a:lvl5pPr>
-            <a:lvl6pPr marL="2286000" indent="0">
+            <a:lvl6pPr marL="1714500" indent="0">
               <a:buNone/>
-              <a:defRPr sz="1400">
+              <a:defRPr sz="1200">
                 <a:solidFill>
                   <a:schemeClr val="tx1">
                     <a:tint val="75000"/>
@@ -1376,9 +1459,9 @@
                 </a:solidFill>
               </a:defRPr>
             </a:lvl6pPr>
-            <a:lvl7pPr marL="2743200" indent="0">
+            <a:lvl7pPr marL="2057400" indent="0">
               <a:buNone/>
-              <a:defRPr sz="1400">
+              <a:defRPr sz="1200">
                 <a:solidFill>
                   <a:schemeClr val="tx1">
                     <a:tint val="75000"/>
@@ -1386,9 +1469,9 @@
                 </a:solidFill>
               </a:defRPr>
             </a:lvl7pPr>
-            <a:lvl8pPr marL="3200400" indent="0">
+            <a:lvl8pPr marL="2400300" indent="0">
               <a:buNone/>
-              <a:defRPr sz="1400">
+              <a:defRPr sz="1200">
                 <a:solidFill>
                   <a:schemeClr val="tx1">
                     <a:tint val="75000"/>
@@ -1396,9 +1479,9 @@
                 </a:solidFill>
               </a:defRPr>
             </a:lvl8pPr>
-            <a:lvl9pPr marL="3657600" indent="0">
+            <a:lvl9pPr marL="2743200" indent="0">
               <a:buNone/>
-              <a:defRPr sz="1400">
+              <a:defRPr sz="1200">
                 <a:solidFill>
                   <a:schemeClr val="tx1">
                     <a:tint val="75000"/>
@@ -1418,7 +1501,13 @@
       </p:sp>
       <p:sp>
         <p:nvSpPr>
-          <p:cNvPr id="4" name="Date Placeholder 3"/>
+          <p:cNvPr id="4" name="Date Placeholder 3">
+            <a:extLst>
+              <a:ext uri="{FF2B5EF4-FFF2-40B4-BE49-F238E27FC236}">
+                <a16:creationId xmlns:a16="http://schemas.microsoft.com/office/drawing/2014/main" id="{E00BC9BF-0679-4770-9A8B-F247C93541BE}"/>
+              </a:ext>
+            </a:extLst>
+          </p:cNvPr>
           <p:cNvSpPr>
             <a:spLocks noGrp="1"/>
           </p:cNvSpPr>
@@ -1433,7 +1522,7 @@
           <a:p>
             <a:fld id="{8BD6ACB8-8078-4239-AB0C-F1770CD2DACB}" type="datetime1">
               <a:rPr lang="id-ID" smtClean="0"/>
-              <a:t>17/06/2020</a:t>
+              <a:t>18/06/2020</a:t>
             </a:fld>
             <a:endParaRPr lang="id-ID"/>
           </a:p>
@@ -1441,7 +1530,13 @@
       </p:sp>
       <p:sp>
         <p:nvSpPr>
-          <p:cNvPr id="5" name="Footer Placeholder 4"/>
+          <p:cNvPr id="5" name="Footer Placeholder 4">
+            <a:extLst>
+              <a:ext uri="{FF2B5EF4-FFF2-40B4-BE49-F238E27FC236}">
+                <a16:creationId xmlns:a16="http://schemas.microsoft.com/office/drawing/2014/main" id="{55AEE184-255D-4293-8332-8A1EFC72E032}"/>
+              </a:ext>
+            </a:extLst>
+          </p:cNvPr>
           <p:cNvSpPr>
             <a:spLocks noGrp="1"/>
           </p:cNvSpPr>
@@ -1460,7 +1555,13 @@
       </p:sp>
       <p:sp>
         <p:nvSpPr>
-          <p:cNvPr id="6" name="Slide Number Placeholder 5"/>
+          <p:cNvPr id="6" name="Slide Number Placeholder 5">
+            <a:extLst>
+              <a:ext uri="{FF2B5EF4-FFF2-40B4-BE49-F238E27FC236}">
+                <a16:creationId xmlns:a16="http://schemas.microsoft.com/office/drawing/2014/main" id="{9B6460DC-47CB-4571-A738-CBDD8EDD24F3}"/>
+              </a:ext>
+            </a:extLst>
+          </p:cNvPr>
           <p:cNvSpPr>
             <a:spLocks noGrp="1"/>
           </p:cNvSpPr>
@@ -1484,7 +1585,7 @@
     </p:spTree>
     <p:extLst>
       <p:ext uri="{BB962C8B-B14F-4D97-AF65-F5344CB8AC3E}">
-        <p14:creationId xmlns:p14="http://schemas.microsoft.com/office/powerpoint/2010/main" val="1154823965"/>
+        <p14:creationId xmlns:p14="http://schemas.microsoft.com/office/powerpoint/2010/main" val="425260258"/>
       </p:ext>
     </p:extLst>
   </p:cSld>
@@ -1513,7 +1614,13 @@
       </p:grpSpPr>
       <p:sp>
         <p:nvSpPr>
-          <p:cNvPr id="2" name="Title 1"/>
+          <p:cNvPr id="2" name="Title 1">
+            <a:extLst>
+              <a:ext uri="{FF2B5EF4-FFF2-40B4-BE49-F238E27FC236}">
+                <a16:creationId xmlns:a16="http://schemas.microsoft.com/office/drawing/2014/main" id="{BB3A9479-8882-40D8-A6BB-AF3D4A303883}"/>
+              </a:ext>
+            </a:extLst>
+          </p:cNvPr>
           <p:cNvSpPr>
             <a:spLocks noGrp="1"/>
           </p:cNvSpPr>
@@ -1536,7 +1643,13 @@
       </p:sp>
       <p:sp>
         <p:nvSpPr>
-          <p:cNvPr id="3" name="Content Placeholder 2"/>
+          <p:cNvPr id="3" name="Content Placeholder 2">
+            <a:extLst>
+              <a:ext uri="{FF2B5EF4-FFF2-40B4-BE49-F238E27FC236}">
+                <a16:creationId xmlns:a16="http://schemas.microsoft.com/office/drawing/2014/main" id="{E7C9B709-D93E-4FC8-B5B4-153C6AE34746}"/>
+              </a:ext>
+            </a:extLst>
+          </p:cNvPr>
           <p:cNvSpPr>
             <a:spLocks noGrp="1"/>
           </p:cNvSpPr>
@@ -1546,41 +1659,13 @@
         </p:nvSpPr>
         <p:spPr>
           <a:xfrm>
-            <a:off x="457200" y="1600200"/>
-            <a:ext cx="4038600" cy="4525963"/>
+            <a:off x="628650" y="1825625"/>
+            <a:ext cx="3886200" cy="4351338"/>
           </a:xfrm>
         </p:spPr>
         <p:txBody>
           <a:bodyPr/>
-          <a:lstStyle>
-            <a:lvl1pPr>
-              <a:defRPr sz="2800"/>
-            </a:lvl1pPr>
-            <a:lvl2pPr>
-              <a:defRPr sz="2400"/>
-            </a:lvl2pPr>
-            <a:lvl3pPr>
-              <a:defRPr sz="2000"/>
-            </a:lvl3pPr>
-            <a:lvl4pPr>
-              <a:defRPr sz="1800"/>
-            </a:lvl4pPr>
-            <a:lvl5pPr>
-              <a:defRPr sz="1800"/>
-            </a:lvl5pPr>
-            <a:lvl6pPr>
-              <a:defRPr sz="1800"/>
-            </a:lvl6pPr>
-            <a:lvl7pPr>
-              <a:defRPr sz="1800"/>
-            </a:lvl7pPr>
-            <a:lvl8pPr>
-              <a:defRPr sz="1800"/>
-            </a:lvl8pPr>
-            <a:lvl9pPr>
-              <a:defRPr sz="1800"/>
-            </a:lvl9pPr>
-          </a:lstStyle>
+          <a:lstStyle/>
           <a:p>
             <a:pPr lvl="0"/>
             <a:r>
@@ -1621,7 +1706,13 @@
       </p:sp>
       <p:sp>
         <p:nvSpPr>
-          <p:cNvPr id="4" name="Content Placeholder 3"/>
+          <p:cNvPr id="4" name="Content Placeholder 3">
+            <a:extLst>
+              <a:ext uri="{FF2B5EF4-FFF2-40B4-BE49-F238E27FC236}">
+                <a16:creationId xmlns:a16="http://schemas.microsoft.com/office/drawing/2014/main" id="{1D3BF386-1D6A-4189-9C44-43436C403F76}"/>
+              </a:ext>
+            </a:extLst>
+          </p:cNvPr>
           <p:cNvSpPr>
             <a:spLocks noGrp="1"/>
           </p:cNvSpPr>
@@ -1631,41 +1722,13 @@
         </p:nvSpPr>
         <p:spPr>
           <a:xfrm>
-            <a:off x="4648200" y="1600200"/>
-            <a:ext cx="4038600" cy="4525963"/>
+            <a:off x="4629150" y="1825625"/>
+            <a:ext cx="3886200" cy="4351338"/>
           </a:xfrm>
         </p:spPr>
         <p:txBody>
           <a:bodyPr/>
-          <a:lstStyle>
-            <a:lvl1pPr>
-              <a:defRPr sz="2800"/>
-            </a:lvl1pPr>
-            <a:lvl2pPr>
-              <a:defRPr sz="2400"/>
-            </a:lvl2pPr>
-            <a:lvl3pPr>
-              <a:defRPr sz="2000"/>
-            </a:lvl3pPr>
-            <a:lvl4pPr>
-              <a:defRPr sz="1800"/>
-            </a:lvl4pPr>
-            <a:lvl5pPr>
-              <a:defRPr sz="1800"/>
-            </a:lvl5pPr>
-            <a:lvl6pPr>
-              <a:defRPr sz="1800"/>
-            </a:lvl6pPr>
-            <a:lvl7pPr>
-              <a:defRPr sz="1800"/>
-            </a:lvl7pPr>
-            <a:lvl8pPr>
-              <a:defRPr sz="1800"/>
-            </a:lvl8pPr>
-            <a:lvl9pPr>
-              <a:defRPr sz="1800"/>
-            </a:lvl9pPr>
-          </a:lstStyle>
+          <a:lstStyle/>
           <a:p>
             <a:pPr lvl="0"/>
             <a:r>
@@ -1706,7 +1769,13 @@
       </p:sp>
       <p:sp>
         <p:nvSpPr>
-          <p:cNvPr id="5" name="Date Placeholder 4"/>
+          <p:cNvPr id="5" name="Date Placeholder 4">
+            <a:extLst>
+              <a:ext uri="{FF2B5EF4-FFF2-40B4-BE49-F238E27FC236}">
+                <a16:creationId xmlns:a16="http://schemas.microsoft.com/office/drawing/2014/main" id="{F261606B-8877-49B3-8FF0-C0C178965BFC}"/>
+              </a:ext>
+            </a:extLst>
+          </p:cNvPr>
           <p:cNvSpPr>
             <a:spLocks noGrp="1"/>
           </p:cNvSpPr>
@@ -1721,7 +1790,7 @@
           <a:p>
             <a:fld id="{1C011B94-F858-41B7-8F99-6301C0B7EE88}" type="datetime1">
               <a:rPr lang="id-ID" smtClean="0"/>
-              <a:t>17/06/2020</a:t>
+              <a:t>18/06/2020</a:t>
             </a:fld>
             <a:endParaRPr lang="id-ID"/>
           </a:p>
@@ -1729,7 +1798,13 @@
       </p:sp>
       <p:sp>
         <p:nvSpPr>
-          <p:cNvPr id="6" name="Footer Placeholder 5"/>
+          <p:cNvPr id="6" name="Footer Placeholder 5">
+            <a:extLst>
+              <a:ext uri="{FF2B5EF4-FFF2-40B4-BE49-F238E27FC236}">
+                <a16:creationId xmlns:a16="http://schemas.microsoft.com/office/drawing/2014/main" id="{714D7CC7-23D2-45D7-8566-AE778104414C}"/>
+              </a:ext>
+            </a:extLst>
+          </p:cNvPr>
           <p:cNvSpPr>
             <a:spLocks noGrp="1"/>
           </p:cNvSpPr>
@@ -1748,7 +1823,13 @@
       </p:sp>
       <p:sp>
         <p:nvSpPr>
-          <p:cNvPr id="7" name="Slide Number Placeholder 6"/>
+          <p:cNvPr id="7" name="Slide Number Placeholder 6">
+            <a:extLst>
+              <a:ext uri="{FF2B5EF4-FFF2-40B4-BE49-F238E27FC236}">
+                <a16:creationId xmlns:a16="http://schemas.microsoft.com/office/drawing/2014/main" id="{B5FD1A49-D715-487D-9B75-7A71DEC57803}"/>
+              </a:ext>
+            </a:extLst>
+          </p:cNvPr>
           <p:cNvSpPr>
             <a:spLocks noGrp="1"/>
           </p:cNvSpPr>
@@ -1772,7 +1853,7 @@
     </p:spTree>
     <p:extLst>
       <p:ext uri="{BB962C8B-B14F-4D97-AF65-F5344CB8AC3E}">
-        <p14:creationId xmlns:p14="http://schemas.microsoft.com/office/powerpoint/2010/main" val="3902626599"/>
+        <p14:creationId xmlns:p14="http://schemas.microsoft.com/office/powerpoint/2010/main" val="3612982516"/>
       </p:ext>
     </p:extLst>
   </p:cSld>
@@ -1801,7 +1882,13 @@
       </p:grpSpPr>
       <p:sp>
         <p:nvSpPr>
-          <p:cNvPr id="2" name="Title 1"/>
+          <p:cNvPr id="2" name="Title 1">
+            <a:extLst>
+              <a:ext uri="{FF2B5EF4-FFF2-40B4-BE49-F238E27FC236}">
+                <a16:creationId xmlns:a16="http://schemas.microsoft.com/office/drawing/2014/main" id="{D2CA72DE-22AC-4ABE-964F-25468E9E7C50}"/>
+              </a:ext>
+            </a:extLst>
+          </p:cNvPr>
           <p:cNvSpPr>
             <a:spLocks noGrp="1"/>
           </p:cNvSpPr>
@@ -1809,14 +1896,15 @@
             <p:ph type="title"/>
           </p:nvPr>
         </p:nvSpPr>
-        <p:spPr/>
+        <p:spPr>
+          <a:xfrm>
+            <a:off x="629841" y="365126"/>
+            <a:ext cx="7886700" cy="1325563"/>
+          </a:xfrm>
+        </p:spPr>
         <p:txBody>
           <a:bodyPr/>
-          <a:lstStyle>
-            <a:lvl1pPr>
-              <a:defRPr/>
-            </a:lvl1pPr>
-          </a:lstStyle>
+          <a:lstStyle/>
           <a:p>
             <a:r>
               <a:rPr lang="en-US"/>
@@ -1828,7 +1916,13 @@
       </p:sp>
       <p:sp>
         <p:nvSpPr>
-          <p:cNvPr id="3" name="Text Placeholder 2"/>
+          <p:cNvPr id="3" name="Text Placeholder 2">
+            <a:extLst>
+              <a:ext uri="{FF2B5EF4-FFF2-40B4-BE49-F238E27FC236}">
+                <a16:creationId xmlns:a16="http://schemas.microsoft.com/office/drawing/2014/main" id="{0E55A164-2D61-4893-95F5-C62A5C952A4D}"/>
+              </a:ext>
+            </a:extLst>
+          </p:cNvPr>
           <p:cNvSpPr>
             <a:spLocks noGrp="1"/>
           </p:cNvSpPr>
@@ -1838,8 +1932,8 @@
         </p:nvSpPr>
         <p:spPr>
           <a:xfrm>
-            <a:off x="457200" y="1535113"/>
-            <a:ext cx="4040188" cy="639762"/>
+            <a:off x="629842" y="1681163"/>
+            <a:ext cx="3868340" cy="823912"/>
           </a:xfrm>
         </p:spPr>
         <p:txBody>
@@ -1847,39 +1941,39 @@
           <a:lstStyle>
             <a:lvl1pPr marL="0" indent="0">
               <a:buNone/>
-              <a:defRPr sz="2400" b="1"/>
+              <a:defRPr sz="1800" b="1"/>
             </a:lvl1pPr>
-            <a:lvl2pPr marL="457200" indent="0">
+            <a:lvl2pPr marL="342900" indent="0">
               <a:buNone/>
-              <a:defRPr sz="2000" b="1"/>
+              <a:defRPr sz="1500" b="1"/>
             </a:lvl2pPr>
-            <a:lvl3pPr marL="914400" indent="0">
+            <a:lvl3pPr marL="685800" indent="0">
               <a:buNone/>
-              <a:defRPr sz="1800" b="1"/>
+              <a:defRPr sz="1350" b="1"/>
             </a:lvl3pPr>
-            <a:lvl4pPr marL="1371600" indent="0">
+            <a:lvl4pPr marL="1028700" indent="0">
               <a:buNone/>
-              <a:defRPr sz="1600" b="1"/>
+              <a:defRPr sz="1200" b="1"/>
             </a:lvl4pPr>
-            <a:lvl5pPr marL="1828800" indent="0">
+            <a:lvl5pPr marL="1371600" indent="0">
               <a:buNone/>
-              <a:defRPr sz="1600" b="1"/>
+              <a:defRPr sz="1200" b="1"/>
             </a:lvl5pPr>
-            <a:lvl6pPr marL="2286000" indent="0">
+            <a:lvl6pPr marL="1714500" indent="0">
               <a:buNone/>
-              <a:defRPr sz="1600" b="1"/>
+              <a:defRPr sz="1200" b="1"/>
             </a:lvl6pPr>
-            <a:lvl7pPr marL="2743200" indent="0">
+            <a:lvl7pPr marL="2057400" indent="0">
               <a:buNone/>
-              <a:defRPr sz="1600" b="1"/>
+              <a:defRPr sz="1200" b="1"/>
             </a:lvl7pPr>
-            <a:lvl8pPr marL="3200400" indent="0">
+            <a:lvl8pPr marL="2400300" indent="0">
               <a:buNone/>
-              <a:defRPr sz="1600" b="1"/>
+              <a:defRPr sz="1200" b="1"/>
             </a:lvl8pPr>
-            <a:lvl9pPr marL="3657600" indent="0">
+            <a:lvl9pPr marL="2743200" indent="0">
               <a:buNone/>
-              <a:defRPr sz="1600" b="1"/>
+              <a:defRPr sz="1200" b="1"/>
             </a:lvl9pPr>
           </a:lstStyle>
           <a:p>
@@ -1893,7 +1987,13 @@
       </p:sp>
       <p:sp>
         <p:nvSpPr>
-          <p:cNvPr id="4" name="Content Placeholder 3"/>
+          <p:cNvPr id="4" name="Content Placeholder 3">
+            <a:extLst>
+              <a:ext uri="{FF2B5EF4-FFF2-40B4-BE49-F238E27FC236}">
+                <a16:creationId xmlns:a16="http://schemas.microsoft.com/office/drawing/2014/main" id="{6A6C692D-2DA6-4846-8669-CFDEEE3C7E18}"/>
+              </a:ext>
+            </a:extLst>
+          </p:cNvPr>
           <p:cNvSpPr>
             <a:spLocks noGrp="1"/>
           </p:cNvSpPr>
@@ -1903,41 +2003,13 @@
         </p:nvSpPr>
         <p:spPr>
           <a:xfrm>
-            <a:off x="457200" y="2174875"/>
-            <a:ext cx="4040188" cy="3951288"/>
+            <a:off x="629842" y="2505075"/>
+            <a:ext cx="3868340" cy="3684588"/>
           </a:xfrm>
         </p:spPr>
         <p:txBody>
           <a:bodyPr/>
-          <a:lstStyle>
-            <a:lvl1pPr>
-              <a:defRPr sz="2400"/>
-            </a:lvl1pPr>
-            <a:lvl2pPr>
-              <a:defRPr sz="2000"/>
-            </a:lvl2pPr>
-            <a:lvl3pPr>
-              <a:defRPr sz="1800"/>
-            </a:lvl3pPr>
-            <a:lvl4pPr>
-              <a:defRPr sz="1600"/>
-            </a:lvl4pPr>
-            <a:lvl5pPr>
-              <a:defRPr sz="1600"/>
-            </a:lvl5pPr>
-            <a:lvl6pPr>
-              <a:defRPr sz="1600"/>
-            </a:lvl6pPr>
-            <a:lvl7pPr>
-              <a:defRPr sz="1600"/>
-            </a:lvl7pPr>
-            <a:lvl8pPr>
-              <a:defRPr sz="1600"/>
-            </a:lvl8pPr>
-            <a:lvl9pPr>
-              <a:defRPr sz="1600"/>
-            </a:lvl9pPr>
-          </a:lstStyle>
+          <a:lstStyle/>
           <a:p>
             <a:pPr lvl="0"/>
             <a:r>
@@ -1978,7 +2050,13 @@
       </p:sp>
       <p:sp>
         <p:nvSpPr>
-          <p:cNvPr id="5" name="Text Placeholder 4"/>
+          <p:cNvPr id="5" name="Text Placeholder 4">
+            <a:extLst>
+              <a:ext uri="{FF2B5EF4-FFF2-40B4-BE49-F238E27FC236}">
+                <a16:creationId xmlns:a16="http://schemas.microsoft.com/office/drawing/2014/main" id="{F93C6FA6-967E-47DD-AE1F-984B1A142156}"/>
+              </a:ext>
+            </a:extLst>
+          </p:cNvPr>
           <p:cNvSpPr>
             <a:spLocks noGrp="1"/>
           </p:cNvSpPr>
@@ -1988,8 +2066,8 @@
         </p:nvSpPr>
         <p:spPr>
           <a:xfrm>
-            <a:off x="4645025" y="1535113"/>
-            <a:ext cx="4041775" cy="639762"/>
+            <a:off x="4629150" y="1681163"/>
+            <a:ext cx="3887391" cy="823912"/>
           </a:xfrm>
         </p:spPr>
         <p:txBody>
@@ -1997,39 +2075,39 @@
           <a:lstStyle>
             <a:lvl1pPr marL="0" indent="0">
               <a:buNone/>
-              <a:defRPr sz="2400" b="1"/>
+              <a:defRPr sz="1800" b="1"/>
             </a:lvl1pPr>
-            <a:lvl2pPr marL="457200" indent="0">
+            <a:lvl2pPr marL="342900" indent="0">
               <a:buNone/>
-              <a:defRPr sz="2000" b="1"/>
+              <a:defRPr sz="1500" b="1"/>
             </a:lvl2pPr>
-            <a:lvl3pPr marL="914400" indent="0">
+            <a:lvl3pPr marL="685800" indent="0">
               <a:buNone/>
-              <a:defRPr sz="1800" b="1"/>
+              <a:defRPr sz="1350" b="1"/>
             </a:lvl3pPr>
-            <a:lvl4pPr marL="1371600" indent="0">
+            <a:lvl4pPr marL="1028700" indent="0">
               <a:buNone/>
-              <a:defRPr sz="1600" b="1"/>
+              <a:defRPr sz="1200" b="1"/>
             </a:lvl4pPr>
-            <a:lvl5pPr marL="1828800" indent="0">
+            <a:lvl5pPr marL="1371600" indent="0">
               <a:buNone/>
-              <a:defRPr sz="1600" b="1"/>
+              <a:defRPr sz="1200" b="1"/>
             </a:lvl5pPr>
-            <a:lvl6pPr marL="2286000" indent="0">
+            <a:lvl6pPr marL="1714500" indent="0">
               <a:buNone/>
-              <a:defRPr sz="1600" b="1"/>
+              <a:defRPr sz="1200" b="1"/>
             </a:lvl6pPr>
-            <a:lvl7pPr marL="2743200" indent="0">
+            <a:lvl7pPr marL="2057400" indent="0">
               <a:buNone/>
-              <a:defRPr sz="1600" b="1"/>
+              <a:defRPr sz="1200" b="1"/>
             </a:lvl7pPr>
-            <a:lvl8pPr marL="3200400" indent="0">
+            <a:lvl8pPr marL="2400300" indent="0">
               <a:buNone/>
-              <a:defRPr sz="1600" b="1"/>
+              <a:defRPr sz="1200" b="1"/>
             </a:lvl8pPr>
-            <a:lvl9pPr marL="3657600" indent="0">
+            <a:lvl9pPr marL="2743200" indent="0">
               <a:buNone/>
-              <a:defRPr sz="1600" b="1"/>
+              <a:defRPr sz="1200" b="1"/>
             </a:lvl9pPr>
           </a:lstStyle>
           <a:p>
@@ -2043,7 +2121,13 @@
       </p:sp>
       <p:sp>
         <p:nvSpPr>
-          <p:cNvPr id="6" name="Content Placeholder 5"/>
+          <p:cNvPr id="6" name="Content Placeholder 5">
+            <a:extLst>
+              <a:ext uri="{FF2B5EF4-FFF2-40B4-BE49-F238E27FC236}">
+                <a16:creationId xmlns:a16="http://schemas.microsoft.com/office/drawing/2014/main" id="{80082D04-D211-428E-A57C-635B730127A4}"/>
+              </a:ext>
+            </a:extLst>
+          </p:cNvPr>
           <p:cNvSpPr>
             <a:spLocks noGrp="1"/>
           </p:cNvSpPr>
@@ -2053,41 +2137,13 @@
         </p:nvSpPr>
         <p:spPr>
           <a:xfrm>
-            <a:off x="4645025" y="2174875"/>
-            <a:ext cx="4041775" cy="3951288"/>
+            <a:off x="4629150" y="2505075"/>
+            <a:ext cx="3887391" cy="3684588"/>
           </a:xfrm>
         </p:spPr>
         <p:txBody>
           <a:bodyPr/>
-          <a:lstStyle>
-            <a:lvl1pPr>
-              <a:defRPr sz="2400"/>
-            </a:lvl1pPr>
-            <a:lvl2pPr>
-              <a:defRPr sz="2000"/>
-            </a:lvl2pPr>
-            <a:lvl3pPr>
-              <a:defRPr sz="1800"/>
-            </a:lvl3pPr>
-            <a:lvl4pPr>
-              <a:defRPr sz="1600"/>
-            </a:lvl4pPr>
-            <a:lvl5pPr>
-              <a:defRPr sz="1600"/>
-            </a:lvl5pPr>
-            <a:lvl6pPr>
-              <a:defRPr sz="1600"/>
-            </a:lvl6pPr>
-            <a:lvl7pPr>
-              <a:defRPr sz="1600"/>
-            </a:lvl7pPr>
-            <a:lvl8pPr>
-              <a:defRPr sz="1600"/>
-            </a:lvl8pPr>
-            <a:lvl9pPr>
-              <a:defRPr sz="1600"/>
-            </a:lvl9pPr>
-          </a:lstStyle>
+          <a:lstStyle/>
           <a:p>
             <a:pPr lvl="0"/>
             <a:r>
@@ -2128,7 +2184,13 @@
       </p:sp>
       <p:sp>
         <p:nvSpPr>
-          <p:cNvPr id="7" name="Date Placeholder 6"/>
+          <p:cNvPr id="7" name="Date Placeholder 6">
+            <a:extLst>
+              <a:ext uri="{FF2B5EF4-FFF2-40B4-BE49-F238E27FC236}">
+                <a16:creationId xmlns:a16="http://schemas.microsoft.com/office/drawing/2014/main" id="{EBAACEB0-814C-4ADE-9E31-6B5F7DD8CFA7}"/>
+              </a:ext>
+            </a:extLst>
+          </p:cNvPr>
           <p:cNvSpPr>
             <a:spLocks noGrp="1"/>
           </p:cNvSpPr>
@@ -2143,7 +2205,7 @@
           <a:p>
             <a:fld id="{2582ADA2-4FAF-45B5-97D4-138401DFB93B}" type="datetime1">
               <a:rPr lang="id-ID" smtClean="0"/>
-              <a:t>17/06/2020</a:t>
+              <a:t>18/06/2020</a:t>
             </a:fld>
             <a:endParaRPr lang="id-ID"/>
           </a:p>
@@ -2151,7 +2213,13 @@
       </p:sp>
       <p:sp>
         <p:nvSpPr>
-          <p:cNvPr id="8" name="Footer Placeholder 7"/>
+          <p:cNvPr id="8" name="Footer Placeholder 7">
+            <a:extLst>
+              <a:ext uri="{FF2B5EF4-FFF2-40B4-BE49-F238E27FC236}">
+                <a16:creationId xmlns:a16="http://schemas.microsoft.com/office/drawing/2014/main" id="{C48190FB-4905-45F4-9866-6593F38A211E}"/>
+              </a:ext>
+            </a:extLst>
+          </p:cNvPr>
           <p:cNvSpPr>
             <a:spLocks noGrp="1"/>
           </p:cNvSpPr>
@@ -2170,7 +2238,13 @@
       </p:sp>
       <p:sp>
         <p:nvSpPr>
-          <p:cNvPr id="9" name="Slide Number Placeholder 8"/>
+          <p:cNvPr id="9" name="Slide Number Placeholder 8">
+            <a:extLst>
+              <a:ext uri="{FF2B5EF4-FFF2-40B4-BE49-F238E27FC236}">
+                <a16:creationId xmlns:a16="http://schemas.microsoft.com/office/drawing/2014/main" id="{4657A1EF-002D-41C8-9F8E-2F8B1E0C1C0C}"/>
+              </a:ext>
+            </a:extLst>
+          </p:cNvPr>
           <p:cNvSpPr>
             <a:spLocks noGrp="1"/>
           </p:cNvSpPr>
@@ -2194,7 +2268,7 @@
     </p:spTree>
     <p:extLst>
       <p:ext uri="{BB962C8B-B14F-4D97-AF65-F5344CB8AC3E}">
-        <p14:creationId xmlns:p14="http://schemas.microsoft.com/office/powerpoint/2010/main" val="4293610716"/>
+        <p14:creationId xmlns:p14="http://schemas.microsoft.com/office/powerpoint/2010/main" val="3012981521"/>
       </p:ext>
     </p:extLst>
   </p:cSld>
@@ -2223,7 +2297,13 @@
       </p:grpSpPr>
       <p:sp>
         <p:nvSpPr>
-          <p:cNvPr id="2" name="Title 1"/>
+          <p:cNvPr id="2" name="Title 1">
+            <a:extLst>
+              <a:ext uri="{FF2B5EF4-FFF2-40B4-BE49-F238E27FC236}">
+                <a16:creationId xmlns:a16="http://schemas.microsoft.com/office/drawing/2014/main" id="{11AEED36-9165-4C0B-8544-0B421174401B}"/>
+              </a:ext>
+            </a:extLst>
+          </p:cNvPr>
           <p:cNvSpPr>
             <a:spLocks noGrp="1"/>
           </p:cNvSpPr>
@@ -2246,7 +2326,13 @@
       </p:sp>
       <p:sp>
         <p:nvSpPr>
-          <p:cNvPr id="3" name="Date Placeholder 2"/>
+          <p:cNvPr id="3" name="Date Placeholder 2">
+            <a:extLst>
+              <a:ext uri="{FF2B5EF4-FFF2-40B4-BE49-F238E27FC236}">
+                <a16:creationId xmlns:a16="http://schemas.microsoft.com/office/drawing/2014/main" id="{57C39871-E7F1-41D3-9C19-6CAFCD7438ED}"/>
+              </a:ext>
+            </a:extLst>
+          </p:cNvPr>
           <p:cNvSpPr>
             <a:spLocks noGrp="1"/>
           </p:cNvSpPr>
@@ -2261,7 +2347,7 @@
           <a:p>
             <a:fld id="{A19995EC-E8A3-458E-9386-98670D64A019}" type="datetime1">
               <a:rPr lang="id-ID" smtClean="0"/>
-              <a:t>17/06/2020</a:t>
+              <a:t>18/06/2020</a:t>
             </a:fld>
             <a:endParaRPr lang="id-ID"/>
           </a:p>
@@ -2269,7 +2355,13 @@
       </p:sp>
       <p:sp>
         <p:nvSpPr>
-          <p:cNvPr id="4" name="Footer Placeholder 3"/>
+          <p:cNvPr id="4" name="Footer Placeholder 3">
+            <a:extLst>
+              <a:ext uri="{FF2B5EF4-FFF2-40B4-BE49-F238E27FC236}">
+                <a16:creationId xmlns:a16="http://schemas.microsoft.com/office/drawing/2014/main" id="{7B6D927D-CC3A-4440-A9A4-5E327BC7FC83}"/>
+              </a:ext>
+            </a:extLst>
+          </p:cNvPr>
           <p:cNvSpPr>
             <a:spLocks noGrp="1"/>
           </p:cNvSpPr>
@@ -2288,7 +2380,13 @@
       </p:sp>
       <p:sp>
         <p:nvSpPr>
-          <p:cNvPr id="5" name="Slide Number Placeholder 4"/>
+          <p:cNvPr id="5" name="Slide Number Placeholder 4">
+            <a:extLst>
+              <a:ext uri="{FF2B5EF4-FFF2-40B4-BE49-F238E27FC236}">
+                <a16:creationId xmlns:a16="http://schemas.microsoft.com/office/drawing/2014/main" id="{6BA55068-0D64-4207-A434-FC69FC71D83A}"/>
+              </a:ext>
+            </a:extLst>
+          </p:cNvPr>
           <p:cNvSpPr>
             <a:spLocks noGrp="1"/>
           </p:cNvSpPr>
@@ -2312,7 +2410,7 @@
     </p:spTree>
     <p:extLst>
       <p:ext uri="{BB962C8B-B14F-4D97-AF65-F5344CB8AC3E}">
-        <p14:creationId xmlns:p14="http://schemas.microsoft.com/office/powerpoint/2010/main" val="2751001696"/>
+        <p14:creationId xmlns:p14="http://schemas.microsoft.com/office/powerpoint/2010/main" val="709769451"/>
       </p:ext>
     </p:extLst>
   </p:cSld>
@@ -2341,7 +2439,13 @@
       </p:grpSpPr>
       <p:sp>
         <p:nvSpPr>
-          <p:cNvPr id="2" name="Date Placeholder 1"/>
+          <p:cNvPr id="2" name="Date Placeholder 1">
+            <a:extLst>
+              <a:ext uri="{FF2B5EF4-FFF2-40B4-BE49-F238E27FC236}">
+                <a16:creationId xmlns:a16="http://schemas.microsoft.com/office/drawing/2014/main" id="{4D2A3D48-CF5C-4C5D-AC8A-378FD34506D0}"/>
+              </a:ext>
+            </a:extLst>
+          </p:cNvPr>
           <p:cNvSpPr>
             <a:spLocks noGrp="1"/>
           </p:cNvSpPr>
@@ -2356,7 +2460,7 @@
           <a:p>
             <a:fld id="{17152BCB-B62E-46E2-BD0F-7E16F5EEB3AC}" type="datetime1">
               <a:rPr lang="id-ID" smtClean="0"/>
-              <a:t>17/06/2020</a:t>
+              <a:t>18/06/2020</a:t>
             </a:fld>
             <a:endParaRPr lang="id-ID"/>
           </a:p>
@@ -2364,7 +2468,13 @@
       </p:sp>
       <p:sp>
         <p:nvSpPr>
-          <p:cNvPr id="3" name="Footer Placeholder 2"/>
+          <p:cNvPr id="3" name="Footer Placeholder 2">
+            <a:extLst>
+              <a:ext uri="{FF2B5EF4-FFF2-40B4-BE49-F238E27FC236}">
+                <a16:creationId xmlns:a16="http://schemas.microsoft.com/office/drawing/2014/main" id="{DB2857F4-A6D3-4684-81A6-697DFF35EBCD}"/>
+              </a:ext>
+            </a:extLst>
+          </p:cNvPr>
           <p:cNvSpPr>
             <a:spLocks noGrp="1"/>
           </p:cNvSpPr>
@@ -2383,7 +2493,13 @@
       </p:sp>
       <p:sp>
         <p:nvSpPr>
-          <p:cNvPr id="4" name="Slide Number Placeholder 3"/>
+          <p:cNvPr id="4" name="Slide Number Placeholder 3">
+            <a:extLst>
+              <a:ext uri="{FF2B5EF4-FFF2-40B4-BE49-F238E27FC236}">
+                <a16:creationId xmlns:a16="http://schemas.microsoft.com/office/drawing/2014/main" id="{FAC1642E-F6B5-4907-94F9-3F731830681F}"/>
+              </a:ext>
+            </a:extLst>
+          </p:cNvPr>
           <p:cNvSpPr>
             <a:spLocks noGrp="1"/>
           </p:cNvSpPr>
@@ -2407,7 +2523,7 @@
     </p:spTree>
     <p:extLst>
       <p:ext uri="{BB962C8B-B14F-4D97-AF65-F5344CB8AC3E}">
-        <p14:creationId xmlns:p14="http://schemas.microsoft.com/office/powerpoint/2010/main" val="2154373451"/>
+        <p14:creationId xmlns:p14="http://schemas.microsoft.com/office/powerpoint/2010/main" val="188627755"/>
       </p:ext>
     </p:extLst>
   </p:cSld>
@@ -2436,7 +2552,13 @@
       </p:grpSpPr>
       <p:sp>
         <p:nvSpPr>
-          <p:cNvPr id="2" name="Title 1"/>
+          <p:cNvPr id="2" name="Title 1">
+            <a:extLst>
+              <a:ext uri="{FF2B5EF4-FFF2-40B4-BE49-F238E27FC236}">
+                <a16:creationId xmlns:a16="http://schemas.microsoft.com/office/drawing/2014/main" id="{DC9F238B-F0AF-4505-A61E-2E0CE1D8AE1D}"/>
+              </a:ext>
+            </a:extLst>
+          </p:cNvPr>
           <p:cNvSpPr>
             <a:spLocks noGrp="1"/>
           </p:cNvSpPr>
@@ -2446,15 +2568,15 @@
         </p:nvSpPr>
         <p:spPr>
           <a:xfrm>
-            <a:off x="457200" y="273050"/>
-            <a:ext cx="3008313" cy="1162050"/>
+            <a:off x="629841" y="457200"/>
+            <a:ext cx="2949178" cy="1600200"/>
           </a:xfrm>
         </p:spPr>
         <p:txBody>
           <a:bodyPr anchor="b"/>
           <a:lstStyle>
-            <a:lvl1pPr algn="l">
-              <a:defRPr sz="2000" b="1"/>
+            <a:lvl1pPr>
+              <a:defRPr sz="2400"/>
             </a:lvl1pPr>
           </a:lstStyle>
           <a:p>
@@ -2468,7 +2590,13 @@
       </p:sp>
       <p:sp>
         <p:nvSpPr>
-          <p:cNvPr id="3" name="Content Placeholder 2"/>
+          <p:cNvPr id="3" name="Content Placeholder 2">
+            <a:extLst>
+              <a:ext uri="{FF2B5EF4-FFF2-40B4-BE49-F238E27FC236}">
+                <a16:creationId xmlns:a16="http://schemas.microsoft.com/office/drawing/2014/main" id="{063A8421-03A5-4983-83BC-A47CA17D1903}"/>
+              </a:ext>
+            </a:extLst>
+          </p:cNvPr>
           <p:cNvSpPr>
             <a:spLocks noGrp="1"/>
           </p:cNvSpPr>
@@ -2478,39 +2606,39 @@
         </p:nvSpPr>
         <p:spPr>
           <a:xfrm>
-            <a:off x="3575050" y="273050"/>
-            <a:ext cx="5111750" cy="5853113"/>
+            <a:off x="3887391" y="987426"/>
+            <a:ext cx="4629150" cy="4873625"/>
           </a:xfrm>
         </p:spPr>
         <p:txBody>
           <a:bodyPr/>
           <a:lstStyle>
             <a:lvl1pPr>
-              <a:defRPr sz="3200"/>
+              <a:defRPr sz="2400"/>
             </a:lvl1pPr>
             <a:lvl2pPr>
-              <a:defRPr sz="2800"/>
+              <a:defRPr sz="2100"/>
             </a:lvl2pPr>
             <a:lvl3pPr>
-              <a:defRPr sz="2400"/>
+              <a:defRPr sz="1800"/>
             </a:lvl3pPr>
             <a:lvl4pPr>
-              <a:defRPr sz="2000"/>
+              <a:defRPr sz="1500"/>
             </a:lvl4pPr>
             <a:lvl5pPr>
-              <a:defRPr sz="2000"/>
+              <a:defRPr sz="1500"/>
             </a:lvl5pPr>
             <a:lvl6pPr>
-              <a:defRPr sz="2000"/>
+              <a:defRPr sz="1500"/>
             </a:lvl6pPr>
             <a:lvl7pPr>
-              <a:defRPr sz="2000"/>
+              <a:defRPr sz="1500"/>
             </a:lvl7pPr>
             <a:lvl8pPr>
-              <a:defRPr sz="2000"/>
+              <a:defRPr sz="1500"/>
             </a:lvl8pPr>
             <a:lvl9pPr>
-              <a:defRPr sz="2000"/>
+              <a:defRPr sz="1500"/>
             </a:lvl9pPr>
           </a:lstStyle>
           <a:p>
@@ -2553,7 +2681,13 @@
       </p:sp>
       <p:sp>
         <p:nvSpPr>
-          <p:cNvPr id="4" name="Text Placeholder 3"/>
+          <p:cNvPr id="4" name="Text Placeholder 3">
+            <a:extLst>
+              <a:ext uri="{FF2B5EF4-FFF2-40B4-BE49-F238E27FC236}">
+                <a16:creationId xmlns:a16="http://schemas.microsoft.com/office/drawing/2014/main" id="{38695082-03BC-4466-B28B-52F09B820AF1}"/>
+              </a:ext>
+            </a:extLst>
+          </p:cNvPr>
           <p:cNvSpPr>
             <a:spLocks noGrp="1"/>
           </p:cNvSpPr>
@@ -2563,8 +2697,8 @@
         </p:nvSpPr>
         <p:spPr>
           <a:xfrm>
-            <a:off x="457200" y="1435100"/>
-            <a:ext cx="3008313" cy="4691063"/>
+            <a:off x="629841" y="2057400"/>
+            <a:ext cx="2949178" cy="3811588"/>
           </a:xfrm>
         </p:spPr>
         <p:txBody>
@@ -2572,39 +2706,39 @@
           <a:lstStyle>
             <a:lvl1pPr marL="0" indent="0">
               <a:buNone/>
-              <a:defRPr sz="1400"/>
+              <a:defRPr sz="1200"/>
             </a:lvl1pPr>
-            <a:lvl2pPr marL="457200" indent="0">
+            <a:lvl2pPr marL="342900" indent="0">
               <a:buNone/>
-              <a:defRPr sz="1200"/>
+              <a:defRPr sz="1050"/>
             </a:lvl2pPr>
-            <a:lvl3pPr marL="914400" indent="0">
-              <a:buNone/>
-              <a:defRPr sz="1000"/>
-            </a:lvl3pPr>
-            <a:lvl4pPr marL="1371600" indent="0">
+            <a:lvl3pPr marL="685800" indent="0">
               <a:buNone/>
               <a:defRPr sz="900"/>
+            </a:lvl3pPr>
+            <a:lvl4pPr marL="1028700" indent="0">
+              <a:buNone/>
+              <a:defRPr sz="750"/>
             </a:lvl4pPr>
-            <a:lvl5pPr marL="1828800" indent="0">
+            <a:lvl5pPr marL="1371600" indent="0">
               <a:buNone/>
-              <a:defRPr sz="900"/>
+              <a:defRPr sz="750"/>
             </a:lvl5pPr>
-            <a:lvl6pPr marL="2286000" indent="0">
+            <a:lvl6pPr marL="1714500" indent="0">
               <a:buNone/>
-              <a:defRPr sz="900"/>
+              <a:defRPr sz="750"/>
             </a:lvl6pPr>
-            <a:lvl7pPr marL="2743200" indent="0">
+            <a:lvl7pPr marL="2057400" indent="0">
               <a:buNone/>
-              <a:defRPr sz="900"/>
+              <a:defRPr sz="750"/>
             </a:lvl7pPr>
-            <a:lvl8pPr marL="3200400" indent="0">
+            <a:lvl8pPr marL="2400300" indent="0">
               <a:buNone/>
-              <a:defRPr sz="900"/>
+              <a:defRPr sz="750"/>
             </a:lvl8pPr>
-            <a:lvl9pPr marL="3657600" indent="0">
+            <a:lvl9pPr marL="2743200" indent="0">
               <a:buNone/>
-              <a:defRPr sz="900"/>
+              <a:defRPr sz="750"/>
             </a:lvl9pPr>
           </a:lstStyle>
           <a:p>
@@ -2618,7 +2752,13 @@
       </p:sp>
       <p:sp>
         <p:nvSpPr>
-          <p:cNvPr id="5" name="Date Placeholder 4"/>
+          <p:cNvPr id="5" name="Date Placeholder 4">
+            <a:extLst>
+              <a:ext uri="{FF2B5EF4-FFF2-40B4-BE49-F238E27FC236}">
+                <a16:creationId xmlns:a16="http://schemas.microsoft.com/office/drawing/2014/main" id="{A240CE21-EC12-462A-B524-702D42DA7AFE}"/>
+              </a:ext>
+            </a:extLst>
+          </p:cNvPr>
           <p:cNvSpPr>
             <a:spLocks noGrp="1"/>
           </p:cNvSpPr>
@@ -2633,7 +2773,7 @@
           <a:p>
             <a:fld id="{DB5444D9-1C33-40FC-96C1-BDE98881B8D4}" type="datetime1">
               <a:rPr lang="id-ID" smtClean="0"/>
-              <a:t>17/06/2020</a:t>
+              <a:t>18/06/2020</a:t>
             </a:fld>
             <a:endParaRPr lang="id-ID"/>
           </a:p>
@@ -2641,7 +2781,13 @@
       </p:sp>
       <p:sp>
         <p:nvSpPr>
-          <p:cNvPr id="6" name="Footer Placeholder 5"/>
+          <p:cNvPr id="6" name="Footer Placeholder 5">
+            <a:extLst>
+              <a:ext uri="{FF2B5EF4-FFF2-40B4-BE49-F238E27FC236}">
+                <a16:creationId xmlns:a16="http://schemas.microsoft.com/office/drawing/2014/main" id="{228A9CAD-F1C7-462F-8BBC-4C4C1E18E7FF}"/>
+              </a:ext>
+            </a:extLst>
+          </p:cNvPr>
           <p:cNvSpPr>
             <a:spLocks noGrp="1"/>
           </p:cNvSpPr>
@@ -2660,7 +2806,13 @@
       </p:sp>
       <p:sp>
         <p:nvSpPr>
-          <p:cNvPr id="7" name="Slide Number Placeholder 6"/>
+          <p:cNvPr id="7" name="Slide Number Placeholder 6">
+            <a:extLst>
+              <a:ext uri="{FF2B5EF4-FFF2-40B4-BE49-F238E27FC236}">
+                <a16:creationId xmlns:a16="http://schemas.microsoft.com/office/drawing/2014/main" id="{070CC2F6-9104-4C8F-A8D7-7F42EC7153A6}"/>
+              </a:ext>
+            </a:extLst>
+          </p:cNvPr>
           <p:cNvSpPr>
             <a:spLocks noGrp="1"/>
           </p:cNvSpPr>
@@ -2684,7 +2836,7 @@
     </p:spTree>
     <p:extLst>
       <p:ext uri="{BB962C8B-B14F-4D97-AF65-F5344CB8AC3E}">
-        <p14:creationId xmlns:p14="http://schemas.microsoft.com/office/powerpoint/2010/main" val="681081437"/>
+        <p14:creationId xmlns:p14="http://schemas.microsoft.com/office/powerpoint/2010/main" val="4136838757"/>
       </p:ext>
     </p:extLst>
   </p:cSld>
@@ -2713,7 +2865,13 @@
       </p:grpSpPr>
       <p:sp>
         <p:nvSpPr>
-          <p:cNvPr id="2" name="Title 1"/>
+          <p:cNvPr id="2" name="Title 1">
+            <a:extLst>
+              <a:ext uri="{FF2B5EF4-FFF2-40B4-BE49-F238E27FC236}">
+                <a16:creationId xmlns:a16="http://schemas.microsoft.com/office/drawing/2014/main" id="{AC7B15B3-E5F3-4660-8AFB-6A3F1D828937}"/>
+              </a:ext>
+            </a:extLst>
+          </p:cNvPr>
           <p:cNvSpPr>
             <a:spLocks noGrp="1"/>
           </p:cNvSpPr>
@@ -2723,15 +2881,15 @@
         </p:nvSpPr>
         <p:spPr>
           <a:xfrm>
-            <a:off x="1792288" y="4800600"/>
-            <a:ext cx="5486400" cy="566738"/>
+            <a:off x="629841" y="457200"/>
+            <a:ext cx="2949178" cy="1600200"/>
           </a:xfrm>
         </p:spPr>
         <p:txBody>
           <a:bodyPr anchor="b"/>
           <a:lstStyle>
-            <a:lvl1pPr algn="l">
-              <a:defRPr sz="2000" b="1"/>
+            <a:lvl1pPr>
+              <a:defRPr sz="2400"/>
             </a:lvl1pPr>
           </a:lstStyle>
           <a:p>
@@ -2745,7 +2903,13 @@
       </p:sp>
       <p:sp>
         <p:nvSpPr>
-          <p:cNvPr id="3" name="Picture Placeholder 2"/>
+          <p:cNvPr id="3" name="Picture Placeholder 2">
+            <a:extLst>
+              <a:ext uri="{FF2B5EF4-FFF2-40B4-BE49-F238E27FC236}">
+                <a16:creationId xmlns:a16="http://schemas.microsoft.com/office/drawing/2014/main" id="{2C3B45DB-A054-42B8-9C34-63AB9D9B4D59}"/>
+              </a:ext>
+            </a:extLst>
+          </p:cNvPr>
           <p:cNvSpPr>
             <a:spLocks noGrp="1"/>
           </p:cNvSpPr>
@@ -2755,8 +2919,8 @@
         </p:nvSpPr>
         <p:spPr>
           <a:xfrm>
-            <a:off x="1792288" y="612775"/>
-            <a:ext cx="5486400" cy="4114800"/>
+            <a:off x="3887391" y="987426"/>
+            <a:ext cx="4629150" cy="4873625"/>
           </a:xfrm>
         </p:spPr>
         <p:txBody>
@@ -2764,39 +2928,39 @@
           <a:lstStyle>
             <a:lvl1pPr marL="0" indent="0">
               <a:buNone/>
-              <a:defRPr sz="3200"/>
+              <a:defRPr sz="2400"/>
             </a:lvl1pPr>
-            <a:lvl2pPr marL="457200" indent="0">
+            <a:lvl2pPr marL="342900" indent="0">
               <a:buNone/>
-              <a:defRPr sz="2800"/>
+              <a:defRPr sz="2100"/>
             </a:lvl2pPr>
-            <a:lvl3pPr marL="914400" indent="0">
+            <a:lvl3pPr marL="685800" indent="0">
               <a:buNone/>
-              <a:defRPr sz="2400"/>
+              <a:defRPr sz="1800"/>
             </a:lvl3pPr>
-            <a:lvl4pPr marL="1371600" indent="0">
+            <a:lvl4pPr marL="1028700" indent="0">
               <a:buNone/>
-              <a:defRPr sz="2000"/>
+              <a:defRPr sz="1500"/>
             </a:lvl4pPr>
-            <a:lvl5pPr marL="1828800" indent="0">
+            <a:lvl5pPr marL="1371600" indent="0">
               <a:buNone/>
-              <a:defRPr sz="2000"/>
+              <a:defRPr sz="1500"/>
             </a:lvl5pPr>
-            <a:lvl6pPr marL="2286000" indent="0">
+            <a:lvl6pPr marL="1714500" indent="0">
               <a:buNone/>
-              <a:defRPr sz="2000"/>
+              <a:defRPr sz="1500"/>
             </a:lvl6pPr>
-            <a:lvl7pPr marL="2743200" indent="0">
+            <a:lvl7pPr marL="2057400" indent="0">
               <a:buNone/>
-              <a:defRPr sz="2000"/>
+              <a:defRPr sz="1500"/>
             </a:lvl7pPr>
-            <a:lvl8pPr marL="3200400" indent="0">
+            <a:lvl8pPr marL="2400300" indent="0">
               <a:buNone/>
-              <a:defRPr sz="2000"/>
+              <a:defRPr sz="1500"/>
             </a:lvl8pPr>
-            <a:lvl9pPr marL="3657600" indent="0">
+            <a:lvl9pPr marL="2743200" indent="0">
               <a:buNone/>
-              <a:defRPr sz="2000"/>
+              <a:defRPr sz="1500"/>
             </a:lvl9pPr>
           </a:lstStyle>
           <a:p>
@@ -2806,7 +2970,13 @@
       </p:sp>
       <p:sp>
         <p:nvSpPr>
-          <p:cNvPr id="4" name="Text Placeholder 3"/>
+          <p:cNvPr id="4" name="Text Placeholder 3">
+            <a:extLst>
+              <a:ext uri="{FF2B5EF4-FFF2-40B4-BE49-F238E27FC236}">
+                <a16:creationId xmlns:a16="http://schemas.microsoft.com/office/drawing/2014/main" id="{8155061F-B48A-4B8E-ACE7-4A2B5451DF34}"/>
+              </a:ext>
+            </a:extLst>
+          </p:cNvPr>
           <p:cNvSpPr>
             <a:spLocks noGrp="1"/>
           </p:cNvSpPr>
@@ -2816,8 +2986,8 @@
         </p:nvSpPr>
         <p:spPr>
           <a:xfrm>
-            <a:off x="1792288" y="5367338"/>
-            <a:ext cx="5486400" cy="804862"/>
+            <a:off x="629841" y="2057400"/>
+            <a:ext cx="2949178" cy="3811588"/>
           </a:xfrm>
         </p:spPr>
         <p:txBody>
@@ -2825,39 +2995,39 @@
           <a:lstStyle>
             <a:lvl1pPr marL="0" indent="0">
               <a:buNone/>
-              <a:defRPr sz="1400"/>
+              <a:defRPr sz="1200"/>
             </a:lvl1pPr>
-            <a:lvl2pPr marL="457200" indent="0">
+            <a:lvl2pPr marL="342900" indent="0">
               <a:buNone/>
-              <a:defRPr sz="1200"/>
+              <a:defRPr sz="1050"/>
             </a:lvl2pPr>
-            <a:lvl3pPr marL="914400" indent="0">
-              <a:buNone/>
-              <a:defRPr sz="1000"/>
-            </a:lvl3pPr>
-            <a:lvl4pPr marL="1371600" indent="0">
+            <a:lvl3pPr marL="685800" indent="0">
               <a:buNone/>
               <a:defRPr sz="900"/>
+            </a:lvl3pPr>
+            <a:lvl4pPr marL="1028700" indent="0">
+              <a:buNone/>
+              <a:defRPr sz="750"/>
             </a:lvl4pPr>
-            <a:lvl5pPr marL="1828800" indent="0">
+            <a:lvl5pPr marL="1371600" indent="0">
               <a:buNone/>
-              <a:defRPr sz="900"/>
+              <a:defRPr sz="750"/>
             </a:lvl5pPr>
-            <a:lvl6pPr marL="2286000" indent="0">
+            <a:lvl6pPr marL="1714500" indent="0">
               <a:buNone/>
-              <a:defRPr sz="900"/>
+              <a:defRPr sz="750"/>
             </a:lvl6pPr>
-            <a:lvl7pPr marL="2743200" indent="0">
+            <a:lvl7pPr marL="2057400" indent="0">
               <a:buNone/>
-              <a:defRPr sz="900"/>
+              <a:defRPr sz="750"/>
             </a:lvl7pPr>
-            <a:lvl8pPr marL="3200400" indent="0">
+            <a:lvl8pPr marL="2400300" indent="0">
               <a:buNone/>
-              <a:defRPr sz="900"/>
+              <a:defRPr sz="750"/>
             </a:lvl8pPr>
-            <a:lvl9pPr marL="3657600" indent="0">
+            <a:lvl9pPr marL="2743200" indent="0">
               <a:buNone/>
-              <a:defRPr sz="900"/>
+              <a:defRPr sz="750"/>
             </a:lvl9pPr>
           </a:lstStyle>
           <a:p>
@@ -2871,7 +3041,13 @@
       </p:sp>
       <p:sp>
         <p:nvSpPr>
-          <p:cNvPr id="5" name="Date Placeholder 4"/>
+          <p:cNvPr id="5" name="Date Placeholder 4">
+            <a:extLst>
+              <a:ext uri="{FF2B5EF4-FFF2-40B4-BE49-F238E27FC236}">
+                <a16:creationId xmlns:a16="http://schemas.microsoft.com/office/drawing/2014/main" id="{E4EF03C0-FC6D-436C-984E-E15FEB092539}"/>
+              </a:ext>
+            </a:extLst>
+          </p:cNvPr>
           <p:cNvSpPr>
             <a:spLocks noGrp="1"/>
           </p:cNvSpPr>
@@ -2886,7 +3062,7 @@
           <a:p>
             <a:fld id="{AD1C5256-660B-4989-84EC-CE67CE4F7551}" type="datetime1">
               <a:rPr lang="id-ID" smtClean="0"/>
-              <a:t>17/06/2020</a:t>
+              <a:t>18/06/2020</a:t>
             </a:fld>
             <a:endParaRPr lang="id-ID"/>
           </a:p>
@@ -2894,7 +3070,13 @@
       </p:sp>
       <p:sp>
         <p:nvSpPr>
-          <p:cNvPr id="6" name="Footer Placeholder 5"/>
+          <p:cNvPr id="6" name="Footer Placeholder 5">
+            <a:extLst>
+              <a:ext uri="{FF2B5EF4-FFF2-40B4-BE49-F238E27FC236}">
+                <a16:creationId xmlns:a16="http://schemas.microsoft.com/office/drawing/2014/main" id="{1202E8A9-F1A6-42A4-B4A8-90CFCE9F9956}"/>
+              </a:ext>
+            </a:extLst>
+          </p:cNvPr>
           <p:cNvSpPr>
             <a:spLocks noGrp="1"/>
           </p:cNvSpPr>
@@ -2913,7 +3095,13 @@
       </p:sp>
       <p:sp>
         <p:nvSpPr>
-          <p:cNvPr id="7" name="Slide Number Placeholder 6"/>
+          <p:cNvPr id="7" name="Slide Number Placeholder 6">
+            <a:extLst>
+              <a:ext uri="{FF2B5EF4-FFF2-40B4-BE49-F238E27FC236}">
+                <a16:creationId xmlns:a16="http://schemas.microsoft.com/office/drawing/2014/main" id="{F6FFB1DD-0EDF-4199-B858-9F87934ED700}"/>
+              </a:ext>
+            </a:extLst>
+          </p:cNvPr>
           <p:cNvSpPr>
             <a:spLocks noGrp="1"/>
           </p:cNvSpPr>
@@ -2937,7 +3125,7 @@
     </p:spTree>
     <p:extLst>
       <p:ext uri="{BB962C8B-B14F-4D97-AF65-F5344CB8AC3E}">
-        <p14:creationId xmlns:p14="http://schemas.microsoft.com/office/powerpoint/2010/main" val="1494544016"/>
+        <p14:creationId xmlns:p14="http://schemas.microsoft.com/office/powerpoint/2010/main" val="1963936162"/>
       </p:ext>
     </p:extLst>
   </p:cSld>
@@ -2971,7 +3159,13 @@
       </p:grpSpPr>
       <p:sp>
         <p:nvSpPr>
-          <p:cNvPr id="2" name="Title Placeholder 1"/>
+          <p:cNvPr id="2" name="Title Placeholder 1">
+            <a:extLst>
+              <a:ext uri="{FF2B5EF4-FFF2-40B4-BE49-F238E27FC236}">
+                <a16:creationId xmlns:a16="http://schemas.microsoft.com/office/drawing/2014/main" id="{E12E3B2B-13B4-4B6F-8F71-A639023242B7}"/>
+              </a:ext>
+            </a:extLst>
+          </p:cNvPr>
           <p:cNvSpPr>
             <a:spLocks noGrp="1"/>
           </p:cNvSpPr>
@@ -2981,8 +3175,8 @@
         </p:nvSpPr>
         <p:spPr>
           <a:xfrm>
-            <a:off x="457200" y="274638"/>
-            <a:ext cx="8229600" cy="1143000"/>
+            <a:off x="628650" y="365126"/>
+            <a:ext cx="7886700" cy="1325563"/>
           </a:xfrm>
           <a:prstGeom prst="rect">
             <a:avLst/>
@@ -3004,7 +3198,13 @@
       </p:sp>
       <p:sp>
         <p:nvSpPr>
-          <p:cNvPr id="3" name="Text Placeholder 2"/>
+          <p:cNvPr id="3" name="Text Placeholder 2">
+            <a:extLst>
+              <a:ext uri="{FF2B5EF4-FFF2-40B4-BE49-F238E27FC236}">
+                <a16:creationId xmlns:a16="http://schemas.microsoft.com/office/drawing/2014/main" id="{8AE34797-A2DB-4686-AC64-B7252566054F}"/>
+              </a:ext>
+            </a:extLst>
+          </p:cNvPr>
           <p:cNvSpPr>
             <a:spLocks noGrp="1"/>
           </p:cNvSpPr>
@@ -3014,8 +3214,8 @@
         </p:nvSpPr>
         <p:spPr>
           <a:xfrm>
-            <a:off x="457200" y="1600200"/>
-            <a:ext cx="8229600" cy="4525963"/>
+            <a:off x="628650" y="1825625"/>
+            <a:ext cx="7886700" cy="4351338"/>
           </a:xfrm>
           <a:prstGeom prst="rect">
             <a:avLst/>
@@ -3066,7 +3266,13 @@
       </p:sp>
       <p:sp>
         <p:nvSpPr>
-          <p:cNvPr id="4" name="Date Placeholder 3"/>
+          <p:cNvPr id="4" name="Date Placeholder 3">
+            <a:extLst>
+              <a:ext uri="{FF2B5EF4-FFF2-40B4-BE49-F238E27FC236}">
+                <a16:creationId xmlns:a16="http://schemas.microsoft.com/office/drawing/2014/main" id="{29D3EF9B-DC2A-46C2-A48F-65623EE51F92}"/>
+              </a:ext>
+            </a:extLst>
+          </p:cNvPr>
           <p:cNvSpPr>
             <a:spLocks noGrp="1"/>
           </p:cNvSpPr>
@@ -3076,8 +3282,8 @@
         </p:nvSpPr>
         <p:spPr>
           <a:xfrm>
-            <a:off x="457200" y="6356350"/>
-            <a:ext cx="2133600" cy="365125"/>
+            <a:off x="628650" y="6356351"/>
+            <a:ext cx="2057400" cy="365125"/>
           </a:xfrm>
           <a:prstGeom prst="rect">
             <a:avLst/>
@@ -3087,7 +3293,7 @@
           <a:bodyPr vert="horz" lIns="91440" tIns="45720" rIns="91440" bIns="45720" rtlCol="0" anchor="ctr"/>
           <a:lstStyle>
             <a:lvl1pPr algn="l">
-              <a:defRPr sz="1200">
+              <a:defRPr sz="900">
                 <a:solidFill>
                   <a:schemeClr val="tx1">
                     <a:tint val="75000"/>
@@ -3099,7 +3305,7 @@
           <a:p>
             <a:fld id="{508825A0-EDD3-4F4D-9FB7-9573B5EAB38C}" type="datetime1">
               <a:rPr lang="id-ID" smtClean="0"/>
-              <a:t>17/06/2020</a:t>
+              <a:t>18/06/2020</a:t>
             </a:fld>
             <a:endParaRPr lang="id-ID"/>
           </a:p>
@@ -3107,7 +3313,13 @@
       </p:sp>
       <p:sp>
         <p:nvSpPr>
-          <p:cNvPr id="5" name="Footer Placeholder 4"/>
+          <p:cNvPr id="5" name="Footer Placeholder 4">
+            <a:extLst>
+              <a:ext uri="{FF2B5EF4-FFF2-40B4-BE49-F238E27FC236}">
+                <a16:creationId xmlns:a16="http://schemas.microsoft.com/office/drawing/2014/main" id="{F5288D7F-2ED9-4C36-A1E8-B25994B5BFFD}"/>
+              </a:ext>
+            </a:extLst>
+          </p:cNvPr>
           <p:cNvSpPr>
             <a:spLocks noGrp="1"/>
           </p:cNvSpPr>
@@ -3117,8 +3329,8 @@
         </p:nvSpPr>
         <p:spPr>
           <a:xfrm>
-            <a:off x="3124200" y="6356350"/>
-            <a:ext cx="2895600" cy="365125"/>
+            <a:off x="3028950" y="6356351"/>
+            <a:ext cx="3086100" cy="365125"/>
           </a:xfrm>
           <a:prstGeom prst="rect">
             <a:avLst/>
@@ -3128,7 +3340,7 @@
           <a:bodyPr vert="horz" lIns="91440" tIns="45720" rIns="91440" bIns="45720" rtlCol="0" anchor="ctr"/>
           <a:lstStyle>
             <a:lvl1pPr algn="ctr">
-              <a:defRPr sz="1200">
+              <a:defRPr sz="900">
                 <a:solidFill>
                   <a:schemeClr val="tx1">
                     <a:tint val="75000"/>
@@ -3144,7 +3356,13 @@
       </p:sp>
       <p:sp>
         <p:nvSpPr>
-          <p:cNvPr id="6" name="Slide Number Placeholder 5"/>
+          <p:cNvPr id="6" name="Slide Number Placeholder 5">
+            <a:extLst>
+              <a:ext uri="{FF2B5EF4-FFF2-40B4-BE49-F238E27FC236}">
+                <a16:creationId xmlns:a16="http://schemas.microsoft.com/office/drawing/2014/main" id="{74CD3294-A952-4A59-BC8E-8D7827E60DFD}"/>
+              </a:ext>
+            </a:extLst>
+          </p:cNvPr>
           <p:cNvSpPr>
             <a:spLocks noGrp="1"/>
           </p:cNvSpPr>
@@ -3154,8 +3372,8 @@
         </p:nvSpPr>
         <p:spPr>
           <a:xfrm>
-            <a:off x="6553200" y="6356350"/>
-            <a:ext cx="2133600" cy="365125"/>
+            <a:off x="6457950" y="6356351"/>
+            <a:ext cx="2057400" cy="365125"/>
           </a:xfrm>
           <a:prstGeom prst="rect">
             <a:avLst/>
@@ -3165,7 +3383,7 @@
           <a:bodyPr vert="horz" lIns="91440" tIns="45720" rIns="91440" bIns="45720" rtlCol="0" anchor="ctr"/>
           <a:lstStyle>
             <a:lvl1pPr algn="r">
-              <a:defRPr sz="1200">
+              <a:defRPr sz="900">
                 <a:solidFill>
                   <a:schemeClr val="tx1">
                     <a:tint val="75000"/>
@@ -3186,33 +3404,36 @@
     </p:spTree>
     <p:extLst>
       <p:ext uri="{BB962C8B-B14F-4D97-AF65-F5344CB8AC3E}">
-        <p14:creationId xmlns:p14="http://schemas.microsoft.com/office/powerpoint/2010/main" val="4149857363"/>
+        <p14:creationId xmlns:p14="http://schemas.microsoft.com/office/powerpoint/2010/main" val="1896369182"/>
       </p:ext>
     </p:extLst>
   </p:cSld>
   <p:clrMap bg1="lt1" tx1="dk1" bg2="lt2" tx2="dk2" accent1="accent1" accent2="accent2" accent3="accent3" accent4="accent4" accent5="accent5" accent6="accent6" hlink="hlink" folHlink="folHlink"/>
   <p:sldLayoutIdLst>
-    <p:sldLayoutId id="2147483649" r:id="rId1"/>
-    <p:sldLayoutId id="2147483650" r:id="rId2"/>
-    <p:sldLayoutId id="2147483651" r:id="rId3"/>
-    <p:sldLayoutId id="2147483652" r:id="rId4"/>
-    <p:sldLayoutId id="2147483653" r:id="rId5"/>
-    <p:sldLayoutId id="2147483654" r:id="rId6"/>
-    <p:sldLayoutId id="2147483655" r:id="rId7"/>
-    <p:sldLayoutId id="2147483656" r:id="rId8"/>
-    <p:sldLayoutId id="2147483657" r:id="rId9"/>
-    <p:sldLayoutId id="2147483658" r:id="rId10"/>
-    <p:sldLayoutId id="2147483659" r:id="rId11"/>
+    <p:sldLayoutId id="2147483709" r:id="rId1"/>
+    <p:sldLayoutId id="2147483710" r:id="rId2"/>
+    <p:sldLayoutId id="2147483711" r:id="rId3"/>
+    <p:sldLayoutId id="2147483712" r:id="rId4"/>
+    <p:sldLayoutId id="2147483713" r:id="rId5"/>
+    <p:sldLayoutId id="2147483714" r:id="rId6"/>
+    <p:sldLayoutId id="2147483715" r:id="rId7"/>
+    <p:sldLayoutId id="2147483716" r:id="rId8"/>
+    <p:sldLayoutId id="2147483717" r:id="rId9"/>
+    <p:sldLayoutId id="2147483718" r:id="rId10"/>
+    <p:sldLayoutId id="2147483719" r:id="rId11"/>
   </p:sldLayoutIdLst>
   <p:hf hdr="0" ftr="0" dt="0"/>
   <p:txStyles>
     <p:titleStyle>
-      <a:lvl1pPr algn="ctr" defTabSz="914400" rtl="0" eaLnBrk="1" latinLnBrk="0" hangingPunct="1">
+      <a:lvl1pPr algn="l" defTabSz="685800" rtl="0" eaLnBrk="1" latinLnBrk="0" hangingPunct="1">
+        <a:lnSpc>
+          <a:spcPct val="90000"/>
+        </a:lnSpc>
         <a:spcBef>
           <a:spcPct val="0"/>
         </a:spcBef>
         <a:buNone/>
-        <a:defRPr sz="4400" kern="1200">
+        <a:defRPr sz="3300" kern="1200">
           <a:solidFill>
             <a:schemeClr val="tx1"/>
           </a:solidFill>
@@ -3223,13 +3444,16 @@
       </a:lvl1pPr>
     </p:titleStyle>
     <p:bodyStyle>
-      <a:lvl1pPr marL="342900" indent="-342900" algn="l" defTabSz="914400" rtl="0" eaLnBrk="1" latinLnBrk="0" hangingPunct="1">
+      <a:lvl1pPr marL="171450" indent="-171450" algn="l" defTabSz="685800" rtl="0" eaLnBrk="1" latinLnBrk="0" hangingPunct="1">
+        <a:lnSpc>
+          <a:spcPct val="90000"/>
+        </a:lnSpc>
         <a:spcBef>
-          <a:spcPct val="20000"/>
+          <a:spcPts val="750"/>
         </a:spcBef>
         <a:buFont typeface="Arial" panose="020B0604020202020204" pitchFamily="34" charset="0"/>
         <a:buChar char="•"/>
-        <a:defRPr sz="3200" kern="1200">
+        <a:defRPr sz="2100" kern="1200">
           <a:solidFill>
             <a:schemeClr val="tx1"/>
           </a:solidFill>
@@ -3238,13 +3462,16 @@
           <a:cs typeface="+mn-cs"/>
         </a:defRPr>
       </a:lvl1pPr>
-      <a:lvl2pPr marL="742950" indent="-285750" algn="l" defTabSz="914400" rtl="0" eaLnBrk="1" latinLnBrk="0" hangingPunct="1">
+      <a:lvl2pPr marL="514350" indent="-171450" algn="l" defTabSz="685800" rtl="0" eaLnBrk="1" latinLnBrk="0" hangingPunct="1">
+        <a:lnSpc>
+          <a:spcPct val="90000"/>
+        </a:lnSpc>
         <a:spcBef>
-          <a:spcPct val="20000"/>
+          <a:spcPts val="375"/>
         </a:spcBef>
         <a:buFont typeface="Arial" panose="020B0604020202020204" pitchFamily="34" charset="0"/>
-        <a:buChar char="–"/>
-        <a:defRPr sz="2800" kern="1200">
+        <a:buChar char="•"/>
+        <a:defRPr sz="1800" kern="1200">
           <a:solidFill>
             <a:schemeClr val="tx1"/>
           </a:solidFill>
@@ -3253,13 +3480,16 @@
           <a:cs typeface="+mn-cs"/>
         </a:defRPr>
       </a:lvl2pPr>
-      <a:lvl3pPr marL="1143000" indent="-228600" algn="l" defTabSz="914400" rtl="0" eaLnBrk="1" latinLnBrk="0" hangingPunct="1">
+      <a:lvl3pPr marL="857250" indent="-171450" algn="l" defTabSz="685800" rtl="0" eaLnBrk="1" latinLnBrk="0" hangingPunct="1">
+        <a:lnSpc>
+          <a:spcPct val="90000"/>
+        </a:lnSpc>
         <a:spcBef>
-          <a:spcPct val="20000"/>
+          <a:spcPts val="375"/>
         </a:spcBef>
         <a:buFont typeface="Arial" panose="020B0604020202020204" pitchFamily="34" charset="0"/>
         <a:buChar char="•"/>
-        <a:defRPr sz="2400" kern="1200">
+        <a:defRPr sz="1500" kern="1200">
           <a:solidFill>
             <a:schemeClr val="tx1"/>
           </a:solidFill>
@@ -3268,13 +3498,16 @@
           <a:cs typeface="+mn-cs"/>
         </a:defRPr>
       </a:lvl3pPr>
-      <a:lvl4pPr marL="1600200" indent="-228600" algn="l" defTabSz="914400" rtl="0" eaLnBrk="1" latinLnBrk="0" hangingPunct="1">
+      <a:lvl4pPr marL="1200150" indent="-171450" algn="l" defTabSz="685800" rtl="0" eaLnBrk="1" latinLnBrk="0" hangingPunct="1">
+        <a:lnSpc>
+          <a:spcPct val="90000"/>
+        </a:lnSpc>
         <a:spcBef>
-          <a:spcPct val="20000"/>
+          <a:spcPts val="375"/>
         </a:spcBef>
         <a:buFont typeface="Arial" panose="020B0604020202020204" pitchFamily="34" charset="0"/>
-        <a:buChar char="–"/>
-        <a:defRPr sz="2000" kern="1200">
+        <a:buChar char="•"/>
+        <a:defRPr sz="1350" kern="1200">
           <a:solidFill>
             <a:schemeClr val="tx1"/>
           </a:solidFill>
@@ -3283,13 +3516,16 @@
           <a:cs typeface="+mn-cs"/>
         </a:defRPr>
       </a:lvl4pPr>
-      <a:lvl5pPr marL="2057400" indent="-228600" algn="l" defTabSz="914400" rtl="0" eaLnBrk="1" latinLnBrk="0" hangingPunct="1">
+      <a:lvl5pPr marL="1543050" indent="-171450" algn="l" defTabSz="685800" rtl="0" eaLnBrk="1" latinLnBrk="0" hangingPunct="1">
+        <a:lnSpc>
+          <a:spcPct val="90000"/>
+        </a:lnSpc>
         <a:spcBef>
-          <a:spcPct val="20000"/>
+          <a:spcPts val="375"/>
         </a:spcBef>
         <a:buFont typeface="Arial" panose="020B0604020202020204" pitchFamily="34" charset="0"/>
-        <a:buChar char="»"/>
-        <a:defRPr sz="2000" kern="1200">
+        <a:buChar char="•"/>
+        <a:defRPr sz="1350" kern="1200">
           <a:solidFill>
             <a:schemeClr val="tx1"/>
           </a:solidFill>
@@ -3298,13 +3534,16 @@
           <a:cs typeface="+mn-cs"/>
         </a:defRPr>
       </a:lvl5pPr>
-      <a:lvl6pPr marL="2514600" indent="-228600" algn="l" defTabSz="914400" rtl="0" eaLnBrk="1" latinLnBrk="0" hangingPunct="1">
+      <a:lvl6pPr marL="1885950" indent="-171450" algn="l" defTabSz="685800" rtl="0" eaLnBrk="1" latinLnBrk="0" hangingPunct="1">
+        <a:lnSpc>
+          <a:spcPct val="90000"/>
+        </a:lnSpc>
         <a:spcBef>
-          <a:spcPct val="20000"/>
+          <a:spcPts val="375"/>
         </a:spcBef>
         <a:buFont typeface="Arial" panose="020B0604020202020204" pitchFamily="34" charset="0"/>
         <a:buChar char="•"/>
-        <a:defRPr sz="2000" kern="1200">
+        <a:defRPr sz="1350" kern="1200">
           <a:solidFill>
             <a:schemeClr val="tx1"/>
           </a:solidFill>
@@ -3313,13 +3552,16 @@
           <a:cs typeface="+mn-cs"/>
         </a:defRPr>
       </a:lvl6pPr>
-      <a:lvl7pPr marL="2971800" indent="-228600" algn="l" defTabSz="914400" rtl="0" eaLnBrk="1" latinLnBrk="0" hangingPunct="1">
+      <a:lvl7pPr marL="2228850" indent="-171450" algn="l" defTabSz="685800" rtl="0" eaLnBrk="1" latinLnBrk="0" hangingPunct="1">
+        <a:lnSpc>
+          <a:spcPct val="90000"/>
+        </a:lnSpc>
         <a:spcBef>
-          <a:spcPct val="20000"/>
+          <a:spcPts val="375"/>
         </a:spcBef>
         <a:buFont typeface="Arial" panose="020B0604020202020204" pitchFamily="34" charset="0"/>
         <a:buChar char="•"/>
-        <a:defRPr sz="2000" kern="1200">
+        <a:defRPr sz="1350" kern="1200">
           <a:solidFill>
             <a:schemeClr val="tx1"/>
           </a:solidFill>
@@ -3328,13 +3570,16 @@
           <a:cs typeface="+mn-cs"/>
         </a:defRPr>
       </a:lvl7pPr>
-      <a:lvl8pPr marL="3429000" indent="-228600" algn="l" defTabSz="914400" rtl="0" eaLnBrk="1" latinLnBrk="0" hangingPunct="1">
+      <a:lvl8pPr marL="2571750" indent="-171450" algn="l" defTabSz="685800" rtl="0" eaLnBrk="1" latinLnBrk="0" hangingPunct="1">
+        <a:lnSpc>
+          <a:spcPct val="90000"/>
+        </a:lnSpc>
         <a:spcBef>
-          <a:spcPct val="20000"/>
+          <a:spcPts val="375"/>
         </a:spcBef>
         <a:buFont typeface="Arial" panose="020B0604020202020204" pitchFamily="34" charset="0"/>
         <a:buChar char="•"/>
-        <a:defRPr sz="2000" kern="1200">
+        <a:defRPr sz="1350" kern="1200">
           <a:solidFill>
             <a:schemeClr val="tx1"/>
           </a:solidFill>
@@ -3343,13 +3588,16 @@
           <a:cs typeface="+mn-cs"/>
         </a:defRPr>
       </a:lvl8pPr>
-      <a:lvl9pPr marL="3886200" indent="-228600" algn="l" defTabSz="914400" rtl="0" eaLnBrk="1" latinLnBrk="0" hangingPunct="1">
+      <a:lvl9pPr marL="2914650" indent="-171450" algn="l" defTabSz="685800" rtl="0" eaLnBrk="1" latinLnBrk="0" hangingPunct="1">
+        <a:lnSpc>
+          <a:spcPct val="90000"/>
+        </a:lnSpc>
         <a:spcBef>
-          <a:spcPct val="20000"/>
+          <a:spcPts val="375"/>
         </a:spcBef>
         <a:buFont typeface="Arial" panose="020B0604020202020204" pitchFamily="34" charset="0"/>
         <a:buChar char="•"/>
-        <a:defRPr sz="2000" kern="1200">
+        <a:defRPr sz="1350" kern="1200">
           <a:solidFill>
             <a:schemeClr val="tx1"/>
           </a:solidFill>
@@ -3363,8 +3611,8 @@
       <a:defPPr>
         <a:defRPr lang="id-ID"/>
       </a:defPPr>
-      <a:lvl1pPr marL="0" algn="l" defTabSz="914400" rtl="0" eaLnBrk="1" latinLnBrk="0" hangingPunct="1">
-        <a:defRPr sz="1800" kern="1200">
+      <a:lvl1pPr marL="0" algn="l" defTabSz="685800" rtl="0" eaLnBrk="1" latinLnBrk="0" hangingPunct="1">
+        <a:defRPr sz="1350" kern="1200">
           <a:solidFill>
             <a:schemeClr val="tx1"/>
           </a:solidFill>
@@ -3373,8 +3621,8 @@
           <a:cs typeface="+mn-cs"/>
         </a:defRPr>
       </a:lvl1pPr>
-      <a:lvl2pPr marL="457200" algn="l" defTabSz="914400" rtl="0" eaLnBrk="1" latinLnBrk="0" hangingPunct="1">
-        <a:defRPr sz="1800" kern="1200">
+      <a:lvl2pPr marL="342900" algn="l" defTabSz="685800" rtl="0" eaLnBrk="1" latinLnBrk="0" hangingPunct="1">
+        <a:defRPr sz="1350" kern="1200">
           <a:solidFill>
             <a:schemeClr val="tx1"/>
           </a:solidFill>
@@ -3383,8 +3631,8 @@
           <a:cs typeface="+mn-cs"/>
         </a:defRPr>
       </a:lvl2pPr>
-      <a:lvl3pPr marL="914400" algn="l" defTabSz="914400" rtl="0" eaLnBrk="1" latinLnBrk="0" hangingPunct="1">
-        <a:defRPr sz="1800" kern="1200">
+      <a:lvl3pPr marL="685800" algn="l" defTabSz="685800" rtl="0" eaLnBrk="1" latinLnBrk="0" hangingPunct="1">
+        <a:defRPr sz="1350" kern="1200">
           <a:solidFill>
             <a:schemeClr val="tx1"/>
           </a:solidFill>
@@ -3393,8 +3641,8 @@
           <a:cs typeface="+mn-cs"/>
         </a:defRPr>
       </a:lvl3pPr>
-      <a:lvl4pPr marL="1371600" algn="l" defTabSz="914400" rtl="0" eaLnBrk="1" latinLnBrk="0" hangingPunct="1">
-        <a:defRPr sz="1800" kern="1200">
+      <a:lvl4pPr marL="1028700" algn="l" defTabSz="685800" rtl="0" eaLnBrk="1" latinLnBrk="0" hangingPunct="1">
+        <a:defRPr sz="1350" kern="1200">
           <a:solidFill>
             <a:schemeClr val="tx1"/>
           </a:solidFill>
@@ -3403,8 +3651,8 @@
           <a:cs typeface="+mn-cs"/>
         </a:defRPr>
       </a:lvl4pPr>
-      <a:lvl5pPr marL="1828800" algn="l" defTabSz="914400" rtl="0" eaLnBrk="1" latinLnBrk="0" hangingPunct="1">
-        <a:defRPr sz="1800" kern="1200">
+      <a:lvl5pPr marL="1371600" algn="l" defTabSz="685800" rtl="0" eaLnBrk="1" latinLnBrk="0" hangingPunct="1">
+        <a:defRPr sz="1350" kern="1200">
           <a:solidFill>
             <a:schemeClr val="tx1"/>
           </a:solidFill>
@@ -3413,8 +3661,8 @@
           <a:cs typeface="+mn-cs"/>
         </a:defRPr>
       </a:lvl5pPr>
-      <a:lvl6pPr marL="2286000" algn="l" defTabSz="914400" rtl="0" eaLnBrk="1" latinLnBrk="0" hangingPunct="1">
-        <a:defRPr sz="1800" kern="1200">
+      <a:lvl6pPr marL="1714500" algn="l" defTabSz="685800" rtl="0" eaLnBrk="1" latinLnBrk="0" hangingPunct="1">
+        <a:defRPr sz="1350" kern="1200">
           <a:solidFill>
             <a:schemeClr val="tx1"/>
           </a:solidFill>
@@ -3423,8 +3671,8 @@
           <a:cs typeface="+mn-cs"/>
         </a:defRPr>
       </a:lvl6pPr>
-      <a:lvl7pPr marL="2743200" algn="l" defTabSz="914400" rtl="0" eaLnBrk="1" latinLnBrk="0" hangingPunct="1">
-        <a:defRPr sz="1800" kern="1200">
+      <a:lvl7pPr marL="2057400" algn="l" defTabSz="685800" rtl="0" eaLnBrk="1" latinLnBrk="0" hangingPunct="1">
+        <a:defRPr sz="1350" kern="1200">
           <a:solidFill>
             <a:schemeClr val="tx1"/>
           </a:solidFill>
@@ -3433,8 +3681,8 @@
           <a:cs typeface="+mn-cs"/>
         </a:defRPr>
       </a:lvl7pPr>
-      <a:lvl8pPr marL="3200400" algn="l" defTabSz="914400" rtl="0" eaLnBrk="1" latinLnBrk="0" hangingPunct="1">
-        <a:defRPr sz="1800" kern="1200">
+      <a:lvl8pPr marL="2400300" algn="l" defTabSz="685800" rtl="0" eaLnBrk="1" latinLnBrk="0" hangingPunct="1">
+        <a:defRPr sz="1350" kern="1200">
           <a:solidFill>
             <a:schemeClr val="tx1"/>
           </a:solidFill>
@@ -3443,8 +3691,8 @@
           <a:cs typeface="+mn-cs"/>
         </a:defRPr>
       </a:lvl8pPr>
-      <a:lvl9pPr marL="3657600" algn="l" defTabSz="914400" rtl="0" eaLnBrk="1" latinLnBrk="0" hangingPunct="1">
-        <a:defRPr sz="1800" kern="1200">
+      <a:lvl9pPr marL="2743200" algn="l" defTabSz="685800" rtl="0" eaLnBrk="1" latinLnBrk="0" hangingPunct="1">
+        <a:defRPr sz="1350" kern="1200">
           <a:solidFill>
             <a:schemeClr val="tx1"/>
           </a:solidFill>
@@ -3519,7 +3767,9 @@
         </p:nvSpPr>
         <p:spPr/>
         <p:txBody>
-          <a:bodyPr/>
+          <a:bodyPr>
+            <a:normAutofit/>
+          </a:bodyPr>
           <a:lstStyle/>
           <a:p>
             <a:r>
@@ -3605,6 +3855,128 @@
           <p:cNvPr id="2" name="Title 1">
             <a:extLst>
               <a:ext uri="{FF2B5EF4-FFF2-40B4-BE49-F238E27FC236}">
+                <a16:creationId xmlns:a16="http://schemas.microsoft.com/office/drawing/2014/main" id="{499C661A-6FBC-415F-B2C0-586A888393C5}"/>
+              </a:ext>
+            </a:extLst>
+          </p:cNvPr>
+          <p:cNvSpPr>
+            <a:spLocks noGrp="1"/>
+          </p:cNvSpPr>
+          <p:nvPr>
+            <p:ph type="title"/>
+          </p:nvPr>
+        </p:nvSpPr>
+        <p:spPr/>
+        <p:txBody>
+          <a:bodyPr/>
+          <a:lstStyle/>
+          <a:p>
+            <a:r>
+              <a:rPr lang="id-ID" dirty="0"/>
+              <a:t>Further Ideas</a:t>
+            </a:r>
+          </a:p>
+        </p:txBody>
+      </p:sp>
+      <p:sp>
+        <p:nvSpPr>
+          <p:cNvPr id="3" name="Content Placeholder 2">
+            <a:extLst>
+              <a:ext uri="{FF2B5EF4-FFF2-40B4-BE49-F238E27FC236}">
+                <a16:creationId xmlns:a16="http://schemas.microsoft.com/office/drawing/2014/main" id="{763A6E48-EAF8-4426-8E45-49F9DC8851C7}"/>
+              </a:ext>
+            </a:extLst>
+          </p:cNvPr>
+          <p:cNvSpPr>
+            <a:spLocks noGrp="1"/>
+          </p:cNvSpPr>
+          <p:nvPr>
+            <p:ph idx="1"/>
+          </p:nvPr>
+        </p:nvSpPr>
+        <p:spPr/>
+        <p:txBody>
+          <a:bodyPr/>
+          <a:lstStyle/>
+          <a:p>
+            <a:r>
+              <a:rPr lang="id-ID" dirty="0"/>
+              <a:t>What can we do with this vibratory model?</a:t>
+            </a:r>
+          </a:p>
+          <a:p>
+            <a:pPr lvl="1"/>
+            <a:r>
+              <a:rPr lang="id-ID" dirty="0"/>
+              <a:t>Think of something, write them down in your report.</a:t>
+            </a:r>
+          </a:p>
+        </p:txBody>
+      </p:sp>
+      <p:sp>
+        <p:nvSpPr>
+          <p:cNvPr id="4" name="Slide Number Placeholder 3">
+            <a:extLst>
+              <a:ext uri="{FF2B5EF4-FFF2-40B4-BE49-F238E27FC236}">
+                <a16:creationId xmlns:a16="http://schemas.microsoft.com/office/drawing/2014/main" id="{E84DE9A1-6018-4C79-9960-EADA7A9BFBC2}"/>
+              </a:ext>
+            </a:extLst>
+          </p:cNvPr>
+          <p:cNvSpPr>
+            <a:spLocks noGrp="1"/>
+          </p:cNvSpPr>
+          <p:nvPr>
+            <p:ph type="sldNum" sz="quarter" idx="12"/>
+          </p:nvPr>
+        </p:nvSpPr>
+        <p:spPr/>
+        <p:txBody>
+          <a:bodyPr/>
+          <a:lstStyle/>
+          <a:p>
+            <a:fld id="{618A9F2F-089D-4DCC-8F7D-C9C922ECE4DB}" type="slidenum">
+              <a:rPr lang="id-ID" smtClean="0"/>
+              <a:t>10</a:t>
+            </a:fld>
+            <a:endParaRPr lang="id-ID"/>
+          </a:p>
+        </p:txBody>
+      </p:sp>
+    </p:spTree>
+    <p:extLst>
+      <p:ext uri="{BB962C8B-B14F-4D97-AF65-F5344CB8AC3E}">
+        <p14:creationId xmlns:p14="http://schemas.microsoft.com/office/powerpoint/2010/main" val="2430441608"/>
+      </p:ext>
+    </p:extLst>
+  </p:cSld>
+  <p:clrMapOvr>
+    <a:masterClrMapping/>
+  </p:clrMapOvr>
+</p:sld>
+</file>
+
+<file path=ppt/slides/slide11.xml><?xml version="1.0" encoding="utf-8"?>
+<p:sld xmlns:a="http://schemas.openxmlformats.org/drawingml/2006/main" xmlns:r="http://schemas.openxmlformats.org/officeDocument/2006/relationships" xmlns:p="http://schemas.openxmlformats.org/presentationml/2006/main">
+  <p:cSld>
+    <p:spTree>
+      <p:nvGrpSpPr>
+        <p:cNvPr id="1" name=""/>
+        <p:cNvGrpSpPr/>
+        <p:nvPr/>
+      </p:nvGrpSpPr>
+      <p:grpSpPr>
+        <a:xfrm>
+          <a:off x="0" y="0"/>
+          <a:ext cx="0" cy="0"/>
+          <a:chOff x="0" y="0"/>
+          <a:chExt cx="0" cy="0"/>
+        </a:xfrm>
+      </p:grpSpPr>
+      <p:sp>
+        <p:nvSpPr>
+          <p:cNvPr id="2" name="Title 1">
+            <a:extLst>
+              <a:ext uri="{FF2B5EF4-FFF2-40B4-BE49-F238E27FC236}">
                 <a16:creationId xmlns:a16="http://schemas.microsoft.com/office/drawing/2014/main" id="{7CC29EB8-038F-4919-BB37-C79345FE9A54}"/>
               </a:ext>
             </a:extLst>
@@ -3647,7 +4019,7 @@
         <p:spPr/>
         <p:txBody>
           <a:bodyPr>
-            <a:normAutofit fontScale="92500"/>
+            <a:normAutofit/>
           </a:bodyPr>
           <a:lstStyle/>
           <a:p>
@@ -3705,7 +4077,7 @@
           <a:p>
             <a:fld id="{618A9F2F-089D-4DCC-8F7D-C9C922ECE4DB}" type="slidenum">
               <a:rPr lang="id-ID" smtClean="0"/>
-              <a:t>10</a:t>
+              <a:t>11</a:t>
             </a:fld>
             <a:endParaRPr lang="id-ID"/>
           </a:p>
@@ -3724,7 +4096,7 @@
 </p:sld>
 </file>
 
-<file path=ppt/slides/slide11.xml><?xml version="1.0" encoding="utf-8"?>
+<file path=ppt/slides/slide12.xml><?xml version="1.0" encoding="utf-8"?>
 <p:sld xmlns:a="http://schemas.openxmlformats.org/drawingml/2006/main" xmlns:r="http://schemas.openxmlformats.org/officeDocument/2006/relationships" xmlns:p="http://schemas.openxmlformats.org/presentationml/2006/main">
   <p:cSld>
     <p:spTree>
@@ -3829,7 +4201,7 @@
           <a:p>
             <a:fld id="{618A9F2F-089D-4DCC-8F7D-C9C922ECE4DB}" type="slidenum">
               <a:rPr lang="id-ID" smtClean="0"/>
-              <a:t>11</a:t>
+              <a:t>12</a:t>
             </a:fld>
             <a:endParaRPr lang="id-ID"/>
           </a:p>
@@ -3912,7 +4284,7 @@
         <p:spPr/>
         <p:txBody>
           <a:bodyPr>
-            <a:normAutofit fontScale="85000" lnSpcReduction="20000"/>
+            <a:normAutofit/>
           </a:bodyPr>
           <a:lstStyle/>
           <a:p>
@@ -3936,7 +4308,7 @@
           <a:p>
             <a:r>
               <a:rPr lang="id-ID" dirty="0"/>
-              <a:t>Student can analyze the model and gain knowledge on the real system through the developed model.</a:t>
+              <a:t>Student can analyze the derived model and gain knowledge on the real system through the model.</a:t>
             </a:r>
           </a:p>
           <a:p>
@@ -4315,6 +4687,35 @@
           </p:sp>
         </mc:Fallback>
       </mc:AlternateContent>
+      <p:sp>
+        <p:nvSpPr>
+          <p:cNvPr id="9" name="Slide Number Placeholder 8">
+            <a:extLst>
+              <a:ext uri="{FF2B5EF4-FFF2-40B4-BE49-F238E27FC236}">
+                <a16:creationId xmlns:a16="http://schemas.microsoft.com/office/drawing/2014/main" id="{86656A3E-7F32-4CBD-9BF8-1F6A28A10F9C}"/>
+              </a:ext>
+            </a:extLst>
+          </p:cNvPr>
+          <p:cNvSpPr>
+            <a:spLocks noGrp="1"/>
+          </p:cNvSpPr>
+          <p:nvPr>
+            <p:ph type="sldNum" sz="quarter" idx="12"/>
+          </p:nvPr>
+        </p:nvSpPr>
+        <p:spPr/>
+        <p:txBody>
+          <a:bodyPr/>
+          <a:lstStyle/>
+          <a:p>
+            <a:fld id="{618A9F2F-089D-4DCC-8F7D-C9C922ECE4DB}" type="slidenum">
+              <a:rPr lang="id-ID" smtClean="0"/>
+              <a:t>3</a:t>
+            </a:fld>
+            <a:endParaRPr lang="id-ID"/>
+          </a:p>
+        </p:txBody>
+      </p:sp>
       <p:grpSp>
         <p:nvGrpSpPr>
           <p:cNvPr id="14" name="Group 13">
@@ -4948,35 +5349,6 @@
           </mc:Fallback>
         </mc:AlternateContent>
       </p:grpSp>
-      <p:sp>
-        <p:nvSpPr>
-          <p:cNvPr id="9" name="Slide Number Placeholder 8">
-            <a:extLst>
-              <a:ext uri="{FF2B5EF4-FFF2-40B4-BE49-F238E27FC236}">
-                <a16:creationId xmlns:a16="http://schemas.microsoft.com/office/drawing/2014/main" id="{86656A3E-7F32-4CBD-9BF8-1F6A28A10F9C}"/>
-              </a:ext>
-            </a:extLst>
-          </p:cNvPr>
-          <p:cNvSpPr>
-            <a:spLocks noGrp="1"/>
-          </p:cNvSpPr>
-          <p:nvPr>
-            <p:ph type="sldNum" sz="quarter" idx="12"/>
-          </p:nvPr>
-        </p:nvSpPr>
-        <p:spPr/>
-        <p:txBody>
-          <a:bodyPr/>
-          <a:lstStyle/>
-          <a:p>
-            <a:fld id="{618A9F2F-089D-4DCC-8F7D-C9C922ECE4DB}" type="slidenum">
-              <a:rPr lang="id-ID" smtClean="0"/>
-              <a:t>3</a:t>
-            </a:fld>
-            <a:endParaRPr lang="id-ID"/>
-          </a:p>
-        </p:txBody>
-      </p:sp>
     </p:spTree>
     <p:extLst>
       <p:ext uri="{BB962C8B-B14F-4D97-AF65-F5344CB8AC3E}">
@@ -5020,7 +5392,7 @@
         <p:spPr/>
         <p:txBody>
           <a:bodyPr>
-            <a:normAutofit fontScale="90000"/>
+            <a:normAutofit/>
           </a:bodyPr>
           <a:lstStyle/>
           <a:p>
@@ -5031,8 +5403,8 @@
           </a:p>
         </p:txBody>
       </p:sp>
-      <mc:AlternateContent xmlns:mc="http://schemas.openxmlformats.org/markup-compatibility/2006" xmlns:a14="http://schemas.microsoft.com/office/drawing/2010/main">
-        <mc:Choice Requires="a14">
+      <mc:AlternateContent xmlns:mc="http://schemas.openxmlformats.org/markup-compatibility/2006">
+        <mc:Choice xmlns:a14="http://schemas.microsoft.com/office/drawing/2010/main" Requires="a14">
           <p:sp>
             <p:nvSpPr>
               <p:cNvPr id="3" name="Content Placeholder 2"/>
@@ -5046,7 +5418,7 @@
             <p:spPr/>
             <p:txBody>
               <a:bodyPr>
-                <a:normAutofit fontScale="92500" lnSpcReduction="20000"/>
+                <a:normAutofit/>
               </a:bodyPr>
               <a:lstStyle/>
               <a:p>
@@ -5254,21 +5626,7 @@
                               <a:latin typeface="Cambria Math"/>
                               <a:ea typeface="Cambria Math"/>
                             </a:rPr>
-                            <m:t>+</m:t>
-                          </m:r>
-                          <m:r>
-                            <a:rPr lang="id-ID" b="0" i="1" smtClean="0">
-                              <a:latin typeface="Cambria Math"/>
-                              <a:ea typeface="Cambria Math"/>
-                            </a:rPr>
-                            <m:t>1</m:t>
-                          </m:r>
-                          <m:r>
-                            <a:rPr lang="id-ID" b="0" i="1" smtClean="0">
-                              <a:latin typeface="Cambria Math"/>
-                              <a:ea typeface="Cambria Math"/>
-                            </a:rPr>
-                            <m:t>)(</m:t>
+                            <m:t>+1)(</m:t>
                           </m:r>
                           <m:sSub>
                             <m:sSubPr>
@@ -5310,21 +5668,7 @@
                               <a:latin typeface="Cambria Math"/>
                               <a:ea typeface="Cambria Math"/>
                             </a:rPr>
-                            <m:t>+</m:t>
-                          </m:r>
-                          <m:r>
-                            <a:rPr lang="id-ID" b="0" i="1" smtClean="0">
-                              <a:latin typeface="Cambria Math"/>
-                              <a:ea typeface="Cambria Math"/>
-                            </a:rPr>
-                            <m:t>1</m:t>
-                          </m:r>
-                          <m:r>
-                            <a:rPr lang="id-ID" b="0" i="1" smtClean="0">
-                              <a:latin typeface="Cambria Math"/>
-                              <a:ea typeface="Cambria Math"/>
-                            </a:rPr>
-                            <m:t>)</m:t>
+                            <m:t>+1)</m:t>
                           </m:r>
                         </m:den>
                       </m:f>
@@ -5485,7 +5829,7 @@
             </p:txBody>
           </p:sp>
         </mc:Choice>
-        <mc:Fallback xmlns="">
+        <mc:Fallback>
           <p:sp>
             <p:nvSpPr>
               <p:cNvPr id="3" name="Content Placeholder 2"/>
@@ -5500,7 +5844,7 @@
               <a:blipFill>
                 <a:blip r:embed="rId2"/>
                 <a:stretch>
-                  <a:fillRect l="-1481" t="-3504" r="-1185"/>
+                  <a:fillRect l="-773" t="-1541"/>
                 </a:stretch>
               </a:blipFill>
             </p:spPr>
@@ -5591,7 +5935,7 @@
         <p:spPr/>
         <p:txBody>
           <a:bodyPr>
-            <a:normAutofit fontScale="90000"/>
+            <a:normAutofit/>
           </a:bodyPr>
           <a:lstStyle/>
           <a:p>
@@ -5602,8 +5946,8 @@
           </a:p>
         </p:txBody>
       </p:sp>
-      <mc:AlternateContent xmlns:mc="http://schemas.openxmlformats.org/markup-compatibility/2006" xmlns:a14="http://schemas.microsoft.com/office/drawing/2010/main">
-        <mc:Choice Requires="a14">
+      <mc:AlternateContent xmlns:mc="http://schemas.openxmlformats.org/markup-compatibility/2006">
+        <mc:Choice xmlns:a14="http://schemas.microsoft.com/office/drawing/2010/main" Requires="a14">
           <p:sp>
             <p:nvSpPr>
               <p:cNvPr id="3" name="Content Placeholder 2"/>
@@ -5617,7 +5961,7 @@
             <p:spPr/>
             <p:txBody>
               <a:bodyPr>
-                <a:normAutofit fontScale="85000" lnSpcReduction="20000"/>
+                <a:normAutofit/>
               </a:bodyPr>
               <a:lstStyle/>
               <a:p>
@@ -5891,7 +6235,7 @@
             </p:txBody>
           </p:sp>
         </mc:Choice>
-        <mc:Fallback xmlns="">
+        <mc:Fallback>
           <p:sp>
             <p:nvSpPr>
               <p:cNvPr id="3" name="Content Placeholder 2"/>
@@ -5906,7 +6250,7 @@
               <a:blipFill>
                 <a:blip r:embed="rId2"/>
                 <a:stretch>
-                  <a:fillRect l="-1259" t="-2830"/>
+                  <a:fillRect l="-773" t="-1541" r="-541"/>
                 </a:stretch>
               </a:blipFill>
             </p:spPr>
@@ -6006,8 +6350,8 @@
           </a:p>
         </p:txBody>
       </p:sp>
-      <mc:AlternateContent xmlns:mc="http://schemas.openxmlformats.org/markup-compatibility/2006" xmlns:a14="http://schemas.microsoft.com/office/drawing/2010/main">
-        <mc:Choice Requires="a14">
+      <mc:AlternateContent xmlns:mc="http://schemas.openxmlformats.org/markup-compatibility/2006">
+        <mc:Choice xmlns:a14="http://schemas.microsoft.com/office/drawing/2010/main" Requires="a14">
           <p:sp>
             <p:nvSpPr>
               <p:cNvPr id="3" name="Content Placeholder 2"/>
@@ -6021,7 +6365,7 @@
             <p:spPr/>
             <p:txBody>
               <a:bodyPr>
-                <a:normAutofit fontScale="92500" lnSpcReduction="10000"/>
+                <a:normAutofit/>
               </a:bodyPr>
               <a:lstStyle/>
               <a:p>
@@ -6263,7 +6607,7 @@
             </p:txBody>
           </p:sp>
         </mc:Choice>
-        <mc:Fallback xmlns="">
+        <mc:Fallback>
           <p:sp>
             <p:nvSpPr>
               <p:cNvPr id="3" name="Content Placeholder 2"/>
@@ -6278,7 +6622,7 @@
               <a:blipFill>
                 <a:blip r:embed="rId2"/>
                 <a:stretch>
-                  <a:fillRect l="-1704" b="-2156"/>
+                  <a:fillRect l="-927"/>
                 </a:stretch>
               </a:blipFill>
             </p:spPr>
@@ -6863,8 +7207,8 @@
             </a:fontRef>
           </p:style>
         </p:cxnSp>
-        <mc:AlternateContent xmlns:mc="http://schemas.openxmlformats.org/markup-compatibility/2006">
-          <mc:Choice xmlns:a14="http://schemas.microsoft.com/office/drawing/2010/main" Requires="a14">
+        <mc:AlternateContent xmlns:mc="http://schemas.openxmlformats.org/markup-compatibility/2006" xmlns:a14="http://schemas.microsoft.com/office/drawing/2010/main">
+          <mc:Choice Requires="a14">
             <p:sp>
               <p:nvSpPr>
                 <p:cNvPr id="14" name="Rectangle 13">
@@ -6892,6 +7236,7 @@
                 </a:bodyPr>
                 <a:lstStyle/>
                 <a:p>
+                  <a:pPr/>
                   <a14:m>
                     <m:oMathPara xmlns:m="http://schemas.openxmlformats.org/officeDocument/2006/math">
                       <m:oMathParaPr>
@@ -6930,7 +7275,7 @@
               </p:txBody>
             </p:sp>
           </mc:Choice>
-          <mc:Fallback>
+          <mc:Fallback xmlns="">
             <p:sp>
               <p:nvSpPr>
                 <p:cNvPr id="14" name="Rectangle 13">
@@ -7055,7 +7400,7 @@
             <p:spPr/>
             <p:txBody>
               <a:bodyPr>
-                <a:normAutofit fontScale="85000" lnSpcReduction="10000"/>
+                <a:normAutofit/>
               </a:bodyPr>
               <a:lstStyle/>
               <a:p>
@@ -7244,6 +7589,12 @@
                                   <a:rPr lang="id-ID" b="0" i="1" smtClean="0">
                                     <a:latin typeface="Cambria Math" panose="02040503050406030204" pitchFamily="18" charset="0"/>
                                   </a:rPr>
+                                  <m:t>−</m:t>
+                                </m:r>
+                                <m:r>
+                                  <a:rPr lang="id-ID" b="0" i="1" smtClean="0">
+                                    <a:latin typeface="Cambria Math" panose="02040503050406030204" pitchFamily="18" charset="0"/>
+                                  </a:rPr>
                                   <m:t>𝐾</m:t>
                                 </m:r>
                                 <m:r>
@@ -7260,6 +7611,12 @@
                                 </m:r>
                               </m:e>
                               <m:e>
+                                <m:r>
+                                  <a:rPr lang="id-ID" b="0" i="1" smtClean="0">
+                                    <a:latin typeface="Cambria Math" panose="02040503050406030204" pitchFamily="18" charset="0"/>
+                                  </a:rPr>
+                                  <m:t>−</m:t>
+                                </m:r>
                                 <m:r>
                                   <a:rPr lang="id-ID" b="0" i="1" smtClean="0">
                                     <a:latin typeface="Cambria Math" panose="02040503050406030204" pitchFamily="18" charset="0"/>
@@ -7388,6 +7745,65 @@
                         </a:rPr>
                         <m:t>+</m:t>
                       </m:r>
+                      <m:d>
+                        <m:dPr>
+                          <m:begChr m:val="["/>
+                          <m:endChr m:val="]"/>
+                          <m:ctrlPr>
+                            <a:rPr lang="id-ID" b="0" i="1" smtClean="0">
+                              <a:latin typeface="Cambria Math" panose="02040503050406030204" pitchFamily="18" charset="0"/>
+                            </a:rPr>
+                          </m:ctrlPr>
+                        </m:dPr>
+                        <m:e>
+                          <m:m>
+                            <m:mPr>
+                              <m:mcs>
+                                <m:mc>
+                                  <m:mcPr>
+                                    <m:count m:val="1"/>
+                                    <m:mcJc m:val="center"/>
+                                  </m:mcPr>
+                                </m:mc>
+                              </m:mcs>
+                              <m:ctrlPr>
+                                <a:rPr lang="id-ID" b="0" i="1" smtClean="0">
+                                  <a:latin typeface="Cambria Math" panose="02040503050406030204" pitchFamily="18" charset="0"/>
+                                </a:rPr>
+                              </m:ctrlPr>
+                            </m:mPr>
+                            <m:mr>
+                              <m:e>
+                                <m:r>
+                                  <m:rPr>
+                                    <m:brk m:alnAt="7"/>
+                                  </m:rPr>
+                                  <a:rPr lang="id-ID" b="0" i="1" smtClean="0">
+                                    <a:latin typeface="Cambria Math" panose="02040503050406030204" pitchFamily="18" charset="0"/>
+                                  </a:rPr>
+                                  <m:t>0</m:t>
+                                </m:r>
+                              </m:e>
+                            </m:mr>
+                            <m:mr>
+                              <m:e>
+                                <m:r>
+                                  <a:rPr lang="id-ID" b="0" i="1" smtClean="0">
+                                    <a:latin typeface="Cambria Math" panose="02040503050406030204" pitchFamily="18" charset="0"/>
+                                  </a:rPr>
+                                  <m:t>1/</m:t>
+                                </m:r>
+                                <m:r>
+                                  <a:rPr lang="id-ID" b="0" i="1" smtClean="0">
+                                    <a:latin typeface="Cambria Math" panose="02040503050406030204" pitchFamily="18" charset="0"/>
+                                  </a:rPr>
+                                  <m:t>𝑀</m:t>
+                                </m:r>
+                              </m:e>
+                            </m:mr>
+                          </m:m>
+                        </m:e>
+                      </m:d>
                       <m:r>
                         <a:rPr lang="id-ID" b="0" i="1" smtClean="0">
                           <a:latin typeface="Cambria Math" panose="02040503050406030204" pitchFamily="18" charset="0"/>
@@ -7427,6 +7843,12 @@
                     </m:oMath>
                   </m:oMathPara>
                 </a14:m>
+                <a:endParaRPr lang="id-ID" b="0" dirty="0"/>
+              </a:p>
+              <a:p>
+                <a:pPr marL="0" indent="0">
+                  <a:buNone/>
+                </a:pPr>
                 <a:endParaRPr lang="id-ID" b="0" dirty="0"/>
               </a:p>
               <a:p>
@@ -7444,7 +7866,7 @@
                           <m:begChr m:val="["/>
                           <m:endChr m:val="]"/>
                           <m:ctrlPr>
-                            <a:rPr lang="id-ID" i="1">
+                            <a:rPr lang="id-ID" sz="2400" i="1">
                               <a:latin typeface="Cambria Math" panose="02040503050406030204" pitchFamily="18" charset="0"/>
                             </a:rPr>
                           </m:ctrlPr>
@@ -7461,7 +7883,7 @@
                                 </m:mc>
                               </m:mcs>
                               <m:ctrlPr>
-                                <a:rPr lang="id-ID" i="1">
+                                <a:rPr lang="id-ID" sz="2400" i="1">
                                   <a:latin typeface="Cambria Math" panose="02040503050406030204" pitchFamily="18" charset="0"/>
                                 </a:rPr>
                               </m:ctrlPr>
@@ -7472,14 +7894,14 @@
                                   <m:accPr>
                                     <m:chr m:val="̇"/>
                                     <m:ctrlPr>
-                                      <a:rPr lang="id-ID" i="1">
+                                      <a:rPr lang="id-ID" sz="2400" i="1">
                                         <a:latin typeface="Cambria Math" panose="02040503050406030204" pitchFamily="18" charset="0"/>
                                       </a:rPr>
                                     </m:ctrlPr>
                                   </m:accPr>
                                   <m:e>
                                     <m:r>
-                                      <a:rPr lang="id-ID" i="1">
+                                      <a:rPr lang="id-ID" sz="2400" i="1">
                                         <a:latin typeface="Cambria Math" panose="02040503050406030204" pitchFamily="18" charset="0"/>
                                       </a:rPr>
                                       <m:t>𝑇</m:t>
@@ -7489,14 +7911,14 @@
                                 <m:d>
                                   <m:dPr>
                                     <m:ctrlPr>
-                                      <a:rPr lang="id-ID" i="1">
+                                      <a:rPr lang="id-ID" sz="2400" i="1">
                                         <a:latin typeface="Cambria Math" panose="02040503050406030204" pitchFamily="18" charset="0"/>
                                       </a:rPr>
                                     </m:ctrlPr>
                                   </m:dPr>
                                   <m:e>
                                     <m:r>
-                                      <a:rPr lang="id-ID" i="1">
+                                      <a:rPr lang="id-ID" sz="2400" i="1">
                                         <a:latin typeface="Cambria Math" panose="02040503050406030204" pitchFamily="18" charset="0"/>
                                       </a:rPr>
                                       <m:t>𝑡</m:t>
@@ -7511,14 +7933,14 @@
                                   <m:accPr>
                                     <m:chr m:val="̈"/>
                                     <m:ctrlPr>
-                                      <a:rPr lang="id-ID" i="1">
+                                      <a:rPr lang="id-ID" sz="2400" i="1">
                                         <a:latin typeface="Cambria Math" panose="02040503050406030204" pitchFamily="18" charset="0"/>
                                       </a:rPr>
                                     </m:ctrlPr>
                                   </m:accPr>
                                   <m:e>
                                     <m:r>
-                                      <a:rPr lang="id-ID" i="1">
+                                      <a:rPr lang="id-ID" sz="2400" i="1">
                                         <a:latin typeface="Cambria Math" panose="02040503050406030204" pitchFamily="18" charset="0"/>
                                       </a:rPr>
                                       <m:t>𝑇</m:t>
@@ -7528,14 +7950,14 @@
                                 <m:d>
                                   <m:dPr>
                                     <m:ctrlPr>
-                                      <a:rPr lang="id-ID" i="1">
+                                      <a:rPr lang="id-ID" sz="2400" i="1">
                                         <a:latin typeface="Cambria Math" panose="02040503050406030204" pitchFamily="18" charset="0"/>
                                       </a:rPr>
                                     </m:ctrlPr>
                                   </m:dPr>
                                   <m:e>
                                     <m:r>
-                                      <a:rPr lang="id-ID" i="1">
+                                      <a:rPr lang="id-ID" sz="2400" i="1">
                                         <a:latin typeface="Cambria Math" panose="02040503050406030204" pitchFamily="18" charset="0"/>
                                       </a:rPr>
                                       <m:t>𝑡</m:t>
@@ -7548,7 +7970,7 @@
                         </m:e>
                       </m:d>
                       <m:r>
-                        <a:rPr lang="id-ID" b="0" i="1" smtClean="0">
+                        <a:rPr lang="id-ID" sz="2400" b="0" i="1" smtClean="0">
                           <a:latin typeface="Cambria Math" panose="02040503050406030204" pitchFamily="18" charset="0"/>
                         </a:rPr>
                         <m:t>=</m:t>
@@ -7558,7 +7980,7 @@
                           <m:begChr m:val="["/>
                           <m:endChr m:val="]"/>
                           <m:ctrlPr>
-                            <a:rPr lang="id-ID" i="1">
+                            <a:rPr lang="id-ID" sz="2400" i="1">
                               <a:latin typeface="Cambria Math" panose="02040503050406030204" pitchFamily="18" charset="0"/>
                             </a:rPr>
                           </m:ctrlPr>
@@ -7575,7 +7997,7 @@
                                 </m:mc>
                               </m:mcs>
                               <m:ctrlPr>
-                                <a:rPr lang="id-ID" i="1">
+                                <a:rPr lang="id-ID" sz="2400" i="1">
                                   <a:latin typeface="Cambria Math" panose="02040503050406030204" pitchFamily="18" charset="0"/>
                                 </a:rPr>
                               </m:ctrlPr>
@@ -7586,7 +8008,7 @@
                                   <m:rPr>
                                     <m:brk m:alnAt="7"/>
                                   </m:rPr>
-                                  <a:rPr lang="id-ID" i="1">
+                                  <a:rPr lang="id-ID" sz="2400" i="1">
                                     <a:latin typeface="Cambria Math" panose="02040503050406030204" pitchFamily="18" charset="0"/>
                                   </a:rPr>
                                   <m:t>0</m:t>
@@ -7594,7 +8016,7 @@
                               </m:e>
                               <m:e>
                                 <m:r>
-                                  <a:rPr lang="id-ID" i="1">
+                                  <a:rPr lang="id-ID" sz="2400" i="1">
                                     <a:latin typeface="Cambria Math" panose="02040503050406030204" pitchFamily="18" charset="0"/>
                                   </a:rPr>
                                   <m:t>1</m:t>
@@ -7604,45 +8026,21 @@
                             <m:mr>
                               <m:e>
                                 <m:r>
-                                  <a:rPr lang="id-ID" b="0" i="1" smtClean="0">
+                                  <a:rPr lang="id-ID" sz="2400" b="0" i="1" smtClean="0">
                                     <a:latin typeface="Cambria Math" panose="02040503050406030204" pitchFamily="18" charset="0"/>
                                   </a:rPr>
-                                  <m:t>0</m:t>
-                                </m:r>
-                                <m:r>
-                                  <a:rPr lang="id-ID" b="0" i="1" smtClean="0">
-                                    <a:latin typeface="Cambria Math" panose="02040503050406030204" pitchFamily="18" charset="0"/>
-                                  </a:rPr>
-                                  <m:t>.</m:t>
-                                </m:r>
-                                <m:r>
-                                  <a:rPr lang="id-ID" b="0" i="1" smtClean="0">
-                                    <a:latin typeface="Cambria Math" panose="02040503050406030204" pitchFamily="18" charset="0"/>
-                                  </a:rPr>
-                                  <m:t>115</m:t>
+                                  <m:t>−0.115</m:t>
                                 </m:r>
                               </m:e>
                               <m:e>
                                 <m:r>
-                                  <a:rPr lang="id-ID" b="0" i="1" smtClean="0">
+                                  <a:rPr lang="id-ID" sz="2400" b="0" i="1" smtClean="0">
                                     <a:latin typeface="Cambria Math" panose="02040503050406030204" pitchFamily="18" charset="0"/>
                                   </a:rPr>
-                                  <m:t>5</m:t>
+                                  <m:t>−5.547</m:t>
                                 </m:r>
                                 <m:r>
-                                  <a:rPr lang="id-ID" b="0" i="1" smtClean="0">
-                                    <a:latin typeface="Cambria Math" panose="02040503050406030204" pitchFamily="18" charset="0"/>
-                                  </a:rPr>
-                                  <m:t>.</m:t>
-                                </m:r>
-                                <m:r>
-                                  <a:rPr lang="id-ID" b="0" i="1" smtClean="0">
-                                    <a:latin typeface="Cambria Math" panose="02040503050406030204" pitchFamily="18" charset="0"/>
-                                  </a:rPr>
-                                  <m:t>547</m:t>
-                                </m:r>
-                                <m:r>
-                                  <a:rPr lang="id-ID" b="0" i="1" smtClean="0">
+                                  <a:rPr lang="id-ID" sz="2400" b="0" i="1" smtClean="0">
                                     <a:latin typeface="Cambria Math" panose="02040503050406030204" pitchFamily="18" charset="0"/>
                                     <a:ea typeface="Cambria Math" panose="02040503050406030204" pitchFamily="18" charset="0"/>
                                   </a:rPr>
@@ -7651,7 +8049,7 @@
                                 <m:sSup>
                                   <m:sSupPr>
                                     <m:ctrlPr>
-                                      <a:rPr lang="id-ID" b="0" i="1" smtClean="0">
+                                      <a:rPr lang="id-ID" sz="2400" b="0" i="1" smtClean="0">
                                         <a:latin typeface="Cambria Math" panose="02040503050406030204" pitchFamily="18" charset="0"/>
                                         <a:ea typeface="Cambria Math" panose="02040503050406030204" pitchFamily="18" charset="0"/>
                                       </a:rPr>
@@ -7659,7 +8057,7 @@
                                   </m:sSupPr>
                                   <m:e>
                                     <m:r>
-                                      <a:rPr lang="id-ID" b="0" i="1" smtClean="0">
+                                      <a:rPr lang="id-ID" sz="2400" b="0" i="1" smtClean="0">
                                         <a:latin typeface="Cambria Math" panose="02040503050406030204" pitchFamily="18" charset="0"/>
                                         <a:ea typeface="Cambria Math" panose="02040503050406030204" pitchFamily="18" charset="0"/>
                                       </a:rPr>
@@ -7668,18 +8066,11 @@
                                   </m:e>
                                   <m:sup>
                                     <m:r>
-                                      <a:rPr lang="id-ID" b="0" i="1" smtClean="0">
+                                      <a:rPr lang="id-ID" sz="2400" b="0" i="1" smtClean="0">
                                         <a:latin typeface="Cambria Math" panose="02040503050406030204" pitchFamily="18" charset="0"/>
                                         <a:ea typeface="Cambria Math" panose="02040503050406030204" pitchFamily="18" charset="0"/>
                                       </a:rPr>
-                                      <m:t>−</m:t>
-                                    </m:r>
-                                    <m:r>
-                                      <a:rPr lang="id-ID" b="0" i="1" smtClean="0">
-                                        <a:latin typeface="Cambria Math" panose="02040503050406030204" pitchFamily="18" charset="0"/>
-                                        <a:ea typeface="Cambria Math" panose="02040503050406030204" pitchFamily="18" charset="0"/>
-                                      </a:rPr>
-                                      <m:t>4</m:t>
+                                      <m:t>−4</m:t>
                                     </m:r>
                                   </m:sup>
                                 </m:sSup>
@@ -7693,7 +8084,7 @@
                           <m:begChr m:val="["/>
                           <m:endChr m:val="]"/>
                           <m:ctrlPr>
-                            <a:rPr lang="id-ID" i="1">
+                            <a:rPr lang="id-ID" sz="2400" i="1">
                               <a:latin typeface="Cambria Math" panose="02040503050406030204" pitchFamily="18" charset="0"/>
                             </a:rPr>
                           </m:ctrlPr>
@@ -7710,7 +8101,7 @@
                                 </m:mc>
                               </m:mcs>
                               <m:ctrlPr>
-                                <a:rPr lang="id-ID" i="1">
+                                <a:rPr lang="id-ID" sz="2400" i="1">
                                   <a:latin typeface="Cambria Math" panose="02040503050406030204" pitchFamily="18" charset="0"/>
                                 </a:rPr>
                               </m:ctrlPr>
@@ -7721,7 +8112,7 @@
                                   <m:rPr>
                                     <m:brk m:alnAt="7"/>
                                   </m:rPr>
-                                  <a:rPr lang="id-ID" i="1">
+                                  <a:rPr lang="id-ID" sz="2400" i="1">
                                     <a:latin typeface="Cambria Math" panose="02040503050406030204" pitchFamily="18" charset="0"/>
                                   </a:rPr>
                                   <m:t>𝑇</m:t>
@@ -7729,14 +8120,14 @@
                                 <m:d>
                                   <m:dPr>
                                     <m:ctrlPr>
-                                      <a:rPr lang="id-ID" i="1">
+                                      <a:rPr lang="id-ID" sz="2400" i="1">
                                         <a:latin typeface="Cambria Math" panose="02040503050406030204" pitchFamily="18" charset="0"/>
                                       </a:rPr>
                                     </m:ctrlPr>
                                   </m:dPr>
                                   <m:e>
                                     <m:r>
-                                      <a:rPr lang="id-ID" i="1">
+                                      <a:rPr lang="id-ID" sz="2400" i="1">
                                         <a:latin typeface="Cambria Math" panose="02040503050406030204" pitchFamily="18" charset="0"/>
                                       </a:rPr>
                                       <m:t>𝑡</m:t>
@@ -7751,14 +8142,14 @@
                                   <m:accPr>
                                     <m:chr m:val="̇"/>
                                     <m:ctrlPr>
-                                      <a:rPr lang="id-ID" i="1">
+                                      <a:rPr lang="id-ID" sz="2400" i="1">
                                         <a:latin typeface="Cambria Math" panose="02040503050406030204" pitchFamily="18" charset="0"/>
                                       </a:rPr>
                                     </m:ctrlPr>
                                   </m:accPr>
                                   <m:e>
                                     <m:r>
-                                      <a:rPr lang="id-ID" i="1">
+                                      <a:rPr lang="id-ID" sz="2400" i="1">
                                         <a:latin typeface="Cambria Math" panose="02040503050406030204" pitchFamily="18" charset="0"/>
                                       </a:rPr>
                                       <m:t>𝑇</m:t>
@@ -7768,14 +8159,14 @@
                                 <m:d>
                                   <m:dPr>
                                     <m:ctrlPr>
-                                      <a:rPr lang="id-ID" i="1">
+                                      <a:rPr lang="id-ID" sz="2400" i="1">
                                         <a:latin typeface="Cambria Math" panose="02040503050406030204" pitchFamily="18" charset="0"/>
                                       </a:rPr>
                                     </m:ctrlPr>
                                   </m:dPr>
                                   <m:e>
                                     <m:r>
-                                      <a:rPr lang="id-ID" i="1">
+                                      <a:rPr lang="id-ID" sz="2400" i="1">
                                         <a:latin typeface="Cambria Math" panose="02040503050406030204" pitchFamily="18" charset="0"/>
                                       </a:rPr>
                                       <m:t>𝑡</m:t>
@@ -7788,44 +8179,132 @@
                         </m:e>
                       </m:d>
                       <m:r>
-                        <a:rPr lang="id-ID" i="1">
+                        <a:rPr lang="id-ID" sz="2400" i="1">
                           <a:latin typeface="Cambria Math" panose="02040503050406030204" pitchFamily="18" charset="0"/>
                         </a:rPr>
                         <m:t>+</m:t>
                       </m:r>
+                      <m:d>
+                        <m:dPr>
+                          <m:begChr m:val="["/>
+                          <m:endChr m:val="]"/>
+                          <m:ctrlPr>
+                            <a:rPr lang="id-ID" sz="2400" i="1">
+                              <a:latin typeface="Cambria Math" panose="02040503050406030204" pitchFamily="18" charset="0"/>
+                            </a:rPr>
+                          </m:ctrlPr>
+                        </m:dPr>
+                        <m:e>
+                          <m:m>
+                            <m:mPr>
+                              <m:mcs>
+                                <m:mc>
+                                  <m:mcPr>
+                                    <m:count m:val="1"/>
+                                    <m:mcJc m:val="center"/>
+                                  </m:mcPr>
+                                </m:mc>
+                              </m:mcs>
+                              <m:ctrlPr>
+                                <a:rPr lang="id-ID" sz="2400" i="1">
+                                  <a:latin typeface="Cambria Math" panose="02040503050406030204" pitchFamily="18" charset="0"/>
+                                </a:rPr>
+                              </m:ctrlPr>
+                            </m:mPr>
+                            <m:mr>
+                              <m:e>
+                                <m:r>
+                                  <m:rPr>
+                                    <m:brk m:alnAt="7"/>
+                                  </m:rPr>
+                                  <a:rPr lang="id-ID" sz="2400" i="1">
+                                    <a:latin typeface="Cambria Math" panose="02040503050406030204" pitchFamily="18" charset="0"/>
+                                  </a:rPr>
+                                  <m:t>0</m:t>
+                                </m:r>
+                              </m:e>
+                            </m:mr>
+                            <m:mr>
+                              <m:e>
+                                <m:r>
+                                  <a:rPr lang="id-ID" sz="2400" i="1">
+                                    <a:latin typeface="Cambria Math" panose="02040503050406030204" pitchFamily="18" charset="0"/>
+                                  </a:rPr>
+                                  <m:t>6.163</m:t>
+                                </m:r>
+                                <m:r>
+                                  <a:rPr lang="id-ID" sz="2400" i="1" smtClean="0">
+                                    <a:latin typeface="Cambria Math" panose="02040503050406030204" pitchFamily="18" charset="0"/>
+                                    <a:ea typeface="Cambria Math" panose="02040503050406030204" pitchFamily="18" charset="0"/>
+                                  </a:rPr>
+                                  <m:t>×</m:t>
+                                </m:r>
+                                <m:sSup>
+                                  <m:sSupPr>
+                                    <m:ctrlPr>
+                                      <a:rPr lang="id-ID" sz="2400" b="0" i="1" smtClean="0">
+                                        <a:latin typeface="Cambria Math" panose="02040503050406030204" pitchFamily="18" charset="0"/>
+                                        <a:ea typeface="Cambria Math" panose="02040503050406030204" pitchFamily="18" charset="0"/>
+                                      </a:rPr>
+                                    </m:ctrlPr>
+                                  </m:sSupPr>
+                                  <m:e>
+                                    <m:r>
+                                      <a:rPr lang="id-ID" sz="2400" b="0" i="1" smtClean="0">
+                                        <a:latin typeface="Cambria Math" panose="02040503050406030204" pitchFamily="18" charset="0"/>
+                                        <a:ea typeface="Cambria Math" panose="02040503050406030204" pitchFamily="18" charset="0"/>
+                                      </a:rPr>
+                                      <m:t>10</m:t>
+                                    </m:r>
+                                  </m:e>
+                                  <m:sup>
+                                    <m:r>
+                                      <a:rPr lang="id-ID" sz="2400" b="0" i="1" smtClean="0">
+                                        <a:latin typeface="Cambria Math" panose="02040503050406030204" pitchFamily="18" charset="0"/>
+                                        <a:ea typeface="Cambria Math" panose="02040503050406030204" pitchFamily="18" charset="0"/>
+                                      </a:rPr>
+                                      <m:t>−4</m:t>
+                                    </m:r>
+                                  </m:sup>
+                                </m:sSup>
+                              </m:e>
+                            </m:mr>
+                          </m:m>
+                        </m:e>
+                      </m:d>
                       <m:r>
-                        <a:rPr lang="id-ID" i="1">
+                        <a:rPr lang="id-ID" sz="2400" i="1">
                           <a:latin typeface="Cambria Math" panose="02040503050406030204" pitchFamily="18" charset="0"/>
                         </a:rPr>
                         <m:t>𝑢</m:t>
                       </m:r>
                       <m:r>
-                        <a:rPr lang="id-ID" i="1">
+                        <a:rPr lang="id-ID" sz="2400" i="1">
                           <a:latin typeface="Cambria Math" panose="02040503050406030204" pitchFamily="18" charset="0"/>
                         </a:rPr>
                         <m:t>(</m:t>
                       </m:r>
                       <m:r>
-                        <a:rPr lang="id-ID" i="1">
+                        <a:rPr lang="id-ID" sz="2400" i="1">
                           <a:latin typeface="Cambria Math" panose="02040503050406030204" pitchFamily="18" charset="0"/>
                         </a:rPr>
                         <m:t>𝑡</m:t>
                       </m:r>
                       <m:r>
-                        <a:rPr lang="id-ID" i="1">
+                        <a:rPr lang="id-ID" sz="2400" i="1">
                           <a:latin typeface="Cambria Math" panose="02040503050406030204" pitchFamily="18" charset="0"/>
                         </a:rPr>
                         <m:t>−</m:t>
                       </m:r>
                       <m:r>
-                        <a:rPr lang="id-ID" i="1">
+                        <a:rPr lang="id-ID" sz="2400" i="1">
                           <a:latin typeface="Cambria Math" panose="02040503050406030204" pitchFamily="18" charset="0"/>
                           <a:ea typeface="Cambria Math" panose="02040503050406030204" pitchFamily="18" charset="0"/>
                         </a:rPr>
                         <m:t>𝜃</m:t>
                       </m:r>
                       <m:r>
-                        <a:rPr lang="id-ID" i="1">
+                        <a:rPr lang="id-ID" sz="2400" i="1">
                           <a:latin typeface="Cambria Math" panose="02040503050406030204" pitchFamily="18" charset="0"/>
                         </a:rPr>
                         <m:t>)</m:t>
@@ -7833,7 +8312,7 @@
                     </m:oMath>
                   </m:oMathPara>
                 </a14:m>
-                <a:endParaRPr lang="id-ID" dirty="0"/>
+                <a:endParaRPr lang="id-ID" sz="2400" dirty="0"/>
               </a:p>
               <a:p>
                 <a:pPr marL="0" indent="0">
@@ -8150,15 +8629,14 @@
               </a:ext>
             </a:extLst>
           </a:blip>
-          <a:srcRect/>
           <a:stretch>
             <a:fillRect/>
           </a:stretch>
         </p:blipFill>
         <p:spPr bwMode="auto">
           <a:xfrm>
-            <a:off x="1554773" y="1600200"/>
-            <a:ext cx="6034454" cy="4525963"/>
+            <a:off x="1671186" y="1825625"/>
+            <a:ext cx="5801627" cy="4351338"/>
           </a:xfrm>
           <a:prstGeom prst="rect">
             <a:avLst/>
@@ -8301,7 +8779,7 @@
           <p:cNvPr id="2" name="Title 1">
             <a:extLst>
               <a:ext uri="{FF2B5EF4-FFF2-40B4-BE49-F238E27FC236}">
-                <a16:creationId xmlns:a16="http://schemas.microsoft.com/office/drawing/2014/main" id="{499C661A-6FBC-415F-B2C0-586A888393C5}"/>
+                <a16:creationId xmlns:a16="http://schemas.microsoft.com/office/drawing/2014/main" id="{DB415FE3-3A60-4244-B807-9A4E7DE7BE71}"/>
               </a:ext>
             </a:extLst>
           </p:cNvPr>
@@ -8314,57 +8792,816 @@
         </p:nvSpPr>
         <p:spPr/>
         <p:txBody>
-          <a:bodyPr/>
+          <a:bodyPr>
+            <a:normAutofit/>
+          </a:bodyPr>
           <a:lstStyle/>
           <a:p>
+            <a:r>
+              <a:rPr lang="en-US" dirty="0"/>
+              <a:t>Approximation of </a:t>
+            </a:r>
             <a:r>
               <a:rPr lang="id-ID" dirty="0"/>
-              <a:t>Further Ideas</a:t>
+              <a:t>the </a:t>
             </a:r>
+            <a:r>
+              <a:rPr lang="en-US" dirty="0"/>
+              <a:t>Delayed System by Taylor Series Expansion</a:t>
+            </a:r>
+            <a:endParaRPr lang="id-ID" dirty="0"/>
           </a:p>
         </p:txBody>
       </p:sp>
-      <p:sp>
-        <p:nvSpPr>
-          <p:cNvPr id="3" name="Content Placeholder 2">
-            <a:extLst>
-              <a:ext uri="{FF2B5EF4-FFF2-40B4-BE49-F238E27FC236}">
-                <a16:creationId xmlns:a16="http://schemas.microsoft.com/office/drawing/2014/main" id="{763A6E48-EAF8-4426-8E45-49F9DC8851C7}"/>
-              </a:ext>
-            </a:extLst>
-          </p:cNvPr>
-          <p:cNvSpPr>
-            <a:spLocks noGrp="1"/>
-          </p:cNvSpPr>
-          <p:nvPr>
-            <p:ph idx="1"/>
-          </p:nvPr>
-        </p:nvSpPr>
-        <p:spPr/>
-        <p:txBody>
-          <a:bodyPr/>
-          <a:lstStyle/>
-          <a:p>
-            <a:r>
-              <a:rPr lang="id-ID" dirty="0"/>
-              <a:t>What can we do with this vibratory model?</a:t>
-            </a:r>
-          </a:p>
-          <a:p>
-            <a:pPr lvl="1"/>
-            <a:r>
-              <a:rPr lang="id-ID" dirty="0"/>
-              <a:t>Think of something, write them down in your report.</a:t>
-            </a:r>
-          </a:p>
-        </p:txBody>
-      </p:sp>
+      <mc:AlternateContent xmlns:mc="http://schemas.openxmlformats.org/markup-compatibility/2006">
+        <mc:Choice xmlns:a14="http://schemas.microsoft.com/office/drawing/2010/main" Requires="a14">
+          <p:sp>
+            <p:nvSpPr>
+              <p:cNvPr id="3" name="Content Placeholder 2">
+                <a:extLst>
+                  <a:ext uri="{FF2B5EF4-FFF2-40B4-BE49-F238E27FC236}">
+                    <a16:creationId xmlns:a16="http://schemas.microsoft.com/office/drawing/2014/main" id="{57DA6629-7431-4249-BA7B-A2959CB5688C}"/>
+                  </a:ext>
+                </a:extLst>
+              </p:cNvPr>
+              <p:cNvSpPr>
+                <a:spLocks noGrp="1"/>
+              </p:cNvSpPr>
+              <p:nvPr>
+                <p:ph idx="1"/>
+              </p:nvPr>
+            </p:nvSpPr>
+            <p:spPr>
+              <a:xfrm>
+                <a:off x="477728" y="1340768"/>
+                <a:ext cx="8229600" cy="4525963"/>
+              </a:xfrm>
+            </p:spPr>
+            <p:txBody>
+              <a:bodyPr>
+                <a:normAutofit/>
+              </a:bodyPr>
+              <a:lstStyle/>
+              <a:p>
+                <a:pPr marL="0" indent="0">
+                  <a:buNone/>
+                </a:pPr>
+                <a:endParaRPr lang="id-ID" b="0" i="1" dirty="0">
+                  <a:latin typeface="Cambria Math" panose="02040503050406030204" pitchFamily="18" charset="0"/>
+                </a:endParaRPr>
+              </a:p>
+              <a:p>
+                <a:pPr marL="0" indent="0">
+                  <a:buNone/>
+                </a:pPr>
+                <a14:m>
+                  <m:oMathPara xmlns:m="http://schemas.openxmlformats.org/officeDocument/2006/math">
+                    <m:oMathParaPr>
+                      <m:jc m:val="centerGroup"/>
+                    </m:oMathParaPr>
+                    <m:oMath xmlns:m="http://schemas.openxmlformats.org/officeDocument/2006/math">
+                      <m:r>
+                        <a:rPr lang="id-ID" b="0" i="1" smtClean="0">
+                          <a:latin typeface="Cambria Math" panose="02040503050406030204" pitchFamily="18" charset="0"/>
+                        </a:rPr>
+                        <m:t>𝑢</m:t>
+                      </m:r>
+                      <m:d>
+                        <m:dPr>
+                          <m:ctrlPr>
+                            <a:rPr lang="id-ID" b="0" i="1" smtClean="0">
+                              <a:latin typeface="Cambria Math" panose="02040503050406030204" pitchFamily="18" charset="0"/>
+                            </a:rPr>
+                          </m:ctrlPr>
+                        </m:dPr>
+                        <m:e>
+                          <m:r>
+                            <a:rPr lang="id-ID" b="0" i="1" smtClean="0">
+                              <a:latin typeface="Cambria Math" panose="02040503050406030204" pitchFamily="18" charset="0"/>
+                            </a:rPr>
+                            <m:t>𝑡</m:t>
+                          </m:r>
+                          <m:r>
+                            <a:rPr lang="id-ID" b="0" i="1" smtClean="0">
+                              <a:latin typeface="Cambria Math" panose="02040503050406030204" pitchFamily="18" charset="0"/>
+                            </a:rPr>
+                            <m:t>−</m:t>
+                          </m:r>
+                          <m:r>
+                            <a:rPr lang="id-ID" b="0" i="1" smtClean="0">
+                              <a:latin typeface="Cambria Math" panose="02040503050406030204" pitchFamily="18" charset="0"/>
+                              <a:ea typeface="Cambria Math" panose="02040503050406030204" pitchFamily="18" charset="0"/>
+                            </a:rPr>
+                            <m:t>𝜃</m:t>
+                          </m:r>
+                        </m:e>
+                      </m:d>
+                      <m:r>
+                        <a:rPr lang="id-ID" b="0" i="1" smtClean="0">
+                          <a:latin typeface="Cambria Math" panose="02040503050406030204" pitchFamily="18" charset="0"/>
+                          <a:ea typeface="Cambria Math" panose="02040503050406030204" pitchFamily="18" charset="0"/>
+                        </a:rPr>
+                        <m:t>=</m:t>
+                      </m:r>
+                      <m:r>
+                        <a:rPr lang="id-ID" b="0" i="1" smtClean="0">
+                          <a:latin typeface="Cambria Math" panose="02040503050406030204" pitchFamily="18" charset="0"/>
+                          <a:ea typeface="Cambria Math" panose="02040503050406030204" pitchFamily="18" charset="0"/>
+                        </a:rPr>
+                        <m:t>𝑢</m:t>
+                      </m:r>
+                      <m:d>
+                        <m:dPr>
+                          <m:ctrlPr>
+                            <a:rPr lang="id-ID" b="0" i="1" smtClean="0">
+                              <a:latin typeface="Cambria Math" panose="02040503050406030204" pitchFamily="18" charset="0"/>
+                              <a:ea typeface="Cambria Math" panose="02040503050406030204" pitchFamily="18" charset="0"/>
+                            </a:rPr>
+                          </m:ctrlPr>
+                        </m:dPr>
+                        <m:e>
+                          <m:r>
+                            <a:rPr lang="id-ID" b="0" i="1" smtClean="0">
+                              <a:latin typeface="Cambria Math" panose="02040503050406030204" pitchFamily="18" charset="0"/>
+                              <a:ea typeface="Cambria Math" panose="02040503050406030204" pitchFamily="18" charset="0"/>
+                            </a:rPr>
+                            <m:t>𝑡</m:t>
+                          </m:r>
+                        </m:e>
+                      </m:d>
+                      <m:r>
+                        <a:rPr lang="id-ID" b="0" i="1" smtClean="0">
+                          <a:latin typeface="Cambria Math" panose="02040503050406030204" pitchFamily="18" charset="0"/>
+                          <a:ea typeface="Cambria Math" panose="02040503050406030204" pitchFamily="18" charset="0"/>
+                        </a:rPr>
+                        <m:t>−</m:t>
+                      </m:r>
+                      <m:r>
+                        <a:rPr lang="id-ID" b="0" i="1" smtClean="0">
+                          <a:latin typeface="Cambria Math" panose="02040503050406030204" pitchFamily="18" charset="0"/>
+                          <a:ea typeface="Cambria Math" panose="02040503050406030204" pitchFamily="18" charset="0"/>
+                        </a:rPr>
+                        <m:t>𝜃</m:t>
+                      </m:r>
+                      <m:acc>
+                        <m:accPr>
+                          <m:chr m:val="̇"/>
+                          <m:ctrlPr>
+                            <a:rPr lang="id-ID" b="0" i="1" smtClean="0">
+                              <a:latin typeface="Cambria Math" panose="02040503050406030204" pitchFamily="18" charset="0"/>
+                              <a:ea typeface="Cambria Math" panose="02040503050406030204" pitchFamily="18" charset="0"/>
+                            </a:rPr>
+                          </m:ctrlPr>
+                        </m:accPr>
+                        <m:e>
+                          <m:r>
+                            <a:rPr lang="id-ID" b="0" i="1" smtClean="0">
+                              <a:latin typeface="Cambria Math" panose="02040503050406030204" pitchFamily="18" charset="0"/>
+                              <a:ea typeface="Cambria Math" panose="02040503050406030204" pitchFamily="18" charset="0"/>
+                            </a:rPr>
+                            <m:t>𝑢</m:t>
+                          </m:r>
+                        </m:e>
+                      </m:acc>
+                      <m:d>
+                        <m:dPr>
+                          <m:ctrlPr>
+                            <a:rPr lang="id-ID" b="0" i="1" smtClean="0">
+                              <a:latin typeface="Cambria Math" panose="02040503050406030204" pitchFamily="18" charset="0"/>
+                            </a:rPr>
+                          </m:ctrlPr>
+                        </m:dPr>
+                        <m:e>
+                          <m:r>
+                            <a:rPr lang="id-ID" b="0" i="1" smtClean="0">
+                              <a:latin typeface="Cambria Math" panose="02040503050406030204" pitchFamily="18" charset="0"/>
+                            </a:rPr>
+                            <m:t>𝑡</m:t>
+                          </m:r>
+                        </m:e>
+                      </m:d>
+                      <m:r>
+                        <a:rPr lang="id-ID" b="0" i="1" smtClean="0">
+                          <a:latin typeface="Cambria Math" panose="02040503050406030204" pitchFamily="18" charset="0"/>
+                        </a:rPr>
+                        <m:t>+</m:t>
+                      </m:r>
+                      <m:f>
+                        <m:fPr>
+                          <m:ctrlPr>
+                            <a:rPr lang="id-ID" i="1">
+                              <a:latin typeface="Cambria Math" panose="02040503050406030204" pitchFamily="18" charset="0"/>
+                            </a:rPr>
+                          </m:ctrlPr>
+                        </m:fPr>
+                        <m:num>
+                          <m:r>
+                            <a:rPr lang="id-ID" b="0" i="1" smtClean="0">
+                              <a:latin typeface="Cambria Math" panose="02040503050406030204" pitchFamily="18" charset="0"/>
+                            </a:rPr>
+                            <m:t>1</m:t>
+                          </m:r>
+                        </m:num>
+                        <m:den>
+                          <m:r>
+                            <a:rPr lang="id-ID" b="0" i="1" smtClean="0">
+                              <a:latin typeface="Cambria Math" panose="02040503050406030204" pitchFamily="18" charset="0"/>
+                            </a:rPr>
+                            <m:t>2</m:t>
+                          </m:r>
+                        </m:den>
+                      </m:f>
+                      <m:sSup>
+                        <m:sSupPr>
+                          <m:ctrlPr>
+                            <a:rPr lang="id-ID" b="0" i="1" smtClean="0">
+                              <a:latin typeface="Cambria Math" panose="02040503050406030204" pitchFamily="18" charset="0"/>
+                              <a:ea typeface="Cambria Math" panose="02040503050406030204" pitchFamily="18" charset="0"/>
+                            </a:rPr>
+                          </m:ctrlPr>
+                        </m:sSupPr>
+                        <m:e>
+                          <m:r>
+                            <a:rPr lang="id-ID" i="1" smtClean="0">
+                              <a:latin typeface="Cambria Math" panose="02040503050406030204" pitchFamily="18" charset="0"/>
+                              <a:ea typeface="Cambria Math" panose="02040503050406030204" pitchFamily="18" charset="0"/>
+                            </a:rPr>
+                            <m:t>𝜃</m:t>
+                          </m:r>
+                        </m:e>
+                        <m:sup>
+                          <m:r>
+                            <a:rPr lang="id-ID" b="0" i="1" smtClean="0">
+                              <a:latin typeface="Cambria Math" panose="02040503050406030204" pitchFamily="18" charset="0"/>
+                              <a:ea typeface="Cambria Math" panose="02040503050406030204" pitchFamily="18" charset="0"/>
+                            </a:rPr>
+                            <m:t>2</m:t>
+                          </m:r>
+                        </m:sup>
+                      </m:sSup>
+                      <m:acc>
+                        <m:accPr>
+                          <m:chr m:val="̈"/>
+                          <m:ctrlPr>
+                            <a:rPr lang="id-ID" b="0" i="1" smtClean="0">
+                              <a:latin typeface="Cambria Math" panose="02040503050406030204" pitchFamily="18" charset="0"/>
+                              <a:ea typeface="Cambria Math" panose="02040503050406030204" pitchFamily="18" charset="0"/>
+                            </a:rPr>
+                          </m:ctrlPr>
+                        </m:accPr>
+                        <m:e>
+                          <m:r>
+                            <a:rPr lang="id-ID" b="0" i="1" smtClean="0">
+                              <a:latin typeface="Cambria Math" panose="02040503050406030204" pitchFamily="18" charset="0"/>
+                              <a:ea typeface="Cambria Math" panose="02040503050406030204" pitchFamily="18" charset="0"/>
+                            </a:rPr>
+                            <m:t>𝑥</m:t>
+                          </m:r>
+                        </m:e>
+                      </m:acc>
+                      <m:d>
+                        <m:dPr>
+                          <m:ctrlPr>
+                            <a:rPr lang="id-ID" b="0" i="1" smtClean="0">
+                              <a:latin typeface="Cambria Math" panose="02040503050406030204" pitchFamily="18" charset="0"/>
+                            </a:rPr>
+                          </m:ctrlPr>
+                        </m:dPr>
+                        <m:e>
+                          <m:r>
+                            <a:rPr lang="id-ID" b="0" i="1" smtClean="0">
+                              <a:latin typeface="Cambria Math" panose="02040503050406030204" pitchFamily="18" charset="0"/>
+                            </a:rPr>
+                            <m:t>𝑡</m:t>
+                          </m:r>
+                        </m:e>
+                      </m:d>
+                      <m:r>
+                        <a:rPr lang="id-ID" b="0" i="1" smtClean="0">
+                          <a:latin typeface="Cambria Math" panose="02040503050406030204" pitchFamily="18" charset="0"/>
+                        </a:rPr>
+                        <m:t>+</m:t>
+                      </m:r>
+                      <m:r>
+                        <a:rPr lang="id-ID" b="0" i="1" smtClean="0">
+                          <a:latin typeface="Cambria Math" panose="02040503050406030204" pitchFamily="18" charset="0"/>
+                          <a:ea typeface="Cambria Math" panose="02040503050406030204" pitchFamily="18" charset="0"/>
+                        </a:rPr>
+                        <m:t>⋯</m:t>
+                      </m:r>
+                    </m:oMath>
+                  </m:oMathPara>
+                </a14:m>
+                <a:endParaRPr lang="id-ID" dirty="0"/>
+              </a:p>
+              <a:p>
+                <a:pPr marL="0" indent="0" algn="ctr">
+                  <a:buNone/>
+                </a:pPr>
+                <a:endParaRPr lang="id-ID" dirty="0"/>
+              </a:p>
+              <a:p>
+                <a:pPr marL="0" indent="0" algn="ctr">
+                  <a:buNone/>
+                </a:pPr>
+                <a:r>
+                  <a:rPr lang="id-ID" dirty="0"/>
+                  <a:t>Therefore,</a:t>
+                </a:r>
+              </a:p>
+              <a:p>
+                <a:pPr marL="0" indent="0" algn="ctr">
+                  <a:buNone/>
+                </a:pPr>
+                <a:endParaRPr lang="id-ID" dirty="0"/>
+              </a:p>
+              <a:p>
+                <a:pPr marL="0" indent="0">
+                  <a:buNone/>
+                </a:pPr>
+                <a14:m>
+                  <m:oMathPara xmlns:m="http://schemas.openxmlformats.org/officeDocument/2006/math">
+                    <m:oMathParaPr>
+                      <m:jc m:val="centerGroup"/>
+                    </m:oMathParaPr>
+                    <m:oMath xmlns:m="http://schemas.openxmlformats.org/officeDocument/2006/math">
+                      <m:acc>
+                        <m:accPr>
+                          <m:chr m:val="̈"/>
+                          <m:ctrlPr>
+                            <a:rPr lang="id-ID" sz="2600" i="1" smtClean="0">
+                              <a:latin typeface="Cambria Math" panose="02040503050406030204" pitchFamily="18" charset="0"/>
+                              <a:ea typeface="Cambria Math" panose="02040503050406030204" pitchFamily="18" charset="0"/>
+                            </a:rPr>
+                          </m:ctrlPr>
+                        </m:accPr>
+                        <m:e>
+                          <m:r>
+                            <a:rPr lang="id-ID" sz="2600" b="0" i="1" smtClean="0">
+                              <a:latin typeface="Cambria Math" panose="02040503050406030204" pitchFamily="18" charset="0"/>
+                              <a:ea typeface="Cambria Math" panose="02040503050406030204" pitchFamily="18" charset="0"/>
+                            </a:rPr>
+                            <m:t>𝑇</m:t>
+                          </m:r>
+                        </m:e>
+                      </m:acc>
+                      <m:d>
+                        <m:dPr>
+                          <m:ctrlPr>
+                            <a:rPr lang="id-ID" sz="2600" b="0" i="1" smtClean="0">
+                              <a:latin typeface="Cambria Math" panose="02040503050406030204" pitchFamily="18" charset="0"/>
+                              <a:ea typeface="Cambria Math" panose="02040503050406030204" pitchFamily="18" charset="0"/>
+                            </a:rPr>
+                          </m:ctrlPr>
+                        </m:dPr>
+                        <m:e>
+                          <m:r>
+                            <a:rPr lang="id-ID" sz="2600" b="0" i="1" smtClean="0">
+                              <a:latin typeface="Cambria Math" panose="02040503050406030204" pitchFamily="18" charset="0"/>
+                              <a:ea typeface="Cambria Math" panose="02040503050406030204" pitchFamily="18" charset="0"/>
+                            </a:rPr>
+                            <m:t>𝑡</m:t>
+                          </m:r>
+                        </m:e>
+                      </m:d>
+                      <m:r>
+                        <a:rPr lang="id-ID" sz="2600" b="0" i="1" smtClean="0">
+                          <a:latin typeface="Cambria Math" panose="02040503050406030204" pitchFamily="18" charset="0"/>
+                          <a:ea typeface="Cambria Math" panose="02040503050406030204" pitchFamily="18" charset="0"/>
+                        </a:rPr>
+                        <m:t>=</m:t>
+                      </m:r>
+                      <m:f>
+                        <m:fPr>
+                          <m:ctrlPr>
+                            <a:rPr lang="id-ID" sz="2600" i="1" smtClean="0">
+                              <a:latin typeface="Cambria Math" panose="02040503050406030204" pitchFamily="18" charset="0"/>
+                              <a:ea typeface="Cambria Math" panose="02040503050406030204" pitchFamily="18" charset="0"/>
+                            </a:rPr>
+                          </m:ctrlPr>
+                        </m:fPr>
+                        <m:num>
+                          <m:r>
+                            <a:rPr lang="id-ID" sz="2600" b="0" i="1" smtClean="0">
+                              <a:latin typeface="Cambria Math" panose="02040503050406030204" pitchFamily="18" charset="0"/>
+                              <a:ea typeface="Cambria Math" panose="02040503050406030204" pitchFamily="18" charset="0"/>
+                            </a:rPr>
+                            <m:t>𝐾</m:t>
+                          </m:r>
+                        </m:num>
+                        <m:den>
+                          <m:r>
+                            <a:rPr lang="id-ID" sz="2600" b="0" i="1" smtClean="0">
+                              <a:latin typeface="Cambria Math" panose="02040503050406030204" pitchFamily="18" charset="0"/>
+                              <a:ea typeface="Cambria Math" panose="02040503050406030204" pitchFamily="18" charset="0"/>
+                            </a:rPr>
+                            <m:t>𝑀</m:t>
+                          </m:r>
+                        </m:den>
+                      </m:f>
+                      <m:r>
+                        <a:rPr lang="id-ID" sz="2600" b="0" i="1" smtClean="0">
+                          <a:latin typeface="Cambria Math" panose="02040503050406030204" pitchFamily="18" charset="0"/>
+                          <a:ea typeface="Cambria Math" panose="02040503050406030204" pitchFamily="18" charset="0"/>
+                        </a:rPr>
+                        <m:t>𝑇</m:t>
+                      </m:r>
+                      <m:d>
+                        <m:dPr>
+                          <m:ctrlPr>
+                            <a:rPr lang="id-ID" sz="2600" b="0" i="1" smtClean="0">
+                              <a:latin typeface="Cambria Math" panose="02040503050406030204" pitchFamily="18" charset="0"/>
+                              <a:ea typeface="Cambria Math" panose="02040503050406030204" pitchFamily="18" charset="0"/>
+                            </a:rPr>
+                          </m:ctrlPr>
+                        </m:dPr>
+                        <m:e>
+                          <m:r>
+                            <a:rPr lang="id-ID" sz="2600" b="0" i="1" smtClean="0">
+                              <a:latin typeface="Cambria Math" panose="02040503050406030204" pitchFamily="18" charset="0"/>
+                              <a:ea typeface="Cambria Math" panose="02040503050406030204" pitchFamily="18" charset="0"/>
+                            </a:rPr>
+                            <m:t>𝑡</m:t>
+                          </m:r>
+                        </m:e>
+                      </m:d>
+                      <m:r>
+                        <a:rPr lang="id-ID" sz="2600" b="0" i="1" smtClean="0">
+                          <a:latin typeface="Cambria Math" panose="02040503050406030204" pitchFamily="18" charset="0"/>
+                          <a:ea typeface="Cambria Math" panose="02040503050406030204" pitchFamily="18" charset="0"/>
+                        </a:rPr>
+                        <m:t>+</m:t>
+                      </m:r>
+                      <m:f>
+                        <m:fPr>
+                          <m:ctrlPr>
+                            <a:rPr lang="id-ID" sz="2600" b="0" i="1" smtClean="0">
+                              <a:latin typeface="Cambria Math" panose="02040503050406030204" pitchFamily="18" charset="0"/>
+                              <a:ea typeface="Cambria Math" panose="02040503050406030204" pitchFamily="18" charset="0"/>
+                            </a:rPr>
+                          </m:ctrlPr>
+                        </m:fPr>
+                        <m:num>
+                          <m:r>
+                            <a:rPr lang="id-ID" sz="2600" b="0" i="1" smtClean="0">
+                              <a:latin typeface="Cambria Math" panose="02040503050406030204" pitchFamily="18" charset="0"/>
+                              <a:ea typeface="Cambria Math" panose="02040503050406030204" pitchFamily="18" charset="0"/>
+                            </a:rPr>
+                            <m:t>𝐵</m:t>
+                          </m:r>
+                        </m:num>
+                        <m:den>
+                          <m:r>
+                            <a:rPr lang="id-ID" sz="2600" b="0" i="1" smtClean="0">
+                              <a:latin typeface="Cambria Math" panose="02040503050406030204" pitchFamily="18" charset="0"/>
+                              <a:ea typeface="Cambria Math" panose="02040503050406030204" pitchFamily="18" charset="0"/>
+                            </a:rPr>
+                            <m:t>𝑀</m:t>
+                          </m:r>
+                        </m:den>
+                      </m:f>
+                      <m:acc>
+                        <m:accPr>
+                          <m:chr m:val="̇"/>
+                          <m:ctrlPr>
+                            <a:rPr lang="id-ID" sz="2600" b="0" i="1" smtClean="0">
+                              <a:latin typeface="Cambria Math" panose="02040503050406030204" pitchFamily="18" charset="0"/>
+                              <a:ea typeface="Cambria Math" panose="02040503050406030204" pitchFamily="18" charset="0"/>
+                            </a:rPr>
+                          </m:ctrlPr>
+                        </m:accPr>
+                        <m:e>
+                          <m:r>
+                            <a:rPr lang="id-ID" sz="2600" b="0" i="1" smtClean="0">
+                              <a:latin typeface="Cambria Math" panose="02040503050406030204" pitchFamily="18" charset="0"/>
+                              <a:ea typeface="Cambria Math" panose="02040503050406030204" pitchFamily="18" charset="0"/>
+                            </a:rPr>
+                            <m:t>𝑇</m:t>
+                          </m:r>
+                        </m:e>
+                      </m:acc>
+                      <m:r>
+                        <a:rPr lang="id-ID" sz="2600" i="1">
+                          <a:latin typeface="Cambria Math" panose="02040503050406030204" pitchFamily="18" charset="0"/>
+                          <a:ea typeface="Cambria Math" panose="02040503050406030204" pitchFamily="18" charset="0"/>
+                        </a:rPr>
+                        <m:t>(</m:t>
+                      </m:r>
+                      <m:r>
+                        <a:rPr lang="id-ID" sz="2600" i="1">
+                          <a:latin typeface="Cambria Math" panose="02040503050406030204" pitchFamily="18" charset="0"/>
+                          <a:ea typeface="Cambria Math" panose="02040503050406030204" pitchFamily="18" charset="0"/>
+                        </a:rPr>
+                        <m:t>𝑡</m:t>
+                      </m:r>
+                      <m:r>
+                        <a:rPr lang="id-ID" sz="2600" i="1">
+                          <a:latin typeface="Cambria Math" panose="02040503050406030204" pitchFamily="18" charset="0"/>
+                          <a:ea typeface="Cambria Math" panose="02040503050406030204" pitchFamily="18" charset="0"/>
+                        </a:rPr>
+                        <m:t>)+</m:t>
+                      </m:r>
+                      <m:f>
+                        <m:fPr>
+                          <m:ctrlPr>
+                            <a:rPr lang="id-ID" sz="2600" b="0" i="1" smtClean="0">
+                              <a:latin typeface="Cambria Math" panose="02040503050406030204" pitchFamily="18" charset="0"/>
+                              <a:ea typeface="Cambria Math" panose="02040503050406030204" pitchFamily="18" charset="0"/>
+                            </a:rPr>
+                          </m:ctrlPr>
+                        </m:fPr>
+                        <m:num>
+                          <m:r>
+                            <a:rPr lang="id-ID" sz="2600" b="0" i="1" smtClean="0">
+                              <a:latin typeface="Cambria Math" panose="02040503050406030204" pitchFamily="18" charset="0"/>
+                              <a:ea typeface="Cambria Math" panose="02040503050406030204" pitchFamily="18" charset="0"/>
+                            </a:rPr>
+                            <m:t>1</m:t>
+                          </m:r>
+                        </m:num>
+                        <m:den>
+                          <m:r>
+                            <a:rPr lang="id-ID" sz="2600" b="0" i="1" smtClean="0">
+                              <a:latin typeface="Cambria Math" panose="02040503050406030204" pitchFamily="18" charset="0"/>
+                              <a:ea typeface="Cambria Math" panose="02040503050406030204" pitchFamily="18" charset="0"/>
+                            </a:rPr>
+                            <m:t>𝑀</m:t>
+                          </m:r>
+                        </m:den>
+                      </m:f>
+                      <m:r>
+                        <a:rPr lang="id-ID" sz="2600" b="0" i="1" smtClean="0">
+                          <a:latin typeface="Cambria Math" panose="02040503050406030204" pitchFamily="18" charset="0"/>
+                          <a:ea typeface="Cambria Math" panose="02040503050406030204" pitchFamily="18" charset="0"/>
+                        </a:rPr>
+                        <m:t>(</m:t>
+                      </m:r>
+                      <m:r>
+                        <a:rPr lang="id-ID" sz="2600" i="1">
+                          <a:latin typeface="Cambria Math" panose="02040503050406030204" pitchFamily="18" charset="0"/>
+                          <a:ea typeface="Cambria Math" panose="02040503050406030204" pitchFamily="18" charset="0"/>
+                        </a:rPr>
+                        <m:t>𝑢</m:t>
+                      </m:r>
+                      <m:d>
+                        <m:dPr>
+                          <m:ctrlPr>
+                            <a:rPr lang="id-ID" sz="2600" i="1">
+                              <a:latin typeface="Cambria Math" panose="02040503050406030204" pitchFamily="18" charset="0"/>
+                              <a:ea typeface="Cambria Math" panose="02040503050406030204" pitchFamily="18" charset="0"/>
+                            </a:rPr>
+                          </m:ctrlPr>
+                        </m:dPr>
+                        <m:e>
+                          <m:r>
+                            <a:rPr lang="id-ID" sz="2600" i="1">
+                              <a:latin typeface="Cambria Math" panose="02040503050406030204" pitchFamily="18" charset="0"/>
+                              <a:ea typeface="Cambria Math" panose="02040503050406030204" pitchFamily="18" charset="0"/>
+                            </a:rPr>
+                            <m:t>𝑡</m:t>
+                          </m:r>
+                        </m:e>
+                      </m:d>
+                      <m:r>
+                        <a:rPr lang="id-ID" sz="2600" i="1">
+                          <a:latin typeface="Cambria Math" panose="02040503050406030204" pitchFamily="18" charset="0"/>
+                          <a:ea typeface="Cambria Math" panose="02040503050406030204" pitchFamily="18" charset="0"/>
+                        </a:rPr>
+                        <m:t>−</m:t>
+                      </m:r>
+                      <m:r>
+                        <a:rPr lang="id-ID" sz="2600" i="1">
+                          <a:latin typeface="Cambria Math" panose="02040503050406030204" pitchFamily="18" charset="0"/>
+                          <a:ea typeface="Cambria Math" panose="02040503050406030204" pitchFamily="18" charset="0"/>
+                        </a:rPr>
+                        <m:t>𝜃</m:t>
+                      </m:r>
+                      <m:acc>
+                        <m:accPr>
+                          <m:chr m:val="̇"/>
+                          <m:ctrlPr>
+                            <a:rPr lang="id-ID" sz="2600" i="1">
+                              <a:latin typeface="Cambria Math" panose="02040503050406030204" pitchFamily="18" charset="0"/>
+                              <a:ea typeface="Cambria Math" panose="02040503050406030204" pitchFamily="18" charset="0"/>
+                            </a:rPr>
+                          </m:ctrlPr>
+                        </m:accPr>
+                        <m:e>
+                          <m:r>
+                            <a:rPr lang="id-ID" sz="2600" i="1">
+                              <a:latin typeface="Cambria Math" panose="02040503050406030204" pitchFamily="18" charset="0"/>
+                              <a:ea typeface="Cambria Math" panose="02040503050406030204" pitchFamily="18" charset="0"/>
+                            </a:rPr>
+                            <m:t>𝑢</m:t>
+                          </m:r>
+                        </m:e>
+                      </m:acc>
+                      <m:d>
+                        <m:dPr>
+                          <m:ctrlPr>
+                            <a:rPr lang="id-ID" sz="2600" i="1">
+                              <a:latin typeface="Cambria Math" panose="02040503050406030204" pitchFamily="18" charset="0"/>
+                            </a:rPr>
+                          </m:ctrlPr>
+                        </m:dPr>
+                        <m:e>
+                          <m:r>
+                            <a:rPr lang="id-ID" sz="2600" i="1">
+                              <a:latin typeface="Cambria Math" panose="02040503050406030204" pitchFamily="18" charset="0"/>
+                            </a:rPr>
+                            <m:t>𝑡</m:t>
+                          </m:r>
+                        </m:e>
+                      </m:d>
+                      <m:r>
+                        <a:rPr lang="id-ID" sz="2600" i="1">
+                          <a:latin typeface="Cambria Math" panose="02040503050406030204" pitchFamily="18" charset="0"/>
+                        </a:rPr>
+                        <m:t>+</m:t>
+                      </m:r>
+                      <m:f>
+                        <m:fPr>
+                          <m:ctrlPr>
+                            <a:rPr lang="id-ID" sz="2600" i="1">
+                              <a:latin typeface="Cambria Math" panose="02040503050406030204" pitchFamily="18" charset="0"/>
+                            </a:rPr>
+                          </m:ctrlPr>
+                        </m:fPr>
+                        <m:num>
+                          <m:r>
+                            <a:rPr lang="id-ID" sz="2600" i="1">
+                              <a:latin typeface="Cambria Math" panose="02040503050406030204" pitchFamily="18" charset="0"/>
+                            </a:rPr>
+                            <m:t>1</m:t>
+                          </m:r>
+                        </m:num>
+                        <m:den>
+                          <m:r>
+                            <a:rPr lang="id-ID" sz="2600" i="1">
+                              <a:latin typeface="Cambria Math" panose="02040503050406030204" pitchFamily="18" charset="0"/>
+                            </a:rPr>
+                            <m:t>2</m:t>
+                          </m:r>
+                        </m:den>
+                      </m:f>
+                      <m:sSup>
+                        <m:sSupPr>
+                          <m:ctrlPr>
+                            <a:rPr lang="id-ID" sz="2600" i="1">
+                              <a:latin typeface="Cambria Math" panose="02040503050406030204" pitchFamily="18" charset="0"/>
+                              <a:ea typeface="Cambria Math" panose="02040503050406030204" pitchFamily="18" charset="0"/>
+                            </a:rPr>
+                          </m:ctrlPr>
+                        </m:sSupPr>
+                        <m:e>
+                          <m:r>
+                            <a:rPr lang="id-ID" sz="2600" i="1">
+                              <a:latin typeface="Cambria Math" panose="02040503050406030204" pitchFamily="18" charset="0"/>
+                              <a:ea typeface="Cambria Math" panose="02040503050406030204" pitchFamily="18" charset="0"/>
+                            </a:rPr>
+                            <m:t>𝜃</m:t>
+                          </m:r>
+                        </m:e>
+                        <m:sup>
+                          <m:r>
+                            <a:rPr lang="id-ID" sz="2600" i="1">
+                              <a:latin typeface="Cambria Math" panose="02040503050406030204" pitchFamily="18" charset="0"/>
+                              <a:ea typeface="Cambria Math" panose="02040503050406030204" pitchFamily="18" charset="0"/>
+                            </a:rPr>
+                            <m:t>2</m:t>
+                          </m:r>
+                        </m:sup>
+                      </m:sSup>
+                      <m:acc>
+                        <m:accPr>
+                          <m:chr m:val="̈"/>
+                          <m:ctrlPr>
+                            <a:rPr lang="id-ID" sz="2600" i="1">
+                              <a:latin typeface="Cambria Math" panose="02040503050406030204" pitchFamily="18" charset="0"/>
+                              <a:ea typeface="Cambria Math" panose="02040503050406030204" pitchFamily="18" charset="0"/>
+                            </a:rPr>
+                          </m:ctrlPr>
+                        </m:accPr>
+                        <m:e>
+                          <m:r>
+                            <a:rPr lang="id-ID" sz="2600" i="1">
+                              <a:latin typeface="Cambria Math" panose="02040503050406030204" pitchFamily="18" charset="0"/>
+                              <a:ea typeface="Cambria Math" panose="02040503050406030204" pitchFamily="18" charset="0"/>
+                            </a:rPr>
+                            <m:t>𝑥</m:t>
+                          </m:r>
+                        </m:e>
+                      </m:acc>
+                      <m:d>
+                        <m:dPr>
+                          <m:ctrlPr>
+                            <a:rPr lang="id-ID" sz="2600" i="1">
+                              <a:latin typeface="Cambria Math" panose="02040503050406030204" pitchFamily="18" charset="0"/>
+                            </a:rPr>
+                          </m:ctrlPr>
+                        </m:dPr>
+                        <m:e>
+                          <m:r>
+                            <a:rPr lang="id-ID" sz="2600" i="1">
+                              <a:latin typeface="Cambria Math" panose="02040503050406030204" pitchFamily="18" charset="0"/>
+                            </a:rPr>
+                            <m:t>𝑡</m:t>
+                          </m:r>
+                        </m:e>
+                      </m:d>
+                      <m:r>
+                        <a:rPr lang="id-ID" sz="2600" i="1">
+                          <a:latin typeface="Cambria Math" panose="02040503050406030204" pitchFamily="18" charset="0"/>
+                        </a:rPr>
+                        <m:t>+</m:t>
+                      </m:r>
+                      <m:r>
+                        <a:rPr lang="id-ID" sz="2600" i="1">
+                          <a:latin typeface="Cambria Math" panose="02040503050406030204" pitchFamily="18" charset="0"/>
+                          <a:ea typeface="Cambria Math" panose="02040503050406030204" pitchFamily="18" charset="0"/>
+                        </a:rPr>
+                        <m:t>⋯</m:t>
+                      </m:r>
+                      <m:r>
+                        <a:rPr lang="id-ID" sz="2600" b="0" i="1" smtClean="0">
+                          <a:latin typeface="Cambria Math" panose="02040503050406030204" pitchFamily="18" charset="0"/>
+                          <a:ea typeface="Cambria Math" panose="02040503050406030204" pitchFamily="18" charset="0"/>
+                        </a:rPr>
+                        <m:t>)</m:t>
+                      </m:r>
+                    </m:oMath>
+                  </m:oMathPara>
+                </a14:m>
+                <a:endParaRPr lang="id-ID" sz="2600" dirty="0"/>
+              </a:p>
+              <a:p>
+                <a:pPr marL="0" indent="0">
+                  <a:buNone/>
+                </a:pPr>
+                <a:endParaRPr lang="id-ID" dirty="0"/>
+              </a:p>
+              <a:p>
+                <a:pPr marL="0" indent="0">
+                  <a:buNone/>
+                </a:pPr>
+                <a:r>
+                  <a:rPr lang="id-ID" dirty="0"/>
+                  <a:t>Can you implement it in your Simulink (up to the first order approximation only)?</a:t>
+                </a:r>
+              </a:p>
+            </p:txBody>
+          </p:sp>
+        </mc:Choice>
+        <mc:Fallback>
+          <p:sp>
+            <p:nvSpPr>
+              <p:cNvPr id="3" name="Content Placeholder 2">
+                <a:extLst>
+                  <a:ext uri="{FF2B5EF4-FFF2-40B4-BE49-F238E27FC236}">
+                    <a16:creationId xmlns:a16="http://schemas.microsoft.com/office/drawing/2014/main" id="{57DA6629-7431-4249-BA7B-A2959CB5688C}"/>
+                  </a:ext>
+                </a:extLst>
+              </p:cNvPr>
+              <p:cNvSpPr>
+                <a:spLocks noGrp="1" noRot="1" noChangeAspect="1" noMove="1" noResize="1" noEditPoints="1" noAdjustHandles="1" noChangeArrowheads="1" noChangeShapeType="1" noTextEdit="1"/>
+              </p:cNvSpPr>
+              <p:nvPr>
+                <p:ph idx="1"/>
+              </p:nvPr>
+            </p:nvSpPr>
+            <p:spPr>
+              <a:xfrm>
+                <a:off x="477728" y="1340768"/>
+                <a:ext cx="8229600" cy="4525963"/>
+              </a:xfrm>
+              <a:blipFill>
+                <a:blip r:embed="rId2"/>
+                <a:stretch>
+                  <a:fillRect l="-889" r="-1407"/>
+                </a:stretch>
+              </a:blipFill>
+            </p:spPr>
+            <p:txBody>
+              <a:bodyPr/>
+              <a:lstStyle/>
+              <a:p>
+                <a:r>
+                  <a:rPr lang="id-ID">
+                    <a:noFill/>
+                  </a:rPr>
+                  <a:t> </a:t>
+                </a:r>
+              </a:p>
+            </p:txBody>
+          </p:sp>
+        </mc:Fallback>
+      </mc:AlternateContent>
       <p:sp>
         <p:nvSpPr>
           <p:cNvPr id="4" name="Slide Number Placeholder 3">
             <a:extLst>
               <a:ext uri="{FF2B5EF4-FFF2-40B4-BE49-F238E27FC236}">
-                <a16:creationId xmlns:a16="http://schemas.microsoft.com/office/drawing/2014/main" id="{E84DE9A1-6018-4C79-9960-EADA7A9BFBC2}"/>
+                <a16:creationId xmlns:a16="http://schemas.microsoft.com/office/drawing/2014/main" id="{7B1512F0-2E1D-453D-BD53-8D2C49093A43}"/>
               </a:ext>
             </a:extLst>
           </p:cNvPr>
@@ -8391,7 +9628,7 @@
     </p:spTree>
     <p:extLst>
       <p:ext uri="{BB962C8B-B14F-4D97-AF65-F5344CB8AC3E}">
-        <p14:creationId xmlns:p14="http://schemas.microsoft.com/office/powerpoint/2010/main" val="2430441608"/>
+        <p14:creationId xmlns:p14="http://schemas.microsoft.com/office/powerpoint/2010/main" val="3292060743"/>
       </p:ext>
     </p:extLst>
   </p:cSld>
@@ -8412,44 +9649,44 @@
         <a:sysClr val="window" lastClr="FFFFFF"/>
       </a:lt1>
       <a:dk2>
-        <a:srgbClr val="1F497D"/>
+        <a:srgbClr val="44546A"/>
       </a:dk2>
       <a:lt2>
-        <a:srgbClr val="EEECE1"/>
+        <a:srgbClr val="E7E6E6"/>
       </a:lt2>
       <a:accent1>
-        <a:srgbClr val="4F81BD"/>
+        <a:srgbClr val="4472C4"/>
       </a:accent1>
       <a:accent2>
-        <a:srgbClr val="C0504D"/>
+        <a:srgbClr val="ED7D31"/>
       </a:accent2>
       <a:accent3>
-        <a:srgbClr val="9BBB59"/>
+        <a:srgbClr val="A5A5A5"/>
       </a:accent3>
       <a:accent4>
-        <a:srgbClr val="8064A2"/>
+        <a:srgbClr val="FFC000"/>
       </a:accent4>
       <a:accent5>
-        <a:srgbClr val="4BACC6"/>
+        <a:srgbClr val="5B9BD5"/>
       </a:accent5>
       <a:accent6>
-        <a:srgbClr val="F79646"/>
+        <a:srgbClr val="70AD47"/>
       </a:accent6>
       <a:hlink>
-        <a:srgbClr val="0000FF"/>
+        <a:srgbClr val="0563C1"/>
       </a:hlink>
       <a:folHlink>
-        <a:srgbClr val="800080"/>
+        <a:srgbClr val="954F72"/>
       </a:folHlink>
     </a:clrScheme>
     <a:fontScheme name="Office">
       <a:majorFont>
-        <a:latin typeface="Calibri"/>
+        <a:latin typeface="Calibri Light" panose="020F0302020204030204"/>
         <a:ea typeface=""/>
         <a:cs typeface=""/>
-        <a:font script="Jpan" typeface="ＭＳ Ｐゴシック"/>
+        <a:font script="Jpan" typeface="游ゴシック Light"/>
         <a:font script="Hang" typeface="맑은 고딕"/>
-        <a:font script="Hans" typeface="宋体"/>
+        <a:font script="Hans" typeface="等线 Light"/>
         <a:font script="Hant" typeface="新細明體"/>
         <a:font script="Arab" typeface="Times New Roman"/>
         <a:font script="Hebr" typeface="Times New Roman"/>
@@ -8477,14 +9714,31 @@
         <a:font script="Viet" typeface="Times New Roman"/>
         <a:font script="Uigh" typeface="Microsoft Uighur"/>
         <a:font script="Geor" typeface="Sylfaen"/>
+        <a:font script="Armn" typeface="Arial"/>
+        <a:font script="Bugi" typeface="Leelawadee UI"/>
+        <a:font script="Bopo" typeface="Microsoft JhengHei"/>
+        <a:font script="Java" typeface="Javanese Text"/>
+        <a:font script="Lisu" typeface="Segoe UI"/>
+        <a:font script="Mymr" typeface="Myanmar Text"/>
+        <a:font script="Nkoo" typeface="Ebrima"/>
+        <a:font script="Olck" typeface="Nirmala UI"/>
+        <a:font script="Osma" typeface="Ebrima"/>
+        <a:font script="Phag" typeface="Phagspa"/>
+        <a:font script="Syrn" typeface="Estrangelo Edessa"/>
+        <a:font script="Syrj" typeface="Estrangelo Edessa"/>
+        <a:font script="Syre" typeface="Estrangelo Edessa"/>
+        <a:font script="Sora" typeface="Nirmala UI"/>
+        <a:font script="Tale" typeface="Microsoft Tai Le"/>
+        <a:font script="Talu" typeface="Microsoft New Tai Lue"/>
+        <a:font script="Tfng" typeface="Ebrima"/>
       </a:majorFont>
       <a:minorFont>
-        <a:latin typeface="Calibri"/>
+        <a:latin typeface="Calibri" panose="020F0502020204030204"/>
         <a:ea typeface=""/>
         <a:cs typeface=""/>
-        <a:font script="Jpan" typeface="ＭＳ Ｐゴシック"/>
+        <a:font script="Jpan" typeface="游ゴシック"/>
         <a:font script="Hang" typeface="맑은 고딕"/>
-        <a:font script="Hans" typeface="宋体"/>
+        <a:font script="Hans" typeface="等线"/>
         <a:font script="Hant" typeface="新細明體"/>
         <a:font script="Arab" typeface="Arial"/>
         <a:font script="Hebr" typeface="Arial"/>
@@ -8512,6 +9766,23 @@
         <a:font script="Viet" typeface="Arial"/>
         <a:font script="Uigh" typeface="Microsoft Uighur"/>
         <a:font script="Geor" typeface="Sylfaen"/>
+        <a:font script="Armn" typeface="Arial"/>
+        <a:font script="Bugi" typeface="Leelawadee UI"/>
+        <a:font script="Bopo" typeface="Microsoft JhengHei"/>
+        <a:font script="Java" typeface="Javanese Text"/>
+        <a:font script="Lisu" typeface="Segoe UI"/>
+        <a:font script="Mymr" typeface="Myanmar Text"/>
+        <a:font script="Nkoo" typeface="Ebrima"/>
+        <a:font script="Olck" typeface="Nirmala UI"/>
+        <a:font script="Osma" typeface="Ebrima"/>
+        <a:font script="Phag" typeface="Phagspa"/>
+        <a:font script="Syrn" typeface="Estrangelo Edessa"/>
+        <a:font script="Syrj" typeface="Estrangelo Edessa"/>
+        <a:font script="Syre" typeface="Estrangelo Edessa"/>
+        <a:font script="Sora" typeface="Nirmala UI"/>
+        <a:font script="Tale" typeface="Microsoft Tai Le"/>
+        <a:font script="Talu" typeface="Microsoft New Tai Lue"/>
+        <a:font script="Tfng" typeface="Ebrima"/>
       </a:minorFont>
     </a:fontScheme>
     <a:fmtScheme name="Office">
@@ -8523,166 +9794,142 @@
           <a:gsLst>
             <a:gs pos="0">
               <a:schemeClr val="phClr">
-                <a:tint val="50000"/>
-                <a:satMod val="300000"/>
+                <a:lumMod val="110000"/>
+                <a:satMod val="105000"/>
+                <a:tint val="67000"/>
               </a:schemeClr>
             </a:gs>
-            <a:gs pos="35000">
+            <a:gs pos="50000">
               <a:schemeClr val="phClr">
-                <a:tint val="37000"/>
-                <a:satMod val="300000"/>
+                <a:lumMod val="105000"/>
+                <a:satMod val="103000"/>
+                <a:tint val="73000"/>
               </a:schemeClr>
             </a:gs>
             <a:gs pos="100000">
               <a:schemeClr val="phClr">
-                <a:tint val="15000"/>
-                <a:satMod val="350000"/>
+                <a:lumMod val="105000"/>
+                <a:satMod val="109000"/>
+                <a:tint val="81000"/>
               </a:schemeClr>
             </a:gs>
           </a:gsLst>
-          <a:lin ang="16200000" scaled="1"/>
+          <a:lin ang="5400000" scaled="0"/>
         </a:gradFill>
         <a:gradFill rotWithShape="1">
           <a:gsLst>
             <a:gs pos="0">
               <a:schemeClr val="phClr">
-                <a:shade val="51000"/>
-                <a:satMod val="130000"/>
+                <a:satMod val="103000"/>
+                <a:lumMod val="102000"/>
+                <a:tint val="94000"/>
               </a:schemeClr>
             </a:gs>
-            <a:gs pos="80000">
+            <a:gs pos="50000">
               <a:schemeClr val="phClr">
-                <a:shade val="93000"/>
-                <a:satMod val="130000"/>
+                <a:satMod val="110000"/>
+                <a:lumMod val="100000"/>
+                <a:shade val="100000"/>
               </a:schemeClr>
             </a:gs>
             <a:gs pos="100000">
               <a:schemeClr val="phClr">
-                <a:shade val="94000"/>
-                <a:satMod val="135000"/>
+                <a:lumMod val="99000"/>
+                <a:satMod val="120000"/>
+                <a:shade val="78000"/>
               </a:schemeClr>
             </a:gs>
           </a:gsLst>
-          <a:lin ang="16200000" scaled="0"/>
+          <a:lin ang="5400000" scaled="0"/>
         </a:gradFill>
       </a:fillStyleLst>
       <a:lnStyleLst>
-        <a:ln w="9525" cap="flat" cmpd="sng" algn="ctr">
-          <a:solidFill>
-            <a:schemeClr val="phClr">
-              <a:shade val="95000"/>
-              <a:satMod val="105000"/>
-            </a:schemeClr>
-          </a:solidFill>
-          <a:prstDash val="solid"/>
-        </a:ln>
-        <a:ln w="25400" cap="flat" cmpd="sng" algn="ctr">
+        <a:ln w="6350" cap="flat" cmpd="sng" algn="ctr">
           <a:solidFill>
             <a:schemeClr val="phClr"/>
           </a:solidFill>
           <a:prstDash val="solid"/>
+          <a:miter lim="800000"/>
         </a:ln>
-        <a:ln w="38100" cap="flat" cmpd="sng" algn="ctr">
+        <a:ln w="12700" cap="flat" cmpd="sng" algn="ctr">
           <a:solidFill>
             <a:schemeClr val="phClr"/>
           </a:solidFill>
           <a:prstDash val="solid"/>
+          <a:miter lim="800000"/>
+        </a:ln>
+        <a:ln w="19050" cap="flat" cmpd="sng" algn="ctr">
+          <a:solidFill>
+            <a:schemeClr val="phClr"/>
+          </a:solidFill>
+          <a:prstDash val="solid"/>
+          <a:miter lim="800000"/>
         </a:ln>
       </a:lnStyleLst>
       <a:effectStyleLst>
         <a:effectStyle>
+          <a:effectLst/>
+        </a:effectStyle>
+        <a:effectStyle>
+          <a:effectLst/>
+        </a:effectStyle>
+        <a:effectStyle>
           <a:effectLst>
-            <a:outerShdw blurRad="40000" dist="20000" dir="5400000" rotWithShape="0">
+            <a:outerShdw blurRad="57150" dist="19050" dir="5400000" algn="ctr" rotWithShape="0">
               <a:srgbClr val="000000">
-                <a:alpha val="38000"/>
+                <a:alpha val="63000"/>
               </a:srgbClr>
             </a:outerShdw>
           </a:effectLst>
-        </a:effectStyle>
-        <a:effectStyle>
-          <a:effectLst>
-            <a:outerShdw blurRad="40000" dist="23000" dir="5400000" rotWithShape="0">
-              <a:srgbClr val="000000">
-                <a:alpha val="35000"/>
-              </a:srgbClr>
-            </a:outerShdw>
-          </a:effectLst>
-        </a:effectStyle>
-        <a:effectStyle>
-          <a:effectLst>
-            <a:outerShdw blurRad="40000" dist="23000" dir="5400000" rotWithShape="0">
-              <a:srgbClr val="000000">
-                <a:alpha val="35000"/>
-              </a:srgbClr>
-            </a:outerShdw>
-          </a:effectLst>
-          <a:scene3d>
-            <a:camera prst="orthographicFront">
-              <a:rot lat="0" lon="0" rev="0"/>
-            </a:camera>
-            <a:lightRig rig="threePt" dir="t">
-              <a:rot lat="0" lon="0" rev="1200000"/>
-            </a:lightRig>
-          </a:scene3d>
-          <a:sp3d>
-            <a:bevelT w="63500" h="25400"/>
-          </a:sp3d>
         </a:effectStyle>
       </a:effectStyleLst>
       <a:bgFillStyleLst>
         <a:solidFill>
           <a:schemeClr val="phClr"/>
         </a:solidFill>
+        <a:solidFill>
+          <a:schemeClr val="phClr">
+            <a:tint val="95000"/>
+            <a:satMod val="170000"/>
+          </a:schemeClr>
+        </a:solidFill>
         <a:gradFill rotWithShape="1">
           <a:gsLst>
             <a:gs pos="0">
               <a:schemeClr val="phClr">
-                <a:tint val="40000"/>
-                <a:satMod val="350000"/>
+                <a:tint val="93000"/>
+                <a:satMod val="150000"/>
+                <a:shade val="98000"/>
+                <a:lumMod val="102000"/>
               </a:schemeClr>
             </a:gs>
-            <a:gs pos="40000">
+            <a:gs pos="50000">
               <a:schemeClr val="phClr">
-                <a:tint val="45000"/>
-                <a:shade val="99000"/>
-                <a:satMod val="350000"/>
+                <a:tint val="98000"/>
+                <a:satMod val="130000"/>
+                <a:shade val="90000"/>
+                <a:lumMod val="103000"/>
               </a:schemeClr>
             </a:gs>
             <a:gs pos="100000">
               <a:schemeClr val="phClr">
-                <a:shade val="20000"/>
-                <a:satMod val="255000"/>
+                <a:shade val="63000"/>
+                <a:satMod val="120000"/>
               </a:schemeClr>
             </a:gs>
           </a:gsLst>
-          <a:path path="circle">
-            <a:fillToRect l="50000" t="-80000" r="50000" b="180000"/>
-          </a:path>
-        </a:gradFill>
-        <a:gradFill rotWithShape="1">
-          <a:gsLst>
-            <a:gs pos="0">
-              <a:schemeClr val="phClr">
-                <a:tint val="80000"/>
-                <a:satMod val="300000"/>
-              </a:schemeClr>
-            </a:gs>
-            <a:gs pos="100000">
-              <a:schemeClr val="phClr">
-                <a:shade val="30000"/>
-                <a:satMod val="200000"/>
-              </a:schemeClr>
-            </a:gs>
-          </a:gsLst>
-          <a:path path="circle">
-            <a:fillToRect l="50000" t="50000" r="50000" b="50000"/>
-          </a:path>
+          <a:lin ang="5400000" scaled="0"/>
         </a:gradFill>
       </a:bgFillStyleLst>
     </a:fmtScheme>
   </a:themeElements>
   <a:objectDefaults/>
   <a:extraClrSchemeLst/>
+  <a:extLst>
+    <a:ext uri="{05A4C25C-085E-4340-85A3-A5531E510DB2}">
+      <thm15:themeFamily xmlns:thm15="http://schemas.microsoft.com/office/thememl/2012/main" name="Office Theme" id="{62F939B6-93AF-4DB8-9C6B-D6C7DFDC589F}" vid="{4A3C46E8-61CC-4603-A589-7422A47A8E4A}"/>
+    </a:ext>
+  </a:extLst>
 </a:theme>
 </file>
 

</xml_diff>